<commit_message>
Visual model: plain UNCLASSIFIED markings, black banner strips removed
Co-Authored-By: Claude Fable 5 <noreply@anthropic.com>
Claude-Session: https://claude.ai/code/session_01YLo1WfwUDkbwfJEF3ZNVbB
</commit_message>
<xml_diff>
--- a/output/withdrawal-sop-visual.pptx
+++ b/output/withdrawal-sop-visual.pptx
@@ -877,23 +877,42 @@
       </p:grpSpPr>
       <p:sp>
         <p:nvSpPr>
-          <p:cNvPr id="2" name="Shape 0"/>
-          <p:cNvSpPr/>
-          <p:nvPr/>
-        </p:nvSpPr>
-        <p:spPr>
-          <a:xfrm>
-            <a:off x="0" y="0"/>
+          <p:cNvPr id="2" name="Text 0"/>
+          <p:cNvSpPr/>
+          <p:nvPr/>
+        </p:nvSpPr>
+        <p:spPr>
+          <a:xfrm>
+            <a:off x="0" y="18288"/>
             <a:ext cx="7562088" cy="164592"/>
           </a:xfrm>
           <a:prstGeom prst="rect">
             <a:avLst/>
           </a:prstGeom>
-          <a:solidFill>
-            <a:srgbClr val="000000"/>
-          </a:solidFill>
-          <a:ln/>
-        </p:spPr>
+          <a:noFill/>
+          <a:ln/>
+        </p:spPr>
+        <p:txBody>
+          <a:bodyPr wrap="square" lIns="0" tIns="0" rIns="0" bIns="0" rtlCol="0" anchor="ctr"/>
+          <a:lstStyle/>
+          <a:p>
+            <a:pPr algn="ctr" indent="0" marL="0">
+              <a:buNone/>
+            </a:pPr>
+            <a:r>
+              <a:rPr lang="en-US" sz="750" b="1" spc="400" kern="0" dirty="0">
+                <a:solidFill>
+                  <a:srgbClr val="000000"/>
+                </a:solidFill>
+                <a:latin typeface="Arial" pitchFamily="34" charset="0"/>
+                <a:ea typeface="Arial" pitchFamily="34" charset="-122"/>
+                <a:cs typeface="Arial" pitchFamily="34" charset="-120"/>
+              </a:rPr>
+              <a:t>UNCLASSIFIED</a:t>
+            </a:r>
+            <a:endParaRPr lang="en-US" sz="750" dirty="0"/>
+          </a:p>
+        </p:txBody>
       </p:sp>
       <p:sp>
         <p:nvSpPr>
@@ -903,7 +922,7 @@
         </p:nvSpPr>
         <p:spPr>
           <a:xfrm>
-            <a:off x="0" y="0"/>
+            <a:off x="0" y="10506456"/>
             <a:ext cx="7562088" cy="164592"/>
           </a:xfrm>
           <a:prstGeom prst="rect">
@@ -922,7 +941,7 @@
             <a:r>
               <a:rPr lang="en-US" sz="750" b="1" spc="400" kern="0" dirty="0">
                 <a:solidFill>
-                  <a:srgbClr val="FFFFFF"/>
+                  <a:srgbClr val="000000"/>
                 </a:solidFill>
                 <a:latin typeface="Arial" pitchFamily="34" charset="0"/>
                 <a:ea typeface="Arial" pitchFamily="34" charset="-122"/>
@@ -936,23 +955,42 @@
       </p:sp>
       <p:sp>
         <p:nvSpPr>
-          <p:cNvPr id="4" name="Shape 2"/>
-          <p:cNvSpPr/>
-          <p:nvPr/>
-        </p:nvSpPr>
-        <p:spPr>
-          <a:xfrm>
-            <a:off x="0" y="10524744"/>
-            <a:ext cx="7562088" cy="164592"/>
-          </a:xfrm>
-          <a:prstGeom prst="rect">
-            <a:avLst/>
-          </a:prstGeom>
-          <a:solidFill>
-            <a:srgbClr val="000000"/>
-          </a:solidFill>
-          <a:ln/>
-        </p:spPr>
+          <p:cNvPr id="4" name="Text 2"/>
+          <p:cNvSpPr/>
+          <p:nvPr/>
+        </p:nvSpPr>
+        <p:spPr>
+          <a:xfrm>
+            <a:off x="457200" y="10506456"/>
+            <a:ext cx="2377440" cy="164592"/>
+          </a:xfrm>
+          <a:prstGeom prst="rect">
+            <a:avLst/>
+          </a:prstGeom>
+          <a:noFill/>
+          <a:ln/>
+        </p:spPr>
+        <p:txBody>
+          <a:bodyPr wrap="square" lIns="0" tIns="0" rIns="0" bIns="0" rtlCol="0" anchor="ctr"/>
+          <a:lstStyle/>
+          <a:p>
+            <a:pPr algn="l" indent="0" marL="0">
+              <a:buNone/>
+            </a:pPr>
+            <a:r>
+              <a:rPr lang="en-US" sz="600" dirty="0">
+                <a:solidFill>
+                  <a:srgbClr val="000000"/>
+                </a:solidFill>
+                <a:latin typeface="Arial" pitchFamily="34" charset="0"/>
+                <a:ea typeface="Arial" pitchFamily="34" charset="-122"/>
+                <a:cs typeface="Arial" pitchFamily="34" charset="-120"/>
+              </a:rPr>
+              <a:t>Army Command School  ·  ACS 2026</a:t>
+            </a:r>
+            <a:endParaRPr lang="en-US" sz="600" dirty="0"/>
+          </a:p>
+        </p:txBody>
       </p:sp>
       <p:sp>
         <p:nvSpPr>
@@ -962,8 +1000,8 @@
         </p:nvSpPr>
         <p:spPr>
           <a:xfrm>
-            <a:off x="0" y="10524744"/>
-            <a:ext cx="7562088" cy="164592"/>
+            <a:off x="5212080" y="10506456"/>
+            <a:ext cx="1892808" cy="164592"/>
           </a:xfrm>
           <a:prstGeom prst="rect">
             <a:avLst/>
@@ -975,91 +1013,13 @@
           <a:bodyPr wrap="square" lIns="0" tIns="0" rIns="0" bIns="0" rtlCol="0" anchor="ctr"/>
           <a:lstStyle/>
           <a:p>
-            <a:pPr algn="ctr" indent="0" marL="0">
-              <a:buNone/>
-            </a:pPr>
-            <a:r>
-              <a:rPr lang="en-US" sz="750" b="1" spc="400" kern="0" dirty="0">
-                <a:solidFill>
-                  <a:srgbClr val="FFFFFF"/>
-                </a:solidFill>
-                <a:latin typeface="Arial" pitchFamily="34" charset="0"/>
-                <a:ea typeface="Arial" pitchFamily="34" charset="-122"/>
-                <a:cs typeface="Arial" pitchFamily="34" charset="-120"/>
-              </a:rPr>
-              <a:t>UNCLASSIFIED</a:t>
-            </a:r>
-            <a:endParaRPr lang="en-US" sz="750" dirty="0"/>
-          </a:p>
-        </p:txBody>
-      </p:sp>
-      <p:sp>
-        <p:nvSpPr>
-          <p:cNvPr id="6" name="Text 4"/>
-          <p:cNvSpPr/>
-          <p:nvPr/>
-        </p:nvSpPr>
-        <p:spPr>
-          <a:xfrm>
-            <a:off x="457200" y="10524744"/>
-            <a:ext cx="2377440" cy="164592"/>
-          </a:xfrm>
-          <a:prstGeom prst="rect">
-            <a:avLst/>
-          </a:prstGeom>
-          <a:noFill/>
-          <a:ln/>
-        </p:spPr>
-        <p:txBody>
-          <a:bodyPr wrap="square" lIns="0" tIns="0" rIns="0" bIns="0" rtlCol="0" anchor="ctr"/>
-          <a:lstStyle/>
-          <a:p>
-            <a:pPr algn="l" indent="0" marL="0">
+            <a:pPr algn="r" indent="0" marL="0">
               <a:buNone/>
             </a:pPr>
             <a:r>
               <a:rPr lang="en-US" sz="600" dirty="0">
                 <a:solidFill>
-                  <a:srgbClr val="CDD2B7"/>
-                </a:solidFill>
-                <a:latin typeface="Arial" pitchFamily="34" charset="0"/>
-                <a:ea typeface="Arial" pitchFamily="34" charset="-122"/>
-                <a:cs typeface="Arial" pitchFamily="34" charset="-120"/>
-              </a:rPr>
-              <a:t>Army Command School  ·  ACS 2026</a:t>
-            </a:r>
-            <a:endParaRPr lang="en-US" sz="600" dirty="0"/>
-          </a:p>
-        </p:txBody>
-      </p:sp>
-      <p:sp>
-        <p:nvSpPr>
-          <p:cNvPr id="7" name="Text 5"/>
-          <p:cNvSpPr/>
-          <p:nvPr/>
-        </p:nvSpPr>
-        <p:spPr>
-          <a:xfrm>
-            <a:off x="5212080" y="10524744"/>
-            <a:ext cx="1892808" cy="164592"/>
-          </a:xfrm>
-          <a:prstGeom prst="rect">
-            <a:avLst/>
-          </a:prstGeom>
-          <a:noFill/>
-          <a:ln/>
-        </p:spPr>
-        <p:txBody>
-          <a:bodyPr wrap="square" lIns="0" tIns="0" rIns="0" bIns="0" rtlCol="0" anchor="ctr"/>
-          <a:lstStyle/>
-          <a:p>
-            <a:pPr algn="r" indent="0" marL="0">
-              <a:buNone/>
-            </a:pPr>
-            <a:r>
-              <a:rPr lang="en-US" sz="600" dirty="0">
-                <a:solidFill>
-                  <a:srgbClr val="CDD2B7"/>
+                  <a:srgbClr val="000000"/>
                 </a:solidFill>
                 <a:latin typeface="Arial" pitchFamily="34" charset="0"/>
                 <a:ea typeface="Arial" pitchFamily="34" charset="-122"/>
@@ -1073,7 +1033,7 @@
       </p:sp>
       <p:pic>
         <p:nvPicPr>
-          <p:cNvPr id="8" name="Image 0" descr="/tmp/claude-0/-home-user-PUP/2d4cec0e-a52e-5368-bb54-803c6f37698d/scratchpad/logo-trimmed.png">    </p:cNvPr>
+          <p:cNvPr id="6" name="Image 0" descr="/tmp/claude-0/-home-user-PUP/2d4cec0e-a52e-5368-bb54-803c6f37698d/scratchpad/logo-trimmed.png">    </p:cNvPr>
           <p:cNvPicPr>
             <a:picLocks noChangeAspect="1"/>
           </p:cNvPicPr>
@@ -1097,7 +1057,7 @@
       </p:pic>
       <p:sp>
         <p:nvSpPr>
-          <p:cNvPr id="9" name="Text 6"/>
+          <p:cNvPr id="7" name="Text 4"/>
           <p:cNvSpPr/>
           <p:nvPr/>
         </p:nvSpPr>
@@ -1136,7 +1096,7 @@
       </p:sp>
       <p:sp>
         <p:nvSpPr>
-          <p:cNvPr id="10" name="Text 7"/>
+          <p:cNvPr id="8" name="Text 5"/>
           <p:cNvSpPr/>
           <p:nvPr/>
         </p:nvSpPr>
@@ -1189,7 +1149,7 @@
       </p:sp>
       <p:sp>
         <p:nvSpPr>
-          <p:cNvPr id="11" name="Shape 8"/>
+          <p:cNvPr id="9" name="Shape 6"/>
           <p:cNvSpPr/>
           <p:nvPr/>
         </p:nvSpPr>
@@ -1212,7 +1172,7 @@
       </p:sp>
       <p:pic>
         <p:nvPicPr>
-          <p:cNvPr id="12" name="Image 1" descr="preencoded.png">    </p:cNvPr>
+          <p:cNvPr id="10" name="Image 1" descr="preencoded.png">    </p:cNvPr>
           <p:cNvPicPr>
             <a:picLocks noChangeAspect="1"/>
           </p:cNvPicPr>
@@ -1236,7 +1196,7 @@
       </p:pic>
       <p:sp>
         <p:nvSpPr>
-          <p:cNvPr id="13" name="Text 9"/>
+          <p:cNvPr id="11" name="Text 7"/>
           <p:cNvSpPr/>
           <p:nvPr/>
         </p:nvSpPr>
@@ -1275,7 +1235,7 @@
       </p:sp>
       <p:sp>
         <p:nvSpPr>
-          <p:cNvPr id="14" name="Text 10"/>
+          <p:cNvPr id="12" name="Text 8"/>
           <p:cNvSpPr/>
           <p:nvPr/>
         </p:nvSpPr>
@@ -1314,7 +1274,7 @@
       </p:sp>
       <p:sp>
         <p:nvSpPr>
-          <p:cNvPr id="15" name="Shape 11"/>
+          <p:cNvPr id="13" name="Shape 9"/>
           <p:cNvSpPr/>
           <p:nvPr/>
         </p:nvSpPr>
@@ -1334,7 +1294,7 @@
       </p:sp>
       <p:sp>
         <p:nvSpPr>
-          <p:cNvPr id="16" name="Text 12"/>
+          <p:cNvPr id="14" name="Text 10"/>
           <p:cNvSpPr/>
           <p:nvPr/>
         </p:nvSpPr>
@@ -1373,7 +1333,7 @@
       </p:sp>
       <p:sp>
         <p:nvSpPr>
-          <p:cNvPr id="17" name="Shape 13"/>
+          <p:cNvPr id="15" name="Shape 11"/>
           <p:cNvSpPr/>
           <p:nvPr/>
         </p:nvSpPr>
@@ -1395,7 +1355,7 @@
       </p:sp>
       <p:sp>
         <p:nvSpPr>
-          <p:cNvPr id="18" name="Text 14"/>
+          <p:cNvPr id="16" name="Text 12"/>
           <p:cNvSpPr/>
           <p:nvPr/>
         </p:nvSpPr>
@@ -1434,7 +1394,7 @@
       </p:sp>
       <p:sp>
         <p:nvSpPr>
-          <p:cNvPr id="19" name="Shape 15"/>
+          <p:cNvPr id="17" name="Shape 13"/>
           <p:cNvSpPr/>
           <p:nvPr/>
         </p:nvSpPr>
@@ -1459,7 +1419,7 @@
       </p:sp>
       <p:pic>
         <p:nvPicPr>
-          <p:cNvPr id="20" name="Image 2" descr="preencoded.png">    </p:cNvPr>
+          <p:cNvPr id="18" name="Image 2" descr="preencoded.png">    </p:cNvPr>
           <p:cNvPicPr>
             <a:picLocks noChangeAspect="1"/>
           </p:cNvPicPr>
@@ -1483,7 +1443,7 @@
       </p:pic>
       <p:sp>
         <p:nvSpPr>
-          <p:cNvPr id="21" name="Text 16"/>
+          <p:cNvPr id="19" name="Text 14"/>
           <p:cNvSpPr/>
           <p:nvPr/>
         </p:nvSpPr>
@@ -1522,7 +1482,7 @@
       </p:sp>
       <p:sp>
         <p:nvSpPr>
-          <p:cNvPr id="22" name="Shape 17"/>
+          <p:cNvPr id="20" name="Shape 15"/>
           <p:cNvSpPr/>
           <p:nvPr/>
         </p:nvSpPr>
@@ -1545,7 +1505,7 @@
       </p:sp>
       <p:sp>
         <p:nvSpPr>
-          <p:cNvPr id="23" name="Shape 18"/>
+          <p:cNvPr id="21" name="Shape 16"/>
           <p:cNvSpPr/>
           <p:nvPr/>
         </p:nvSpPr>
@@ -1570,7 +1530,7 @@
       </p:sp>
       <p:pic>
         <p:nvPicPr>
-          <p:cNvPr id="24" name="Image 3" descr="preencoded.png">    </p:cNvPr>
+          <p:cNvPr id="22" name="Image 3" descr="preencoded.png">    </p:cNvPr>
           <p:cNvPicPr>
             <a:picLocks noChangeAspect="1"/>
           </p:cNvPicPr>
@@ -1594,7 +1554,7 @@
       </p:pic>
       <p:sp>
         <p:nvSpPr>
-          <p:cNvPr id="25" name="Text 19"/>
+          <p:cNvPr id="23" name="Text 17"/>
           <p:cNvSpPr/>
           <p:nvPr/>
         </p:nvSpPr>
@@ -1633,7 +1593,7 @@
       </p:sp>
       <p:sp>
         <p:nvSpPr>
-          <p:cNvPr id="26" name="Shape 20"/>
+          <p:cNvPr id="24" name="Shape 18"/>
           <p:cNvSpPr/>
           <p:nvPr/>
         </p:nvSpPr>
@@ -1656,7 +1616,7 @@
       </p:sp>
       <p:sp>
         <p:nvSpPr>
-          <p:cNvPr id="27" name="Shape 21"/>
+          <p:cNvPr id="25" name="Shape 19"/>
           <p:cNvSpPr/>
           <p:nvPr/>
         </p:nvSpPr>
@@ -1681,7 +1641,7 @@
       </p:sp>
       <p:pic>
         <p:nvPicPr>
-          <p:cNvPr id="28" name="Image 4" descr="preencoded.png">    </p:cNvPr>
+          <p:cNvPr id="26" name="Image 4" descr="preencoded.png">    </p:cNvPr>
           <p:cNvPicPr>
             <a:picLocks noChangeAspect="1"/>
           </p:cNvPicPr>
@@ -1705,7 +1665,7 @@
       </p:pic>
       <p:sp>
         <p:nvSpPr>
-          <p:cNvPr id="29" name="Text 22"/>
+          <p:cNvPr id="27" name="Text 20"/>
           <p:cNvSpPr/>
           <p:nvPr/>
         </p:nvSpPr>
@@ -1744,7 +1704,7 @@
       </p:sp>
       <p:sp>
         <p:nvSpPr>
-          <p:cNvPr id="30" name="Shape 23"/>
+          <p:cNvPr id="28" name="Shape 21"/>
           <p:cNvSpPr/>
           <p:nvPr/>
         </p:nvSpPr>
@@ -1764,7 +1724,7 @@
       </p:sp>
       <p:sp>
         <p:nvSpPr>
-          <p:cNvPr id="31" name="Text 24"/>
+          <p:cNvPr id="29" name="Text 22"/>
           <p:cNvSpPr/>
           <p:nvPr/>
         </p:nvSpPr>
@@ -1803,7 +1763,7 @@
       </p:sp>
       <p:sp>
         <p:nvSpPr>
-          <p:cNvPr id="32" name="Shape 25"/>
+          <p:cNvPr id="30" name="Shape 23"/>
           <p:cNvSpPr/>
           <p:nvPr/>
         </p:nvSpPr>
@@ -1828,7 +1788,7 @@
       </p:sp>
       <p:pic>
         <p:nvPicPr>
-          <p:cNvPr id="33" name="Image 5" descr="preencoded.png">    </p:cNvPr>
+          <p:cNvPr id="31" name="Image 5" descr="preencoded.png">    </p:cNvPr>
           <p:cNvPicPr>
             <a:picLocks noChangeAspect="1"/>
           </p:cNvPicPr>
@@ -1852,7 +1812,7 @@
       </p:pic>
       <p:sp>
         <p:nvSpPr>
-          <p:cNvPr id="34" name="Text 26"/>
+          <p:cNvPr id="32" name="Text 24"/>
           <p:cNvSpPr/>
           <p:nvPr/>
         </p:nvSpPr>
@@ -1891,7 +1851,7 @@
       </p:sp>
       <p:sp>
         <p:nvSpPr>
-          <p:cNvPr id="35" name="Shape 27"/>
+          <p:cNvPr id="33" name="Shape 25"/>
           <p:cNvSpPr/>
           <p:nvPr/>
         </p:nvSpPr>
@@ -1914,7 +1874,7 @@
       </p:sp>
       <p:pic>
         <p:nvPicPr>
-          <p:cNvPr id="36" name="Image 6" descr="preencoded.png">    </p:cNvPr>
+          <p:cNvPr id="34" name="Image 6" descr="preencoded.png">    </p:cNvPr>
           <p:cNvPicPr>
             <a:picLocks noChangeAspect="1"/>
           </p:cNvPicPr>
@@ -1938,7 +1898,7 @@
       </p:pic>
       <p:sp>
         <p:nvSpPr>
-          <p:cNvPr id="37" name="Text 28"/>
+          <p:cNvPr id="35" name="Text 26"/>
           <p:cNvSpPr/>
           <p:nvPr/>
         </p:nvSpPr>
@@ -1977,7 +1937,7 @@
       </p:sp>
       <p:sp>
         <p:nvSpPr>
-          <p:cNvPr id="38" name="Shape 29"/>
+          <p:cNvPr id="36" name="Shape 27"/>
           <p:cNvSpPr/>
           <p:nvPr/>
         </p:nvSpPr>
@@ -2000,7 +1960,7 @@
       </p:sp>
       <p:pic>
         <p:nvPicPr>
-          <p:cNvPr id="39" name="Image 7" descr="preencoded.png">    </p:cNvPr>
+          <p:cNvPr id="37" name="Image 7" descr="preencoded.png">    </p:cNvPr>
           <p:cNvPicPr>
             <a:picLocks noChangeAspect="1"/>
           </p:cNvPicPr>
@@ -2024,7 +1984,7 @@
       </p:pic>
       <p:sp>
         <p:nvSpPr>
-          <p:cNvPr id="40" name="Text 30"/>
+          <p:cNvPr id="38" name="Text 28"/>
           <p:cNvSpPr/>
           <p:nvPr/>
         </p:nvSpPr>
@@ -2063,7 +2023,7 @@
       </p:sp>
       <p:sp>
         <p:nvSpPr>
-          <p:cNvPr id="41" name="Shape 31"/>
+          <p:cNvPr id="39" name="Shape 29"/>
           <p:cNvSpPr/>
           <p:nvPr/>
         </p:nvSpPr>
@@ -2086,7 +2046,7 @@
       </p:sp>
       <p:pic>
         <p:nvPicPr>
-          <p:cNvPr id="42" name="Image 8" descr="preencoded.png">    </p:cNvPr>
+          <p:cNvPr id="40" name="Image 8" descr="preencoded.png">    </p:cNvPr>
           <p:cNvPicPr>
             <a:picLocks noChangeAspect="1"/>
           </p:cNvPicPr>
@@ -2110,7 +2070,7 @@
       </p:pic>
       <p:sp>
         <p:nvSpPr>
-          <p:cNvPr id="43" name="Text 32"/>
+          <p:cNvPr id="41" name="Text 30"/>
           <p:cNvSpPr/>
           <p:nvPr/>
         </p:nvSpPr>
@@ -2149,7 +2109,7 @@
       </p:sp>
       <p:sp>
         <p:nvSpPr>
-          <p:cNvPr id="44" name="Shape 33"/>
+          <p:cNvPr id="42" name="Shape 31"/>
           <p:cNvSpPr/>
           <p:nvPr/>
         </p:nvSpPr>
@@ -2172,7 +2132,7 @@
       </p:sp>
       <p:pic>
         <p:nvPicPr>
-          <p:cNvPr id="45" name="Image 9" descr="preencoded.png">    </p:cNvPr>
+          <p:cNvPr id="43" name="Image 9" descr="preencoded.png">    </p:cNvPr>
           <p:cNvPicPr>
             <a:picLocks noChangeAspect="1"/>
           </p:cNvPicPr>
@@ -2196,7 +2156,7 @@
       </p:pic>
       <p:sp>
         <p:nvSpPr>
-          <p:cNvPr id="46" name="Text 34"/>
+          <p:cNvPr id="44" name="Text 32"/>
           <p:cNvSpPr/>
           <p:nvPr/>
         </p:nvSpPr>
@@ -2235,7 +2195,7 @@
       </p:sp>
       <p:sp>
         <p:nvSpPr>
-          <p:cNvPr id="47" name="Shape 35"/>
+          <p:cNvPr id="45" name="Shape 33"/>
           <p:cNvSpPr/>
           <p:nvPr/>
         </p:nvSpPr>
@@ -2258,7 +2218,7 @@
       </p:sp>
       <p:pic>
         <p:nvPicPr>
-          <p:cNvPr id="48" name="Image 10" descr="preencoded.png">    </p:cNvPr>
+          <p:cNvPr id="46" name="Image 10" descr="preencoded.png">    </p:cNvPr>
           <p:cNvPicPr>
             <a:picLocks noChangeAspect="1"/>
           </p:cNvPicPr>
@@ -2282,7 +2242,7 @@
       </p:pic>
       <p:sp>
         <p:nvSpPr>
-          <p:cNvPr id="49" name="Text 36"/>
+          <p:cNvPr id="47" name="Text 34"/>
           <p:cNvSpPr/>
           <p:nvPr/>
         </p:nvSpPr>
@@ -2321,7 +2281,7 @@
       </p:sp>
       <p:sp>
         <p:nvSpPr>
-          <p:cNvPr id="50" name="Shape 37"/>
+          <p:cNvPr id="48" name="Shape 35"/>
           <p:cNvSpPr/>
           <p:nvPr/>
         </p:nvSpPr>
@@ -2343,7 +2303,7 @@
       </p:sp>
       <p:sp>
         <p:nvSpPr>
-          <p:cNvPr id="51" name="Text 38"/>
+          <p:cNvPr id="49" name="Text 36"/>
           <p:cNvSpPr/>
           <p:nvPr/>
         </p:nvSpPr>
@@ -2382,7 +2342,7 @@
       </p:sp>
       <p:sp>
         <p:nvSpPr>
-          <p:cNvPr id="52" name="Shape 39"/>
+          <p:cNvPr id="50" name="Shape 37"/>
           <p:cNvSpPr/>
           <p:nvPr/>
         </p:nvSpPr>
@@ -2402,7 +2362,7 @@
       </p:sp>
       <p:sp>
         <p:nvSpPr>
-          <p:cNvPr id="53" name="Text 40"/>
+          <p:cNvPr id="51" name="Text 38"/>
           <p:cNvSpPr/>
           <p:nvPr/>
         </p:nvSpPr>
@@ -2441,7 +2401,7 @@
       </p:sp>
       <p:sp>
         <p:nvSpPr>
-          <p:cNvPr id="54" name="Shape 41"/>
+          <p:cNvPr id="52" name="Shape 39"/>
           <p:cNvSpPr/>
           <p:nvPr/>
         </p:nvSpPr>
@@ -2466,7 +2426,7 @@
       </p:sp>
       <p:sp>
         <p:nvSpPr>
-          <p:cNvPr id="55" name="Shape 42"/>
+          <p:cNvPr id="53" name="Shape 40"/>
           <p:cNvSpPr/>
           <p:nvPr/>
         </p:nvSpPr>
@@ -2486,7 +2446,7 @@
       </p:sp>
       <p:sp>
         <p:nvSpPr>
-          <p:cNvPr id="56" name="Text 43"/>
+          <p:cNvPr id="54" name="Text 41"/>
           <p:cNvSpPr/>
           <p:nvPr/>
         </p:nvSpPr>
@@ -2525,7 +2485,7 @@
       </p:sp>
       <p:sp>
         <p:nvSpPr>
-          <p:cNvPr id="57" name="Shape 44"/>
+          <p:cNvPr id="55" name="Shape 42"/>
           <p:cNvSpPr/>
           <p:nvPr/>
         </p:nvSpPr>
@@ -2545,7 +2505,7 @@
       </p:sp>
       <p:pic>
         <p:nvPicPr>
-          <p:cNvPr id="58" name="Image 11" descr="preencoded.png">    </p:cNvPr>
+          <p:cNvPr id="56" name="Image 11" descr="preencoded.png">    </p:cNvPr>
           <p:cNvPicPr>
             <a:picLocks noChangeAspect="1"/>
           </p:cNvPicPr>
@@ -2569,7 +2529,7 @@
       </p:pic>
       <p:sp>
         <p:nvSpPr>
-          <p:cNvPr id="59" name="Text 45"/>
+          <p:cNvPr id="57" name="Text 43"/>
           <p:cNvSpPr/>
           <p:nvPr/>
         </p:nvSpPr>
@@ -2608,7 +2568,7 @@
       </p:sp>
       <p:sp>
         <p:nvSpPr>
-          <p:cNvPr id="60" name="Text 46"/>
+          <p:cNvPr id="58" name="Text 44"/>
           <p:cNvSpPr/>
           <p:nvPr/>
         </p:nvSpPr>
@@ -2647,7 +2607,7 @@
       </p:sp>
       <p:sp>
         <p:nvSpPr>
-          <p:cNvPr id="61" name="Shape 47"/>
+          <p:cNvPr id="59" name="Shape 45"/>
           <p:cNvSpPr/>
           <p:nvPr/>
         </p:nvSpPr>
@@ -2672,7 +2632,7 @@
       </p:sp>
       <p:sp>
         <p:nvSpPr>
-          <p:cNvPr id="62" name="Shape 48"/>
+          <p:cNvPr id="60" name="Shape 46"/>
           <p:cNvSpPr/>
           <p:nvPr/>
         </p:nvSpPr>
@@ -2692,7 +2652,7 @@
       </p:sp>
       <p:sp>
         <p:nvSpPr>
-          <p:cNvPr id="63" name="Text 49"/>
+          <p:cNvPr id="61" name="Text 47"/>
           <p:cNvSpPr/>
           <p:nvPr/>
         </p:nvSpPr>
@@ -2731,7 +2691,7 @@
       </p:sp>
       <p:sp>
         <p:nvSpPr>
-          <p:cNvPr id="64" name="Shape 50"/>
+          <p:cNvPr id="62" name="Shape 48"/>
           <p:cNvSpPr/>
           <p:nvPr/>
         </p:nvSpPr>
@@ -2751,7 +2711,7 @@
       </p:sp>
       <p:pic>
         <p:nvPicPr>
-          <p:cNvPr id="65" name="Image 12" descr="preencoded.png">    </p:cNvPr>
+          <p:cNvPr id="63" name="Image 12" descr="preencoded.png">    </p:cNvPr>
           <p:cNvPicPr>
             <a:picLocks noChangeAspect="1"/>
           </p:cNvPicPr>
@@ -2775,7 +2735,7 @@
       </p:pic>
       <p:sp>
         <p:nvSpPr>
-          <p:cNvPr id="66" name="Text 51"/>
+          <p:cNvPr id="64" name="Text 49"/>
           <p:cNvSpPr/>
           <p:nvPr/>
         </p:nvSpPr>
@@ -2814,7 +2774,7 @@
       </p:sp>
       <p:sp>
         <p:nvSpPr>
-          <p:cNvPr id="67" name="Text 52"/>
+          <p:cNvPr id="65" name="Text 50"/>
           <p:cNvSpPr/>
           <p:nvPr/>
         </p:nvSpPr>
@@ -2853,7 +2813,7 @@
       </p:sp>
       <p:sp>
         <p:nvSpPr>
-          <p:cNvPr id="68" name="Shape 53"/>
+          <p:cNvPr id="66" name="Shape 51"/>
           <p:cNvSpPr/>
           <p:nvPr/>
         </p:nvSpPr>
@@ -2878,7 +2838,7 @@
       </p:sp>
       <p:sp>
         <p:nvSpPr>
-          <p:cNvPr id="69" name="Shape 54"/>
+          <p:cNvPr id="67" name="Shape 52"/>
           <p:cNvSpPr/>
           <p:nvPr/>
         </p:nvSpPr>
@@ -2898,7 +2858,7 @@
       </p:sp>
       <p:sp>
         <p:nvSpPr>
-          <p:cNvPr id="70" name="Text 55"/>
+          <p:cNvPr id="68" name="Text 53"/>
           <p:cNvSpPr/>
           <p:nvPr/>
         </p:nvSpPr>
@@ -2937,7 +2897,7 @@
       </p:sp>
       <p:sp>
         <p:nvSpPr>
-          <p:cNvPr id="71" name="Shape 56"/>
+          <p:cNvPr id="69" name="Shape 54"/>
           <p:cNvSpPr/>
           <p:nvPr/>
         </p:nvSpPr>
@@ -2957,7 +2917,7 @@
       </p:sp>
       <p:pic>
         <p:nvPicPr>
-          <p:cNvPr id="72" name="Image 13" descr="preencoded.png">    </p:cNvPr>
+          <p:cNvPr id="70" name="Image 13" descr="preencoded.png">    </p:cNvPr>
           <p:cNvPicPr>
             <a:picLocks noChangeAspect="1"/>
           </p:cNvPicPr>
@@ -2981,7 +2941,7 @@
       </p:pic>
       <p:sp>
         <p:nvSpPr>
-          <p:cNvPr id="73" name="Text 57"/>
+          <p:cNvPr id="71" name="Text 55"/>
           <p:cNvSpPr/>
           <p:nvPr/>
         </p:nvSpPr>
@@ -3020,7 +2980,7 @@
       </p:sp>
       <p:sp>
         <p:nvSpPr>
-          <p:cNvPr id="74" name="Text 58"/>
+          <p:cNvPr id="72" name="Text 56"/>
           <p:cNvSpPr/>
           <p:nvPr/>
         </p:nvSpPr>
@@ -3059,7 +3019,7 @@
       </p:sp>
       <p:sp>
         <p:nvSpPr>
-          <p:cNvPr id="75" name="Shape 59"/>
+          <p:cNvPr id="73" name="Shape 57"/>
           <p:cNvSpPr/>
           <p:nvPr/>
         </p:nvSpPr>
@@ -3084,7 +3044,7 @@
       </p:sp>
       <p:sp>
         <p:nvSpPr>
-          <p:cNvPr id="76" name="Shape 60"/>
+          <p:cNvPr id="74" name="Shape 58"/>
           <p:cNvSpPr/>
           <p:nvPr/>
         </p:nvSpPr>
@@ -3104,7 +3064,7 @@
       </p:sp>
       <p:sp>
         <p:nvSpPr>
-          <p:cNvPr id="77" name="Text 61"/>
+          <p:cNvPr id="75" name="Text 59"/>
           <p:cNvSpPr/>
           <p:nvPr/>
         </p:nvSpPr>
@@ -3143,7 +3103,7 @@
       </p:sp>
       <p:sp>
         <p:nvSpPr>
-          <p:cNvPr id="78" name="Shape 62"/>
+          <p:cNvPr id="76" name="Shape 60"/>
           <p:cNvSpPr/>
           <p:nvPr/>
         </p:nvSpPr>
@@ -3163,7 +3123,7 @@
       </p:sp>
       <p:pic>
         <p:nvPicPr>
-          <p:cNvPr id="79" name="Image 14" descr="preencoded.png">    </p:cNvPr>
+          <p:cNvPr id="77" name="Image 14" descr="preencoded.png">    </p:cNvPr>
           <p:cNvPicPr>
             <a:picLocks noChangeAspect="1"/>
           </p:cNvPicPr>
@@ -3187,7 +3147,7 @@
       </p:pic>
       <p:sp>
         <p:nvSpPr>
-          <p:cNvPr id="80" name="Text 63"/>
+          <p:cNvPr id="78" name="Text 61"/>
           <p:cNvSpPr/>
           <p:nvPr/>
         </p:nvSpPr>
@@ -3226,7 +3186,7 @@
       </p:sp>
       <p:sp>
         <p:nvSpPr>
-          <p:cNvPr id="81" name="Text 64"/>
+          <p:cNvPr id="79" name="Text 62"/>
           <p:cNvSpPr/>
           <p:nvPr/>
         </p:nvSpPr>
@@ -3265,7 +3225,7 @@
       </p:sp>
       <p:sp>
         <p:nvSpPr>
-          <p:cNvPr id="82" name="Shape 65"/>
+          <p:cNvPr id="80" name="Shape 63"/>
           <p:cNvSpPr/>
           <p:nvPr/>
         </p:nvSpPr>
@@ -3290,7 +3250,7 @@
       </p:sp>
       <p:sp>
         <p:nvSpPr>
-          <p:cNvPr id="83" name="Shape 66"/>
+          <p:cNvPr id="81" name="Shape 64"/>
           <p:cNvSpPr/>
           <p:nvPr/>
         </p:nvSpPr>
@@ -3310,7 +3270,7 @@
       </p:sp>
       <p:sp>
         <p:nvSpPr>
-          <p:cNvPr id="84" name="Text 67"/>
+          <p:cNvPr id="82" name="Text 65"/>
           <p:cNvSpPr/>
           <p:nvPr/>
         </p:nvSpPr>
@@ -3349,7 +3309,7 @@
       </p:sp>
       <p:sp>
         <p:nvSpPr>
-          <p:cNvPr id="85" name="Shape 68"/>
+          <p:cNvPr id="83" name="Shape 66"/>
           <p:cNvSpPr/>
           <p:nvPr/>
         </p:nvSpPr>
@@ -3369,7 +3329,7 @@
       </p:sp>
       <p:pic>
         <p:nvPicPr>
-          <p:cNvPr id="86" name="Image 15" descr="preencoded.png">    </p:cNvPr>
+          <p:cNvPr id="84" name="Image 15" descr="preencoded.png">    </p:cNvPr>
           <p:cNvPicPr>
             <a:picLocks noChangeAspect="1"/>
           </p:cNvPicPr>
@@ -3393,7 +3353,7 @@
       </p:pic>
       <p:sp>
         <p:nvSpPr>
-          <p:cNvPr id="87" name="Text 69"/>
+          <p:cNvPr id="85" name="Text 67"/>
           <p:cNvSpPr/>
           <p:nvPr/>
         </p:nvSpPr>
@@ -3432,7 +3392,7 @@
       </p:sp>
       <p:sp>
         <p:nvSpPr>
-          <p:cNvPr id="88" name="Text 70"/>
+          <p:cNvPr id="86" name="Text 68"/>
           <p:cNvSpPr/>
           <p:nvPr/>
         </p:nvSpPr>
@@ -3471,7 +3431,7 @@
       </p:sp>
       <p:sp>
         <p:nvSpPr>
-          <p:cNvPr id="89" name="Shape 71"/>
+          <p:cNvPr id="87" name="Shape 69"/>
           <p:cNvSpPr/>
           <p:nvPr/>
         </p:nvSpPr>
@@ -3491,7 +3451,7 @@
       </p:sp>
       <p:sp>
         <p:nvSpPr>
-          <p:cNvPr id="90" name="Text 72"/>
+          <p:cNvPr id="88" name="Text 70"/>
           <p:cNvSpPr/>
           <p:nvPr/>
         </p:nvSpPr>
@@ -3530,7 +3490,7 @@
       </p:sp>
       <p:sp>
         <p:nvSpPr>
-          <p:cNvPr id="91" name="Text 73"/>
+          <p:cNvPr id="89" name="Text 71"/>
           <p:cNvSpPr/>
           <p:nvPr/>
         </p:nvSpPr>
@@ -3569,7 +3529,7 @@
       </p:sp>
       <p:sp>
         <p:nvSpPr>
-          <p:cNvPr id="92" name="Text 74"/>
+          <p:cNvPr id="90" name="Text 72"/>
           <p:cNvSpPr/>
           <p:nvPr/>
         </p:nvSpPr>
@@ -3608,7 +3568,7 @@
       </p:sp>
       <p:sp>
         <p:nvSpPr>
-          <p:cNvPr id="93" name="Shape 75"/>
+          <p:cNvPr id="91" name="Shape 73"/>
           <p:cNvSpPr/>
           <p:nvPr/>
         </p:nvSpPr>
@@ -3628,7 +3588,7 @@
       </p:sp>
       <p:sp>
         <p:nvSpPr>
-          <p:cNvPr id="94" name="Text 76"/>
+          <p:cNvPr id="92" name="Text 74"/>
           <p:cNvSpPr/>
           <p:nvPr/>
         </p:nvSpPr>
@@ -3667,7 +3627,7 @@
       </p:sp>
       <p:sp>
         <p:nvSpPr>
-          <p:cNvPr id="95" name="Shape 77"/>
+          <p:cNvPr id="93" name="Shape 75"/>
           <p:cNvSpPr/>
           <p:nvPr/>
         </p:nvSpPr>
@@ -3692,7 +3652,7 @@
       </p:sp>
       <p:pic>
         <p:nvPicPr>
-          <p:cNvPr id="96" name="Image 16" descr="preencoded.png">    </p:cNvPr>
+          <p:cNvPr id="94" name="Image 16" descr="preencoded.png">    </p:cNvPr>
           <p:cNvPicPr>
             <a:picLocks noChangeAspect="1"/>
           </p:cNvPicPr>
@@ -3716,7 +3676,7 @@
       </p:pic>
       <p:sp>
         <p:nvSpPr>
-          <p:cNvPr id="97" name="Text 78"/>
+          <p:cNvPr id="95" name="Text 76"/>
           <p:cNvSpPr/>
           <p:nvPr/>
         </p:nvSpPr>
@@ -3769,7 +3729,7 @@
       </p:sp>
       <p:sp>
         <p:nvSpPr>
-          <p:cNvPr id="98" name="Text 79"/>
+          <p:cNvPr id="96" name="Text 77"/>
           <p:cNvSpPr/>
           <p:nvPr/>
         </p:nvSpPr>
@@ -3808,7 +3768,7 @@
       </p:sp>
       <p:sp>
         <p:nvSpPr>
-          <p:cNvPr id="99" name="Text 80"/>
+          <p:cNvPr id="97" name="Text 78"/>
           <p:cNvSpPr/>
           <p:nvPr/>
         </p:nvSpPr>
@@ -3847,7 +3807,7 @@
       </p:sp>
       <p:sp>
         <p:nvSpPr>
-          <p:cNvPr id="100" name="Shape 81"/>
+          <p:cNvPr id="98" name="Shape 79"/>
           <p:cNvSpPr/>
           <p:nvPr/>
         </p:nvSpPr>
@@ -3872,7 +3832,7 @@
       </p:sp>
       <p:pic>
         <p:nvPicPr>
-          <p:cNvPr id="101" name="Image 17" descr="preencoded.png">    </p:cNvPr>
+          <p:cNvPr id="99" name="Image 17" descr="preencoded.png">    </p:cNvPr>
           <p:cNvPicPr>
             <a:picLocks noChangeAspect="1"/>
           </p:cNvPicPr>
@@ -3896,7 +3856,7 @@
       </p:pic>
       <p:sp>
         <p:nvSpPr>
-          <p:cNvPr id="102" name="Text 82"/>
+          <p:cNvPr id="100" name="Text 80"/>
           <p:cNvSpPr/>
           <p:nvPr/>
         </p:nvSpPr>
@@ -3949,7 +3909,7 @@
       </p:sp>
       <p:sp>
         <p:nvSpPr>
-          <p:cNvPr id="103" name="Text 83"/>
+          <p:cNvPr id="101" name="Text 81"/>
           <p:cNvSpPr/>
           <p:nvPr/>
         </p:nvSpPr>
@@ -3988,7 +3948,7 @@
       </p:sp>
       <p:sp>
         <p:nvSpPr>
-          <p:cNvPr id="104" name="Text 84"/>
+          <p:cNvPr id="102" name="Text 82"/>
           <p:cNvSpPr/>
           <p:nvPr/>
         </p:nvSpPr>
@@ -4027,7 +3987,7 @@
       </p:sp>
       <p:sp>
         <p:nvSpPr>
-          <p:cNvPr id="105" name="Shape 85"/>
+          <p:cNvPr id="103" name="Shape 83"/>
           <p:cNvSpPr/>
           <p:nvPr/>
         </p:nvSpPr>
@@ -4052,7 +4012,7 @@
       </p:sp>
       <p:pic>
         <p:nvPicPr>
-          <p:cNvPr id="106" name="Image 18" descr="preencoded.png">    </p:cNvPr>
+          <p:cNvPr id="104" name="Image 18" descr="preencoded.png">    </p:cNvPr>
           <p:cNvPicPr>
             <a:picLocks noChangeAspect="1"/>
           </p:cNvPicPr>
@@ -4076,7 +4036,7 @@
       </p:pic>
       <p:sp>
         <p:nvSpPr>
-          <p:cNvPr id="107" name="Text 86"/>
+          <p:cNvPr id="105" name="Text 84"/>
           <p:cNvSpPr/>
           <p:nvPr/>
         </p:nvSpPr>
@@ -4129,7 +4089,7 @@
       </p:sp>
       <p:sp>
         <p:nvSpPr>
-          <p:cNvPr id="108" name="Text 87"/>
+          <p:cNvPr id="106" name="Text 85"/>
           <p:cNvSpPr/>
           <p:nvPr/>
         </p:nvSpPr>
@@ -4168,7 +4128,7 @@
       </p:sp>
       <p:sp>
         <p:nvSpPr>
-          <p:cNvPr id="109" name="Shape 88"/>
+          <p:cNvPr id="107" name="Shape 86"/>
           <p:cNvSpPr/>
           <p:nvPr/>
         </p:nvSpPr>
@@ -4190,7 +4150,7 @@
       </p:sp>
       <p:sp>
         <p:nvSpPr>
-          <p:cNvPr id="110" name="Text 89"/>
+          <p:cNvPr id="108" name="Text 87"/>
           <p:cNvSpPr/>
           <p:nvPr/>
         </p:nvSpPr>
@@ -4243,7 +4203,7 @@
       </p:sp>
       <p:sp>
         <p:nvSpPr>
-          <p:cNvPr id="111" name="Shape 90"/>
+          <p:cNvPr id="109" name="Shape 88"/>
           <p:cNvSpPr/>
           <p:nvPr/>
         </p:nvSpPr>
@@ -4263,7 +4223,7 @@
       </p:sp>
       <p:sp>
         <p:nvSpPr>
-          <p:cNvPr id="112" name="Text 91"/>
+          <p:cNvPr id="110" name="Text 89"/>
           <p:cNvSpPr/>
           <p:nvPr/>
         </p:nvSpPr>
@@ -4302,7 +4262,7 @@
       </p:sp>
       <p:sp>
         <p:nvSpPr>
-          <p:cNvPr id="113" name="Shape 92"/>
+          <p:cNvPr id="111" name="Shape 90"/>
           <p:cNvSpPr/>
           <p:nvPr/>
         </p:nvSpPr>
@@ -4324,7 +4284,7 @@
       </p:sp>
       <p:pic>
         <p:nvPicPr>
-          <p:cNvPr id="114" name="Image 19" descr="preencoded.png">    </p:cNvPr>
+          <p:cNvPr id="112" name="Image 19" descr="preencoded.png">    </p:cNvPr>
           <p:cNvPicPr>
             <a:picLocks noChangeAspect="1"/>
           </p:cNvPicPr>
@@ -4348,7 +4308,7 @@
       </p:pic>
       <p:sp>
         <p:nvSpPr>
-          <p:cNvPr id="115" name="Text 93"/>
+          <p:cNvPr id="113" name="Text 91"/>
           <p:cNvSpPr/>
           <p:nvPr/>
         </p:nvSpPr>
@@ -4387,7 +4347,7 @@
       </p:sp>
       <p:sp>
         <p:nvSpPr>
-          <p:cNvPr id="116" name="Shape 94"/>
+          <p:cNvPr id="114" name="Shape 92"/>
           <p:cNvSpPr/>
           <p:nvPr/>
         </p:nvSpPr>
@@ -4407,7 +4367,7 @@
       </p:sp>
       <p:sp>
         <p:nvSpPr>
-          <p:cNvPr id="117" name="Text 95"/>
+          <p:cNvPr id="115" name="Text 93"/>
           <p:cNvSpPr/>
           <p:nvPr/>
         </p:nvSpPr>
@@ -4446,7 +4406,7 @@
       </p:sp>
       <p:sp>
         <p:nvSpPr>
-          <p:cNvPr id="118" name="Shape 96"/>
+          <p:cNvPr id="116" name="Shape 94"/>
           <p:cNvSpPr/>
           <p:nvPr/>
         </p:nvSpPr>
@@ -4471,7 +4431,7 @@
       </p:sp>
       <p:sp>
         <p:nvSpPr>
-          <p:cNvPr id="119" name="Text 97"/>
+          <p:cNvPr id="117" name="Text 95"/>
           <p:cNvSpPr/>
           <p:nvPr/>
         </p:nvSpPr>
@@ -4510,7 +4470,7 @@
       </p:sp>
       <p:sp>
         <p:nvSpPr>
-          <p:cNvPr id="120" name="Text 98"/>
+          <p:cNvPr id="118" name="Text 96"/>
           <p:cNvSpPr/>
           <p:nvPr/>
         </p:nvSpPr>
@@ -4549,7 +4509,7 @@
       </p:sp>
       <p:sp>
         <p:nvSpPr>
-          <p:cNvPr id="121" name="Text 99"/>
+          <p:cNvPr id="119" name="Text 97"/>
           <p:cNvSpPr/>
           <p:nvPr/>
         </p:nvSpPr>
@@ -4588,7 +4548,7 @@
       </p:sp>
       <p:sp>
         <p:nvSpPr>
-          <p:cNvPr id="122" name="Text 100"/>
+          <p:cNvPr id="120" name="Text 98"/>
           <p:cNvSpPr/>
           <p:nvPr/>
         </p:nvSpPr>
@@ -4627,7 +4587,7 @@
       </p:sp>
       <p:sp>
         <p:nvSpPr>
-          <p:cNvPr id="123" name="Text 101"/>
+          <p:cNvPr id="121" name="Text 99"/>
           <p:cNvSpPr/>
           <p:nvPr/>
         </p:nvSpPr>
@@ -4666,7 +4626,7 @@
       </p:sp>
       <p:sp>
         <p:nvSpPr>
-          <p:cNvPr id="124" name="Text 102"/>
+          <p:cNvPr id="122" name="Text 100"/>
           <p:cNvSpPr/>
           <p:nvPr/>
         </p:nvSpPr>
@@ -4705,7 +4665,7 @@
       </p:sp>
       <p:sp>
         <p:nvSpPr>
-          <p:cNvPr id="125" name="Text 103"/>
+          <p:cNvPr id="123" name="Text 101"/>
           <p:cNvSpPr/>
           <p:nvPr/>
         </p:nvSpPr>
@@ -4744,7 +4704,7 @@
       </p:sp>
       <p:sp>
         <p:nvSpPr>
-          <p:cNvPr id="126" name="Text 104"/>
+          <p:cNvPr id="124" name="Text 102"/>
           <p:cNvSpPr/>
           <p:nvPr/>
         </p:nvSpPr>
@@ -4783,7 +4743,7 @@
       </p:sp>
       <p:sp>
         <p:nvSpPr>
-          <p:cNvPr id="127" name="Text 105"/>
+          <p:cNvPr id="125" name="Text 103"/>
           <p:cNvSpPr/>
           <p:nvPr/>
         </p:nvSpPr>
@@ -4822,7 +4782,7 @@
       </p:sp>
       <p:sp>
         <p:nvSpPr>
-          <p:cNvPr id="128" name="Text 106"/>
+          <p:cNvPr id="126" name="Text 104"/>
           <p:cNvSpPr/>
           <p:nvPr/>
         </p:nvSpPr>
@@ -4861,7 +4821,7 @@
       </p:sp>
       <p:sp>
         <p:nvSpPr>
-          <p:cNvPr id="129" name="Text 107"/>
+          <p:cNvPr id="127" name="Text 105"/>
           <p:cNvSpPr/>
           <p:nvPr/>
         </p:nvSpPr>
@@ -4900,7 +4860,7 @@
       </p:sp>
       <p:sp>
         <p:nvSpPr>
-          <p:cNvPr id="130" name="Text 108"/>
+          <p:cNvPr id="128" name="Text 106"/>
           <p:cNvSpPr/>
           <p:nvPr/>
         </p:nvSpPr>

</xml_diff>

<commit_message>
Withdrawal SOP: restructure to three grounds by protected object
Grounds reduced from five to three, each protecting a different thing:
medical and safety (the individual), learning and assessment (the
learning environment), conduct (the safe and effective conduct of the
activity). Governing-principle conditions aligned to mirror the three
grounds. Visual model updated with protects-captions per ground.

Co-Authored-By: Claude Fable 5 <noreply@anthropic.com>
Claude-Session: https://claude.ai/code/session_01YLo1WfwUDkbwfJEF3ZNVbB
</commit_message>
<xml_diff>
--- a/output/withdrawal-sop-visual.pptx
+++ b/output/withdrawal-sop-visual.pptx
@@ -1585,7 +1585,7 @@
                 <a:ea typeface="Arial" pitchFamily="34" charset="-122"/>
                 <a:cs typeface="Arial" pitchFamily="34" charset="-120"/>
               </a:rPr>
-              <a:t>Meaningful individual participation</a:t>
+              <a:t>The intended learning and assessment conditions</a:t>
             </a:r>
             <a:endParaRPr lang="en-US" sz="660" dirty="0"/>
           </a:p>
@@ -1696,7 +1696,7 @@
                 <a:ea typeface="Arial" pitchFamily="34" charset="-122"/>
                 <a:cs typeface="Arial" pitchFamily="34" charset="-120"/>
               </a:rPr>
-              <a:t>Maintenance of learning and assessment conditions</a:t>
+              <a:t>The safe and effective conduct of the activity</a:t>
             </a:r>
             <a:endParaRPr lang="en-US" sz="660" dirty="0"/>
           </a:p>
@@ -2408,7 +2408,7 @@
         <p:spPr>
           <a:xfrm>
             <a:off x="457200" y="4279392"/>
-            <a:ext cx="1271016" cy="1481328"/>
+            <a:ext cx="2142744" cy="1481328"/>
           </a:xfrm>
           <a:prstGeom prst="rect">
             <a:avLst/>
@@ -2432,8 +2432,8 @@
         </p:nvSpPr>
         <p:spPr>
           <a:xfrm>
-            <a:off x="512064" y="4334256"/>
-            <a:ext cx="155448" cy="155448"/>
+            <a:off x="530352" y="4352544"/>
+            <a:ext cx="173736" cy="173736"/>
           </a:xfrm>
           <a:prstGeom prst="rect">
             <a:avLst/>
@@ -2452,8 +2452,8 @@
         </p:nvSpPr>
         <p:spPr>
           <a:xfrm>
-            <a:off x="512064" y="4334256"/>
-            <a:ext cx="155448" cy="155448"/>
+            <a:off x="530352" y="4352544"/>
+            <a:ext cx="173736" cy="173736"/>
           </a:xfrm>
           <a:prstGeom prst="rect">
             <a:avLst/>
@@ -2469,7 +2469,7 @@
               <a:buNone/>
             </a:pPr>
             <a:r>
-              <a:rPr lang="en-US" sz="750" b="1" dirty="0">
+              <a:rPr lang="en-US" sz="800" b="1" dirty="0">
                 <a:solidFill>
                   <a:srgbClr val="FFFFFF"/>
                 </a:solidFill>
@@ -2479,7 +2479,7 @@
               </a:rPr>
               <a:t>1</a:t>
             </a:r>
-            <a:endParaRPr lang="en-US" sz="750" dirty="0"/>
+            <a:endParaRPr lang="en-US" sz="800" dirty="0"/>
           </a:p>
         </p:txBody>
       </p:sp>
@@ -2491,8 +2491,8 @@
         </p:nvSpPr>
         <p:spPr>
           <a:xfrm>
-            <a:off x="909828" y="4352544"/>
-            <a:ext cx="365760" cy="365760"/>
+            <a:off x="1336548" y="4352544"/>
+            <a:ext cx="384048" cy="384048"/>
           </a:xfrm>
           <a:prstGeom prst="ellipse">
             <a:avLst/>
@@ -2519,8 +2519,8 @@
         </p:blipFill>
         <p:spPr>
           <a:xfrm>
-            <a:off x="992124" y="4434840"/>
-            <a:ext cx="201168" cy="201168"/>
+            <a:off x="1423416" y="4439412"/>
+            <a:ext cx="210312" cy="210312"/>
           </a:xfrm>
           <a:prstGeom prst="rect">
             <a:avLst/>
@@ -2535,8 +2535,8 @@
         </p:nvSpPr>
         <p:spPr>
           <a:xfrm>
-            <a:off x="493776" y="4754880"/>
-            <a:ext cx="1197864" cy="274320"/>
+            <a:off x="512064" y="4773168"/>
+            <a:ext cx="2033016" cy="182880"/>
           </a:xfrm>
           <a:prstGeom prst="rect">
             <a:avLst/>
@@ -2552,7 +2552,7 @@
               <a:buNone/>
             </a:pPr>
             <a:r>
-              <a:rPr lang="en-US" sz="700" b="1" dirty="0">
+              <a:rPr lang="en-US" sz="820" b="1" dirty="0">
                 <a:solidFill>
                   <a:srgbClr val="002516"/>
                 </a:solidFill>
@@ -2560,9 +2560,9 @@
                 <a:ea typeface="Arial" pitchFamily="34" charset="-122"/>
                 <a:cs typeface="Arial" pitchFamily="34" charset="-120"/>
               </a:rPr>
-              <a:t>Safety or medical risk</a:t>
-            </a:r>
-            <a:endParaRPr lang="en-US" sz="700" dirty="0"/>
+              <a:t>Medical and safety</a:t>
+            </a:r>
+            <a:endParaRPr lang="en-US" sz="820" dirty="0"/>
           </a:p>
         </p:txBody>
       </p:sp>
@@ -2574,8 +2574,47 @@
         </p:nvSpPr>
         <p:spPr>
           <a:xfrm>
-            <a:off x="512064" y="5029200"/>
-            <a:ext cx="1161288" cy="694944"/>
+            <a:off x="512064" y="4956048"/>
+            <a:ext cx="2033016" cy="146304"/>
+          </a:xfrm>
+          <a:prstGeom prst="rect">
+            <a:avLst/>
+          </a:prstGeom>
+          <a:noFill/>
+          <a:ln/>
+        </p:spPr>
+        <p:txBody>
+          <a:bodyPr wrap="square" lIns="0" tIns="0" rIns="0" bIns="0" rtlCol="0" anchor="ctr"/>
+          <a:lstStyle/>
+          <a:p>
+            <a:pPr algn="ctr" indent="0" marL="0">
+              <a:buNone/>
+            </a:pPr>
+            <a:r>
+              <a:rPr lang="en-US" sz="660" i="1" dirty="0">
+                <a:solidFill>
+                  <a:srgbClr val="C62026"/>
+                </a:solidFill>
+                <a:latin typeface="Arial" pitchFamily="34" charset="0"/>
+                <a:ea typeface="Arial" pitchFamily="34" charset="-122"/>
+                <a:cs typeface="Arial" pitchFamily="34" charset="-120"/>
+              </a:rPr>
+              <a:t>Protects the individual</a:t>
+            </a:r>
+            <a:endParaRPr lang="en-US" sz="660" dirty="0"/>
+          </a:p>
+        </p:txBody>
+      </p:sp>
+      <p:sp>
+        <p:nvSpPr>
+          <p:cNvPr id="59" name="Text 45"/>
+          <p:cNvSpPr/>
+          <p:nvPr/>
+        </p:nvSpPr>
+        <p:spPr>
+          <a:xfrm>
+            <a:off x="566928" y="5138928"/>
+            <a:ext cx="1923288" cy="585216"/>
           </a:xfrm>
           <a:prstGeom prst="rect">
             <a:avLst/>
@@ -2591,7 +2630,7 @@
               <a:buNone/>
             </a:pPr>
             <a:r>
-              <a:rPr lang="en-US" sz="610" dirty="0">
+              <a:rPr lang="en-US" sz="680" dirty="0">
                 <a:solidFill>
                   <a:srgbClr val="000000"/>
                 </a:solidFill>
@@ -2599,22 +2638,22 @@
                 <a:ea typeface="Arial" pitchFamily="34" charset="-122"/>
                 <a:cs typeface="Arial" pitchFamily="34" charset="-120"/>
               </a:rPr>
-              <a:t>Continued participation is unsafe or breaches an authorised medical restriction.</a:t>
-            </a:r>
-            <a:endParaRPr lang="en-US" sz="610" dirty="0"/>
-          </a:p>
-        </p:txBody>
-      </p:sp>
-      <p:sp>
-        <p:nvSpPr>
-          <p:cNvPr id="59" name="Shape 45"/>
-          <p:cNvSpPr/>
-          <p:nvPr/>
-        </p:nvSpPr>
-        <p:spPr>
-          <a:xfrm>
-            <a:off x="1801368" y="4279392"/>
-            <a:ext cx="1271016" cy="1481328"/>
+              <a:t>The participant cannot continue safely because of a medical condition or safety risk.</a:t>
+            </a:r>
+            <a:endParaRPr lang="en-US" sz="680" dirty="0"/>
+          </a:p>
+        </p:txBody>
+      </p:sp>
+      <p:sp>
+        <p:nvSpPr>
+          <p:cNvPr id="60" name="Shape 46"/>
+          <p:cNvSpPr/>
+          <p:nvPr/>
+        </p:nvSpPr>
+        <p:spPr>
+          <a:xfrm>
+            <a:off x="2709672" y="4279392"/>
+            <a:ext cx="2142744" cy="1481328"/>
           </a:xfrm>
           <a:prstGeom prst="rect">
             <a:avLst/>
@@ -2632,14 +2671,14 @@
       </p:sp>
       <p:sp>
         <p:nvSpPr>
-          <p:cNvPr id="60" name="Shape 46"/>
-          <p:cNvSpPr/>
-          <p:nvPr/>
-        </p:nvSpPr>
-        <p:spPr>
-          <a:xfrm>
-            <a:off x="1856232" y="4334256"/>
-            <a:ext cx="155448" cy="155448"/>
+          <p:cNvPr id="61" name="Shape 47"/>
+          <p:cNvSpPr/>
+          <p:nvPr/>
+        </p:nvSpPr>
+        <p:spPr>
+          <a:xfrm>
+            <a:off x="2782824" y="4352544"/>
+            <a:ext cx="173736" cy="173736"/>
           </a:xfrm>
           <a:prstGeom prst="rect">
             <a:avLst/>
@@ -2652,14 +2691,14 @@
       </p:sp>
       <p:sp>
         <p:nvSpPr>
-          <p:cNvPr id="61" name="Text 47"/>
-          <p:cNvSpPr/>
-          <p:nvPr/>
-        </p:nvSpPr>
-        <p:spPr>
-          <a:xfrm>
-            <a:off x="1856232" y="4334256"/>
-            <a:ext cx="155448" cy="155448"/>
+          <p:cNvPr id="62" name="Text 48"/>
+          <p:cNvSpPr/>
+          <p:nvPr/>
+        </p:nvSpPr>
+        <p:spPr>
+          <a:xfrm>
+            <a:off x="2782824" y="4352544"/>
+            <a:ext cx="173736" cy="173736"/>
           </a:xfrm>
           <a:prstGeom prst="rect">
             <a:avLst/>
@@ -2675,7 +2714,7 @@
               <a:buNone/>
             </a:pPr>
             <a:r>
-              <a:rPr lang="en-US" sz="750" b="1" dirty="0">
+              <a:rPr lang="en-US" sz="800" b="1" dirty="0">
                 <a:solidFill>
                   <a:srgbClr val="FFFFFF"/>
                 </a:solidFill>
@@ -2685,20 +2724,20 @@
               </a:rPr>
               <a:t>2</a:t>
             </a:r>
-            <a:endParaRPr lang="en-US" sz="750" dirty="0"/>
-          </a:p>
-        </p:txBody>
-      </p:sp>
-      <p:sp>
-        <p:nvSpPr>
-          <p:cNvPr id="62" name="Shape 48"/>
-          <p:cNvSpPr/>
-          <p:nvPr/>
-        </p:nvSpPr>
-        <p:spPr>
-          <a:xfrm>
-            <a:off x="2253996" y="4352544"/>
-            <a:ext cx="365760" cy="365760"/>
+            <a:endParaRPr lang="en-US" sz="800" dirty="0"/>
+          </a:p>
+        </p:txBody>
+      </p:sp>
+      <p:sp>
+        <p:nvSpPr>
+          <p:cNvPr id="63" name="Shape 49"/>
+          <p:cNvSpPr/>
+          <p:nvPr/>
+        </p:nvSpPr>
+        <p:spPr>
+          <a:xfrm>
+            <a:off x="3589020" y="4352544"/>
+            <a:ext cx="384048" cy="384048"/>
           </a:xfrm>
           <a:prstGeom prst="ellipse">
             <a:avLst/>
@@ -2711,7 +2750,7 @@
       </p:sp>
       <p:pic>
         <p:nvPicPr>
-          <p:cNvPr id="63" name="Image 12" descr="preencoded.png">    </p:cNvPr>
+          <p:cNvPr id="64" name="Image 12" descr="preencoded.png">    </p:cNvPr>
           <p:cNvPicPr>
             <a:picLocks noChangeAspect="1"/>
           </p:cNvPicPr>
@@ -2725,8 +2764,8 @@
         </p:blipFill>
         <p:spPr>
           <a:xfrm>
-            <a:off x="2336292" y="4434840"/>
-            <a:ext cx="201168" cy="201168"/>
+            <a:off x="3675888" y="4439412"/>
+            <a:ext cx="210312" cy="210312"/>
           </a:xfrm>
           <a:prstGeom prst="rect">
             <a:avLst/>
@@ -2735,14 +2774,14 @@
       </p:pic>
       <p:sp>
         <p:nvSpPr>
-          <p:cNvPr id="64" name="Text 49"/>
-          <p:cNvSpPr/>
-          <p:nvPr/>
-        </p:nvSpPr>
-        <p:spPr>
-          <a:xfrm>
-            <a:off x="1837944" y="4754880"/>
-            <a:ext cx="1197864" cy="274320"/>
+          <p:cNvPr id="65" name="Text 50"/>
+          <p:cNvSpPr/>
+          <p:nvPr/>
+        </p:nvSpPr>
+        <p:spPr>
+          <a:xfrm>
+            <a:off x="2764536" y="4773168"/>
+            <a:ext cx="2033016" cy="182880"/>
           </a:xfrm>
           <a:prstGeom prst="rect">
             <a:avLst/>
@@ -2758,7 +2797,7 @@
               <a:buNone/>
             </a:pPr>
             <a:r>
-              <a:rPr lang="en-US" sz="700" b="1" dirty="0">
+              <a:rPr lang="en-US" sz="820" b="1" dirty="0">
                 <a:solidFill>
                   <a:srgbClr val="002516"/>
                 </a:solidFill>
@@ -2766,22 +2805,61 @@
                 <a:ea typeface="Arial" pitchFamily="34" charset="-122"/>
                 <a:cs typeface="Arial" pitchFamily="34" charset="-120"/>
               </a:rPr>
-              <a:t>Physical participation</a:t>
-            </a:r>
-            <a:endParaRPr lang="en-US" sz="700" dirty="0"/>
-          </a:p>
-        </p:txBody>
-      </p:sp>
-      <p:sp>
-        <p:nvSpPr>
-          <p:cNvPr id="65" name="Text 50"/>
-          <p:cNvSpPr/>
-          <p:nvPr/>
-        </p:nvSpPr>
-        <p:spPr>
-          <a:xfrm>
-            <a:off x="1856232" y="5029200"/>
-            <a:ext cx="1161288" cy="694944"/>
+              <a:t>Learning and assessment</a:t>
+            </a:r>
+            <a:endParaRPr lang="en-US" sz="820" dirty="0"/>
+          </a:p>
+        </p:txBody>
+      </p:sp>
+      <p:sp>
+        <p:nvSpPr>
+          <p:cNvPr id="66" name="Text 51"/>
+          <p:cNvSpPr/>
+          <p:nvPr/>
+        </p:nvSpPr>
+        <p:spPr>
+          <a:xfrm>
+            <a:off x="2764536" y="4956048"/>
+            <a:ext cx="2033016" cy="146304"/>
+          </a:xfrm>
+          <a:prstGeom prst="rect">
+            <a:avLst/>
+          </a:prstGeom>
+          <a:noFill/>
+          <a:ln/>
+        </p:spPr>
+        <p:txBody>
+          <a:bodyPr wrap="square" lIns="0" tIns="0" rIns="0" bIns="0" rtlCol="0" anchor="ctr"/>
+          <a:lstStyle/>
+          <a:p>
+            <a:pPr algn="ctr" indent="0" marL="0">
+              <a:buNone/>
+            </a:pPr>
+            <a:r>
+              <a:rPr lang="en-US" sz="660" i="1" dirty="0">
+                <a:solidFill>
+                  <a:srgbClr val="C62026"/>
+                </a:solidFill>
+                <a:latin typeface="Arial" pitchFamily="34" charset="0"/>
+                <a:ea typeface="Arial" pitchFamily="34" charset="-122"/>
+                <a:cs typeface="Arial" pitchFamily="34" charset="-120"/>
+              </a:rPr>
+              <a:t>Protects the learning environment</a:t>
+            </a:r>
+            <a:endParaRPr lang="en-US" sz="660" dirty="0"/>
+          </a:p>
+        </p:txBody>
+      </p:sp>
+      <p:sp>
+        <p:nvSpPr>
+          <p:cNvPr id="67" name="Text 52"/>
+          <p:cNvSpPr/>
+          <p:nvPr/>
+        </p:nvSpPr>
+        <p:spPr>
+          <a:xfrm>
+            <a:off x="2819400" y="5138928"/>
+            <a:ext cx="1923288" cy="585216"/>
           </a:xfrm>
           <a:prstGeom prst="rect">
             <a:avLst/>
@@ -2797,7 +2875,7 @@
               <a:buNone/>
             </a:pPr>
             <a:r>
-              <a:rPr lang="en-US" sz="610" dirty="0">
+              <a:rPr lang="en-US" sz="680" dirty="0">
                 <a:solidFill>
                   <a:srgbClr val="000000"/>
                 </a:solidFill>
@@ -2805,22 +2883,22 @@
                 <a:ea typeface="Arial" pitchFamily="34" charset="-122"/>
                 <a:cs typeface="Arial" pitchFamily="34" charset="-120"/>
               </a:rPr>
-              <a:t>Cannot safely undertake sufficient required activity despite reasonable adaptation.</a:t>
-            </a:r>
-            <a:endParaRPr lang="en-US" sz="610" dirty="0"/>
-          </a:p>
-        </p:txBody>
-      </p:sp>
-      <p:sp>
-        <p:nvSpPr>
-          <p:cNvPr id="66" name="Shape 51"/>
-          <p:cNvSpPr/>
-          <p:nvPr/>
-        </p:nvSpPr>
-        <p:spPr>
-          <a:xfrm>
-            <a:off x="3145536" y="4279392"/>
-            <a:ext cx="1271016" cy="1481328"/>
+              <a:t>Continued participation by the participant prevents the activity from providing the intended learning and assessment conditions.</a:t>
+            </a:r>
+            <a:endParaRPr lang="en-US" sz="680" dirty="0"/>
+          </a:p>
+        </p:txBody>
+      </p:sp>
+      <p:sp>
+        <p:nvSpPr>
+          <p:cNvPr id="68" name="Shape 53"/>
+          <p:cNvSpPr/>
+          <p:nvPr/>
+        </p:nvSpPr>
+        <p:spPr>
+          <a:xfrm>
+            <a:off x="4962144" y="4279392"/>
+            <a:ext cx="2142744" cy="1481328"/>
           </a:xfrm>
           <a:prstGeom prst="rect">
             <a:avLst/>
@@ -2838,14 +2916,14 @@
       </p:sp>
       <p:sp>
         <p:nvSpPr>
-          <p:cNvPr id="67" name="Shape 52"/>
-          <p:cNvSpPr/>
-          <p:nvPr/>
-        </p:nvSpPr>
-        <p:spPr>
-          <a:xfrm>
-            <a:off x="3200400" y="4334256"/>
-            <a:ext cx="155448" cy="155448"/>
+          <p:cNvPr id="69" name="Shape 54"/>
+          <p:cNvSpPr/>
+          <p:nvPr/>
+        </p:nvSpPr>
+        <p:spPr>
+          <a:xfrm>
+            <a:off x="5035296" y="4352544"/>
+            <a:ext cx="173736" cy="173736"/>
           </a:xfrm>
           <a:prstGeom prst="rect">
             <a:avLst/>
@@ -2858,14 +2936,14 @@
       </p:sp>
       <p:sp>
         <p:nvSpPr>
-          <p:cNvPr id="68" name="Text 53"/>
-          <p:cNvSpPr/>
-          <p:nvPr/>
-        </p:nvSpPr>
-        <p:spPr>
-          <a:xfrm>
-            <a:off x="3200400" y="4334256"/>
-            <a:ext cx="155448" cy="155448"/>
+          <p:cNvPr id="70" name="Text 55"/>
+          <p:cNvSpPr/>
+          <p:nvPr/>
+        </p:nvSpPr>
+        <p:spPr>
+          <a:xfrm>
+            <a:off x="5035296" y="4352544"/>
+            <a:ext cx="173736" cy="173736"/>
           </a:xfrm>
           <a:prstGeom prst="rect">
             <a:avLst/>
@@ -2881,7 +2959,7 @@
               <a:buNone/>
             </a:pPr>
             <a:r>
-              <a:rPr lang="en-US" sz="750" b="1" dirty="0">
+              <a:rPr lang="en-US" sz="800" b="1" dirty="0">
                 <a:solidFill>
                   <a:srgbClr val="FFFFFF"/>
                 </a:solidFill>
@@ -2891,20 +2969,20 @@
               </a:rPr>
               <a:t>3</a:t>
             </a:r>
-            <a:endParaRPr lang="en-US" sz="750" dirty="0"/>
-          </a:p>
-        </p:txBody>
-      </p:sp>
-      <p:sp>
-        <p:nvSpPr>
-          <p:cNvPr id="69" name="Shape 54"/>
-          <p:cNvSpPr/>
-          <p:nvPr/>
-        </p:nvSpPr>
-        <p:spPr>
-          <a:xfrm>
-            <a:off x="3598164" y="4352544"/>
-            <a:ext cx="365760" cy="365760"/>
+            <a:endParaRPr lang="en-US" sz="800" dirty="0"/>
+          </a:p>
+        </p:txBody>
+      </p:sp>
+      <p:sp>
+        <p:nvSpPr>
+          <p:cNvPr id="71" name="Shape 56"/>
+          <p:cNvSpPr/>
+          <p:nvPr/>
+        </p:nvSpPr>
+        <p:spPr>
+          <a:xfrm>
+            <a:off x="5841492" y="4352544"/>
+            <a:ext cx="384048" cy="384048"/>
           </a:xfrm>
           <a:prstGeom prst="ellipse">
             <a:avLst/>
@@ -2917,7 +2995,7 @@
       </p:sp>
       <p:pic>
         <p:nvPicPr>
-          <p:cNvPr id="70" name="Image 13" descr="preencoded.png">    </p:cNvPr>
+          <p:cNvPr id="72" name="Image 13" descr="preencoded.png">    </p:cNvPr>
           <p:cNvPicPr>
             <a:picLocks noChangeAspect="1"/>
           </p:cNvPicPr>
@@ -2931,8 +3009,8 @@
         </p:blipFill>
         <p:spPr>
           <a:xfrm>
-            <a:off x="3680460" y="4434840"/>
-            <a:ext cx="201168" cy="201168"/>
+            <a:off x="5928360" y="4439412"/>
+            <a:ext cx="210312" cy="210312"/>
           </a:xfrm>
           <a:prstGeom prst="rect">
             <a:avLst/>
@@ -2941,14 +3019,14 @@
       </p:pic>
       <p:sp>
         <p:nvSpPr>
-          <p:cNvPr id="71" name="Text 55"/>
-          <p:cNvSpPr/>
-          <p:nvPr/>
-        </p:nvSpPr>
-        <p:spPr>
-          <a:xfrm>
-            <a:off x="3182112" y="4754880"/>
-            <a:ext cx="1197864" cy="274320"/>
+          <p:cNvPr id="73" name="Text 57"/>
+          <p:cNvSpPr/>
+          <p:nvPr/>
+        </p:nvSpPr>
+        <p:spPr>
+          <a:xfrm>
+            <a:off x="5017008" y="4773168"/>
+            <a:ext cx="2033016" cy="182880"/>
           </a:xfrm>
           <a:prstGeom prst="rect">
             <a:avLst/>
@@ -2964,7 +3042,7 @@
               <a:buNone/>
             </a:pPr>
             <a:r>
-              <a:rPr lang="en-US" sz="700" b="1" dirty="0">
+              <a:rPr lang="en-US" sz="820" b="1" dirty="0">
                 <a:solidFill>
                   <a:srgbClr val="002516"/>
                 </a:solidFill>
@@ -2972,7 +3050,222 @@
                 <a:ea typeface="Arial" pitchFamily="34" charset="-122"/>
                 <a:cs typeface="Arial" pitchFamily="34" charset="-120"/>
               </a:rPr>
-              <a:t>Learning and assessment validity</a:t>
+              <a:t>Conduct</a:t>
+            </a:r>
+            <a:endParaRPr lang="en-US" sz="820" dirty="0"/>
+          </a:p>
+        </p:txBody>
+      </p:sp>
+      <p:sp>
+        <p:nvSpPr>
+          <p:cNvPr id="74" name="Text 58"/>
+          <p:cNvSpPr/>
+          <p:nvPr/>
+        </p:nvSpPr>
+        <p:spPr>
+          <a:xfrm>
+            <a:off x="5017008" y="4956048"/>
+            <a:ext cx="2033016" cy="146304"/>
+          </a:xfrm>
+          <a:prstGeom prst="rect">
+            <a:avLst/>
+          </a:prstGeom>
+          <a:noFill/>
+          <a:ln/>
+        </p:spPr>
+        <p:txBody>
+          <a:bodyPr wrap="square" lIns="0" tIns="0" rIns="0" bIns="0" rtlCol="0" anchor="ctr"/>
+          <a:lstStyle/>
+          <a:p>
+            <a:pPr algn="ctr" indent="0" marL="0">
+              <a:buNone/>
+            </a:pPr>
+            <a:r>
+              <a:rPr lang="en-US" sz="660" i="1" dirty="0">
+                <a:solidFill>
+                  <a:srgbClr val="C62026"/>
+                </a:solidFill>
+                <a:latin typeface="Arial" pitchFamily="34" charset="0"/>
+                <a:ea typeface="Arial" pitchFamily="34" charset="-122"/>
+                <a:cs typeface="Arial" pitchFamily="34" charset="-120"/>
+              </a:rPr>
+              <a:t>Protects the activity</a:t>
+            </a:r>
+            <a:endParaRPr lang="en-US" sz="660" dirty="0"/>
+          </a:p>
+        </p:txBody>
+      </p:sp>
+      <p:sp>
+        <p:nvSpPr>
+          <p:cNvPr id="75" name="Text 59"/>
+          <p:cNvSpPr/>
+          <p:nvPr/>
+        </p:nvSpPr>
+        <p:spPr>
+          <a:xfrm>
+            <a:off x="5071872" y="5138928"/>
+            <a:ext cx="1923288" cy="585216"/>
+          </a:xfrm>
+          <a:prstGeom prst="rect">
+            <a:avLst/>
+          </a:prstGeom>
+          <a:noFill/>
+          <a:ln/>
+        </p:spPr>
+        <p:txBody>
+          <a:bodyPr wrap="square" lIns="0" tIns="0" rIns="0" bIns="0" rtlCol="0" anchor="t"/>
+          <a:lstStyle/>
+          <a:p>
+            <a:pPr algn="ctr" indent="0" marL="0">
+              <a:buNone/>
+            </a:pPr>
+            <a:r>
+              <a:rPr lang="en-US" sz="680" dirty="0">
+                <a:solidFill>
+                  <a:srgbClr val="000000"/>
+                </a:solidFill>
+                <a:latin typeface="Arial" pitchFamily="34" charset="0"/>
+                <a:ea typeface="Arial" pitchFamily="34" charset="-122"/>
+                <a:cs typeface="Arial" pitchFamily="34" charset="-120"/>
+              </a:rPr>
+              <a:t>The participant refuses to follow lawful instructions or behaves in a way that prevents the safe and effective conduct of the activity.</a:t>
+            </a:r>
+            <a:endParaRPr lang="en-US" sz="680" dirty="0"/>
+          </a:p>
+        </p:txBody>
+      </p:sp>
+      <p:sp>
+        <p:nvSpPr>
+          <p:cNvPr id="76" name="Shape 60"/>
+          <p:cNvSpPr/>
+          <p:nvPr/>
+        </p:nvSpPr>
+        <p:spPr>
+          <a:xfrm>
+            <a:off x="457200" y="5870448"/>
+            <a:ext cx="6647688" cy="914400"/>
+          </a:xfrm>
+          <a:prstGeom prst="rect">
+            <a:avLst/>
+          </a:prstGeom>
+          <a:solidFill>
+            <a:srgbClr val="3A4B00"/>
+          </a:solidFill>
+          <a:ln/>
+        </p:spPr>
+      </p:sp>
+      <p:sp>
+        <p:nvSpPr>
+          <p:cNvPr id="77" name="Text 61"/>
+          <p:cNvSpPr/>
+          <p:nvPr/>
+        </p:nvSpPr>
+        <p:spPr>
+          <a:xfrm>
+            <a:off x="457200" y="5916168"/>
+            <a:ext cx="6647688" cy="164592"/>
+          </a:xfrm>
+          <a:prstGeom prst="rect">
+            <a:avLst/>
+          </a:prstGeom>
+          <a:noFill/>
+          <a:ln/>
+        </p:spPr>
+        <p:txBody>
+          <a:bodyPr wrap="square" lIns="0" tIns="0" rIns="0" bIns="0" rtlCol="0" anchor="ctr"/>
+          <a:lstStyle/>
+          <a:p>
+            <a:pPr algn="ctr" indent="0" marL="0">
+              <a:buNone/>
+            </a:pPr>
+            <a:r>
+              <a:rPr lang="en-US" sz="860" b="1" spc="200" kern="0" dirty="0">
+                <a:solidFill>
+                  <a:srgbClr val="CDD2B7"/>
+                </a:solidFill>
+                <a:latin typeface="Arial" pitchFamily="34" charset="0"/>
+                <a:ea typeface="Arial" pitchFamily="34" charset="-122"/>
+                <a:cs typeface="Arial" pitchFamily="34" charset="-120"/>
+              </a:rPr>
+              <a:t>4. THE WITHDRAWAL TEST</a:t>
+            </a:r>
+            <a:endParaRPr lang="en-US" sz="860" dirty="0"/>
+          </a:p>
+        </p:txBody>
+      </p:sp>
+      <p:sp>
+        <p:nvSpPr>
+          <p:cNvPr id="78" name="Text 62"/>
+          <p:cNvSpPr/>
+          <p:nvPr/>
+        </p:nvSpPr>
+        <p:spPr>
+          <a:xfrm>
+            <a:off x="777240" y="6089904"/>
+            <a:ext cx="6007608" cy="475488"/>
+          </a:xfrm>
+          <a:prstGeom prst="rect">
+            <a:avLst/>
+          </a:prstGeom>
+          <a:noFill/>
+          <a:ln/>
+        </p:spPr>
+        <p:txBody>
+          <a:bodyPr wrap="square" lIns="0" tIns="0" rIns="0" bIns="0" rtlCol="0" anchor="t"/>
+          <a:lstStyle/>
+          <a:p>
+            <a:pPr algn="ctr" indent="0" marL="0">
+              <a:buNone/>
+            </a:pPr>
+            <a:r>
+              <a:rPr lang="en-US" sz="800" b="1" i="1" dirty="0">
+                <a:solidFill>
+                  <a:srgbClr val="FFFFFF"/>
+                </a:solidFill>
+                <a:latin typeface="Arial" pitchFamily="34" charset="0"/>
+                <a:ea typeface="Arial" pitchFamily="34" charset="-122"/>
+                <a:cs typeface="Arial" pitchFamily="34" charset="-120"/>
+              </a:rPr>
+              <a:t>What specific safety requirement, required activity, or approved learning or assessment objective can no longer be safely or meaningfully achieved, and what evidence shows that reasonable coaching, team adaptation or authorised adjustment will not restore the necessary conditions?</a:t>
+            </a:r>
+            <a:endParaRPr lang="en-US" sz="800" dirty="0"/>
+          </a:p>
+        </p:txBody>
+      </p:sp>
+      <p:sp>
+        <p:nvSpPr>
+          <p:cNvPr id="79" name="Text 63"/>
+          <p:cNvSpPr/>
+          <p:nvPr/>
+        </p:nvSpPr>
+        <p:spPr>
+          <a:xfrm>
+            <a:off x="777240" y="6565392"/>
+            <a:ext cx="6007608" cy="164592"/>
+          </a:xfrm>
+          <a:prstGeom prst="rect">
+            <a:avLst/>
+          </a:prstGeom>
+          <a:noFill/>
+          <a:ln/>
+        </p:spPr>
+        <p:txBody>
+          <a:bodyPr wrap="square" lIns="0" tIns="0" rIns="0" bIns="0" rtlCol="0" anchor="ctr"/>
+          <a:lstStyle/>
+          <a:p>
+            <a:pPr algn="ctr" indent="0" marL="0">
+              <a:buNone/>
+            </a:pPr>
+            <a:r>
+              <a:rPr lang="en-US" sz="700" i="1" dirty="0">
+                <a:solidFill>
+                  <a:srgbClr val="CDD2B7"/>
+                </a:solidFill>
+                <a:latin typeface="Arial" pitchFamily="34" charset="0"/>
+                <a:ea typeface="Arial" pitchFamily="34" charset="-122"/>
+                <a:cs typeface="Arial" pitchFamily="34" charset="-120"/>
+              </a:rPr>
+              <a:t>A slower team, greater workload or frustration alone will not normally meet this threshold.</a:t>
             </a:r>
             <a:endParaRPr lang="en-US" sz="700" dirty="0"/>
           </a:p>
@@ -2980,14 +3273,175 @@
       </p:sp>
       <p:sp>
         <p:nvSpPr>
-          <p:cNvPr id="72" name="Text 56"/>
-          <p:cNvSpPr/>
-          <p:nvPr/>
-        </p:nvSpPr>
-        <p:spPr>
-          <a:xfrm>
-            <a:off x="3200400" y="5029200"/>
-            <a:ext cx="1161288" cy="694944"/>
+          <p:cNvPr id="80" name="Shape 64"/>
+          <p:cNvSpPr/>
+          <p:nvPr/>
+        </p:nvSpPr>
+        <p:spPr>
+          <a:xfrm>
+            <a:off x="457200" y="6894576"/>
+            <a:ext cx="6647688" cy="256032"/>
+          </a:xfrm>
+          <a:prstGeom prst="rect">
+            <a:avLst/>
+          </a:prstGeom>
+          <a:solidFill>
+            <a:srgbClr val="002516"/>
+          </a:solidFill>
+          <a:ln/>
+        </p:spPr>
+      </p:sp>
+      <p:sp>
+        <p:nvSpPr>
+          <p:cNvPr id="81" name="Text 65"/>
+          <p:cNvSpPr/>
+          <p:nvPr/>
+        </p:nvSpPr>
+        <p:spPr>
+          <a:xfrm>
+            <a:off x="457200" y="6894576"/>
+            <a:ext cx="6647688" cy="256032"/>
+          </a:xfrm>
+          <a:prstGeom prst="rect">
+            <a:avLst/>
+          </a:prstGeom>
+          <a:noFill/>
+          <a:ln/>
+        </p:spPr>
+        <p:txBody>
+          <a:bodyPr wrap="square" lIns="0" tIns="0" rIns="0" bIns="0" rtlCol="0" anchor="ctr"/>
+          <a:lstStyle/>
+          <a:p>
+            <a:pPr algn="ctr" indent="0" marL="0">
+              <a:buNone/>
+            </a:pPr>
+            <a:r>
+              <a:rPr lang="en-US" sz="860" b="1" spc="150" kern="0" dirty="0">
+                <a:solidFill>
+                  <a:srgbClr val="FFFFFF"/>
+                </a:solidFill>
+                <a:latin typeface="Arial" pitchFamily="34" charset="0"/>
+                <a:ea typeface="Arial" pitchFamily="34" charset="-122"/>
+                <a:cs typeface="Arial" pitchFamily="34" charset="-120"/>
+              </a:rPr>
+              <a:t>5. DECISION PROCESS</a:t>
+            </a:r>
+            <a:endParaRPr lang="en-US" sz="860" dirty="0"/>
+          </a:p>
+        </p:txBody>
+      </p:sp>
+      <p:sp>
+        <p:nvSpPr>
+          <p:cNvPr id="82" name="Shape 66"/>
+          <p:cNvSpPr/>
+          <p:nvPr/>
+        </p:nvSpPr>
+        <p:spPr>
+          <a:xfrm>
+            <a:off x="457200" y="7260336"/>
+            <a:ext cx="310896" cy="310896"/>
+          </a:xfrm>
+          <a:prstGeom prst="ellipse">
+            <a:avLst/>
+          </a:prstGeom>
+          <a:solidFill>
+            <a:srgbClr val="FFFFFF"/>
+          </a:solidFill>
+          <a:ln w="15875">
+            <a:solidFill>
+              <a:srgbClr val="002516"/>
+            </a:solidFill>
+            <a:prstDash val="solid"/>
+          </a:ln>
+        </p:spPr>
+      </p:sp>
+      <p:pic>
+        <p:nvPicPr>
+          <p:cNvPr id="83" name="Image 14" descr="preencoded.png">    </p:cNvPr>
+          <p:cNvPicPr>
+            <a:picLocks noChangeAspect="1"/>
+          </p:cNvPicPr>
+          <p:nvPr/>
+        </p:nvPicPr>
+        <p:blipFill>
+          <a:blip r:embed="rId15"/>
+          <a:stretch>
+            <a:fillRect/>
+          </a:stretch>
+        </p:blipFill>
+        <p:spPr>
+          <a:xfrm>
+            <a:off x="521208" y="7324344"/>
+            <a:ext cx="182880" cy="182880"/>
+          </a:xfrm>
+          <a:prstGeom prst="rect">
+            <a:avLst/>
+          </a:prstGeom>
+        </p:spPr>
+      </p:pic>
+      <p:sp>
+        <p:nvSpPr>
+          <p:cNvPr id="84" name="Text 67"/>
+          <p:cNvSpPr/>
+          <p:nvPr/>
+        </p:nvSpPr>
+        <p:spPr>
+          <a:xfrm>
+            <a:off x="822960" y="7242048"/>
+            <a:ext cx="1691640" cy="164592"/>
+          </a:xfrm>
+          <a:prstGeom prst="rect">
+            <a:avLst/>
+          </a:prstGeom>
+          <a:noFill/>
+          <a:ln/>
+        </p:spPr>
+        <p:txBody>
+          <a:bodyPr wrap="square" lIns="0" tIns="0" rIns="0" bIns="0" rtlCol="0" anchor="ctr"/>
+          <a:lstStyle/>
+          <a:p>
+            <a:pPr algn="l" indent="0" marL="0">
+              <a:buNone/>
+            </a:pPr>
+            <a:r>
+              <a:rPr lang="en-US" sz="780" b="1" dirty="0">
+                <a:solidFill>
+                  <a:srgbClr val="C62026"/>
+                </a:solidFill>
+                <a:latin typeface="Arial" pitchFamily="34" charset="0"/>
+                <a:ea typeface="Arial" pitchFamily="34" charset="-122"/>
+                <a:cs typeface="Arial" pitchFamily="34" charset="-120"/>
+              </a:rPr>
+              <a:t>1.  </a:t>
+            </a:r>
+            <a:pPr algn="l" indent="0" marL="0">
+              <a:buNone/>
+            </a:pPr>
+            <a:r>
+              <a:rPr lang="en-US" sz="780" b="1" dirty="0">
+                <a:solidFill>
+                  <a:srgbClr val="002516"/>
+                </a:solidFill>
+                <a:latin typeface="Arial" pitchFamily="34" charset="0"/>
+                <a:ea typeface="Arial" pitchFamily="34" charset="-122"/>
+                <a:cs typeface="Arial" pitchFamily="34" charset="-120"/>
+              </a:rPr>
+              <a:t>Observe and enable</a:t>
+            </a:r>
+            <a:endParaRPr lang="en-US" sz="780" dirty="0"/>
+          </a:p>
+        </p:txBody>
+      </p:sp>
+      <p:sp>
+        <p:nvSpPr>
+          <p:cNvPr id="85" name="Text 68"/>
+          <p:cNvSpPr/>
+          <p:nvPr/>
+        </p:nvSpPr>
+        <p:spPr>
+          <a:xfrm>
+            <a:off x="822960" y="7406640"/>
+            <a:ext cx="1673352" cy="603504"/>
           </a:xfrm>
           <a:prstGeom prst="rect">
             <a:avLst/>
@@ -2999,11 +3453,191 @@
           <a:bodyPr wrap="square" lIns="0" tIns="0" rIns="0" bIns="0" rtlCol="0" anchor="t"/>
           <a:lstStyle/>
           <a:p>
+            <a:pPr algn="l" indent="0" marL="0">
+              <a:buNone/>
+            </a:pPr>
+            <a:r>
+              <a:rPr lang="en-US" sz="630" dirty="0">
+                <a:solidFill>
+                  <a:srgbClr val="000000"/>
+                </a:solidFill>
+                <a:latin typeface="Arial" pitchFamily="34" charset="0"/>
+                <a:ea typeface="Arial" pitchFamily="34" charset="-122"/>
+                <a:cs typeface="Arial" pitchFamily="34" charset="-120"/>
+              </a:rPr>
+              <a:t>Identify the issue; allow the team a reasonable opportunity to recognise, respond and manage it.</a:t>
+            </a:r>
+            <a:endParaRPr lang="en-US" sz="630" dirty="0"/>
+          </a:p>
+        </p:txBody>
+      </p:sp>
+      <p:sp>
+        <p:nvSpPr>
+          <p:cNvPr id="86" name="Text 69"/>
+          <p:cNvSpPr/>
+          <p:nvPr/>
+        </p:nvSpPr>
+        <p:spPr>
+          <a:xfrm>
+            <a:off x="2478024" y="7296912"/>
+            <a:ext cx="310896" cy="219456"/>
+          </a:xfrm>
+          <a:prstGeom prst="rect">
+            <a:avLst/>
+          </a:prstGeom>
+          <a:noFill/>
+          <a:ln/>
+        </p:spPr>
+        <p:txBody>
+          <a:bodyPr wrap="square" lIns="0" tIns="0" rIns="0" bIns="0" rtlCol="0" anchor="ctr"/>
+          <a:lstStyle/>
+          <a:p>
             <a:pPr algn="ctr" indent="0" marL="0">
               <a:buNone/>
             </a:pPr>
             <a:r>
-              <a:rPr lang="en-US" sz="610" dirty="0">
+              <a:rPr lang="en-US" sz="1000" b="1" dirty="0">
+                <a:solidFill>
+                  <a:srgbClr val="C62026"/>
+                </a:solidFill>
+                <a:latin typeface="Arial" pitchFamily="34" charset="0"/>
+                <a:ea typeface="Arial" pitchFamily="34" charset="-122"/>
+                <a:cs typeface="Arial" pitchFamily="34" charset="-120"/>
+              </a:rPr>
+              <a:t>►</a:t>
+            </a:r>
+            <a:endParaRPr lang="en-US" sz="1000" dirty="0"/>
+          </a:p>
+        </p:txBody>
+      </p:sp>
+      <p:sp>
+        <p:nvSpPr>
+          <p:cNvPr id="87" name="Shape 70"/>
+          <p:cNvSpPr/>
+          <p:nvPr/>
+        </p:nvSpPr>
+        <p:spPr>
+          <a:xfrm>
+            <a:off x="2752344" y="7260336"/>
+            <a:ext cx="310896" cy="310896"/>
+          </a:xfrm>
+          <a:prstGeom prst="ellipse">
+            <a:avLst/>
+          </a:prstGeom>
+          <a:solidFill>
+            <a:srgbClr val="FFFFFF"/>
+          </a:solidFill>
+          <a:ln w="15875">
+            <a:solidFill>
+              <a:srgbClr val="002516"/>
+            </a:solidFill>
+            <a:prstDash val="solid"/>
+          </a:ln>
+        </p:spPr>
+      </p:sp>
+      <p:pic>
+        <p:nvPicPr>
+          <p:cNvPr id="88" name="Image 15" descr="preencoded.png">    </p:cNvPr>
+          <p:cNvPicPr>
+            <a:picLocks noChangeAspect="1"/>
+          </p:cNvPicPr>
+          <p:nvPr/>
+        </p:nvPicPr>
+        <p:blipFill>
+          <a:blip r:embed="rId16"/>
+          <a:stretch>
+            <a:fillRect/>
+          </a:stretch>
+        </p:blipFill>
+        <p:spPr>
+          <a:xfrm>
+            <a:off x="2816352" y="7324344"/>
+            <a:ext cx="182880" cy="182880"/>
+          </a:xfrm>
+          <a:prstGeom prst="rect">
+            <a:avLst/>
+          </a:prstGeom>
+        </p:spPr>
+      </p:pic>
+      <p:sp>
+        <p:nvSpPr>
+          <p:cNvPr id="89" name="Text 71"/>
+          <p:cNvSpPr/>
+          <p:nvPr/>
+        </p:nvSpPr>
+        <p:spPr>
+          <a:xfrm>
+            <a:off x="3118104" y="7242048"/>
+            <a:ext cx="1691640" cy="164592"/>
+          </a:xfrm>
+          <a:prstGeom prst="rect">
+            <a:avLst/>
+          </a:prstGeom>
+          <a:noFill/>
+          <a:ln/>
+        </p:spPr>
+        <p:txBody>
+          <a:bodyPr wrap="square" lIns="0" tIns="0" rIns="0" bIns="0" rtlCol="0" anchor="ctr"/>
+          <a:lstStyle/>
+          <a:p>
+            <a:pPr algn="l" indent="0" marL="0">
+              <a:buNone/>
+            </a:pPr>
+            <a:r>
+              <a:rPr lang="en-US" sz="780" b="1" dirty="0">
+                <a:solidFill>
+                  <a:srgbClr val="C62026"/>
+                </a:solidFill>
+                <a:latin typeface="Arial" pitchFamily="34" charset="0"/>
+                <a:ea typeface="Arial" pitchFamily="34" charset="-122"/>
+                <a:cs typeface="Arial" pitchFamily="34" charset="-120"/>
+              </a:rPr>
+              <a:t>2.  </a:t>
+            </a:r>
+            <a:pPr algn="l" indent="0" marL="0">
+              <a:buNone/>
+            </a:pPr>
+            <a:r>
+              <a:rPr lang="en-US" sz="780" b="1" dirty="0">
+                <a:solidFill>
+                  <a:srgbClr val="002516"/>
+                </a:solidFill>
+                <a:latin typeface="Arial" pitchFamily="34" charset="0"/>
+                <a:ea typeface="Arial" pitchFamily="34" charset="-122"/>
+                <a:cs typeface="Arial" pitchFamily="34" charset="-120"/>
+              </a:rPr>
+              <a:t>Intervene and reassess</a:t>
+            </a:r>
+            <a:endParaRPr lang="en-US" sz="780" dirty="0"/>
+          </a:p>
+        </p:txBody>
+      </p:sp>
+      <p:sp>
+        <p:nvSpPr>
+          <p:cNvPr id="90" name="Text 72"/>
+          <p:cNvSpPr/>
+          <p:nvPr/>
+        </p:nvSpPr>
+        <p:spPr>
+          <a:xfrm>
+            <a:off x="3118104" y="7406640"/>
+            <a:ext cx="1673352" cy="603504"/>
+          </a:xfrm>
+          <a:prstGeom prst="rect">
+            <a:avLst/>
+          </a:prstGeom>
+          <a:noFill/>
+          <a:ln/>
+        </p:spPr>
+        <p:txBody>
+          <a:bodyPr wrap="square" lIns="0" tIns="0" rIns="0" bIns="0" rtlCol="0" anchor="t"/>
+          <a:lstStyle/>
+          <a:p>
+            <a:pPr algn="l" indent="0" marL="0">
+              <a:buNone/>
+            </a:pPr>
+            <a:r>
+              <a:rPr lang="en-US" sz="630" dirty="0">
                 <a:solidFill>
                   <a:srgbClr val="000000"/>
                 </a:solidFill>
@@ -3011,22 +3645,480 @@
                 <a:ea typeface="Arial" pitchFamily="34" charset="-122"/>
                 <a:cs typeface="Arial" pitchFamily="34" charset="-120"/>
               </a:rPr>
-              <a:t>Can no longer be meaningfully exposed to, develop against, or be assessed against approved objectives.</a:t>
-            </a:r>
-            <a:endParaRPr lang="en-US" sz="610" dirty="0"/>
-          </a:p>
-        </p:txBody>
-      </p:sp>
-      <p:sp>
-        <p:nvSpPr>
-          <p:cNvPr id="73" name="Shape 57"/>
-          <p:cNvSpPr/>
-          <p:nvPr/>
-        </p:nvSpPr>
-        <p:spPr>
-          <a:xfrm>
-            <a:off x="4489704" y="4279392"/>
-            <a:ext cx="1271016" cy="1481328"/>
+              <a:t>Provide clear feedback; apply authorised adjustments; reassess whether safe and meaningful participation remains achievable.</a:t>
+            </a:r>
+            <a:endParaRPr lang="en-US" sz="630" dirty="0"/>
+          </a:p>
+        </p:txBody>
+      </p:sp>
+      <p:sp>
+        <p:nvSpPr>
+          <p:cNvPr id="91" name="Text 73"/>
+          <p:cNvSpPr/>
+          <p:nvPr/>
+        </p:nvSpPr>
+        <p:spPr>
+          <a:xfrm>
+            <a:off x="4773168" y="7296912"/>
+            <a:ext cx="310896" cy="219456"/>
+          </a:xfrm>
+          <a:prstGeom prst="rect">
+            <a:avLst/>
+          </a:prstGeom>
+          <a:noFill/>
+          <a:ln/>
+        </p:spPr>
+        <p:txBody>
+          <a:bodyPr wrap="square" lIns="0" tIns="0" rIns="0" bIns="0" rtlCol="0" anchor="ctr"/>
+          <a:lstStyle/>
+          <a:p>
+            <a:pPr algn="ctr" indent="0" marL="0">
+              <a:buNone/>
+            </a:pPr>
+            <a:r>
+              <a:rPr lang="en-US" sz="1000" b="1" dirty="0">
+                <a:solidFill>
+                  <a:srgbClr val="C62026"/>
+                </a:solidFill>
+                <a:latin typeface="Arial" pitchFamily="34" charset="0"/>
+                <a:ea typeface="Arial" pitchFamily="34" charset="-122"/>
+                <a:cs typeface="Arial" pitchFamily="34" charset="-120"/>
+              </a:rPr>
+              <a:t>►</a:t>
+            </a:r>
+            <a:endParaRPr lang="en-US" sz="1000" dirty="0"/>
+          </a:p>
+        </p:txBody>
+      </p:sp>
+      <p:sp>
+        <p:nvSpPr>
+          <p:cNvPr id="92" name="Shape 74"/>
+          <p:cNvSpPr/>
+          <p:nvPr/>
+        </p:nvSpPr>
+        <p:spPr>
+          <a:xfrm>
+            <a:off x="5047488" y="7260336"/>
+            <a:ext cx="310896" cy="310896"/>
+          </a:xfrm>
+          <a:prstGeom prst="ellipse">
+            <a:avLst/>
+          </a:prstGeom>
+          <a:solidFill>
+            <a:srgbClr val="FFFFFF"/>
+          </a:solidFill>
+          <a:ln w="15875">
+            <a:solidFill>
+              <a:srgbClr val="002516"/>
+            </a:solidFill>
+            <a:prstDash val="solid"/>
+          </a:ln>
+        </p:spPr>
+      </p:sp>
+      <p:pic>
+        <p:nvPicPr>
+          <p:cNvPr id="93" name="Image 16" descr="preencoded.png">    </p:cNvPr>
+          <p:cNvPicPr>
+            <a:picLocks noChangeAspect="1"/>
+          </p:cNvPicPr>
+          <p:nvPr/>
+        </p:nvPicPr>
+        <p:blipFill>
+          <a:blip r:embed="rId17"/>
+          <a:stretch>
+            <a:fillRect/>
+          </a:stretch>
+        </p:blipFill>
+        <p:spPr>
+          <a:xfrm>
+            <a:off x="5111496" y="7324344"/>
+            <a:ext cx="182880" cy="182880"/>
+          </a:xfrm>
+          <a:prstGeom prst="rect">
+            <a:avLst/>
+          </a:prstGeom>
+        </p:spPr>
+      </p:pic>
+      <p:sp>
+        <p:nvSpPr>
+          <p:cNvPr id="94" name="Text 75"/>
+          <p:cNvSpPr/>
+          <p:nvPr/>
+        </p:nvSpPr>
+        <p:spPr>
+          <a:xfrm>
+            <a:off x="5413248" y="7242048"/>
+            <a:ext cx="1691640" cy="164592"/>
+          </a:xfrm>
+          <a:prstGeom prst="rect">
+            <a:avLst/>
+          </a:prstGeom>
+          <a:noFill/>
+          <a:ln/>
+        </p:spPr>
+        <p:txBody>
+          <a:bodyPr wrap="square" lIns="0" tIns="0" rIns="0" bIns="0" rtlCol="0" anchor="ctr"/>
+          <a:lstStyle/>
+          <a:p>
+            <a:pPr algn="l" indent="0" marL="0">
+              <a:buNone/>
+            </a:pPr>
+            <a:r>
+              <a:rPr lang="en-US" sz="780" b="1" dirty="0">
+                <a:solidFill>
+                  <a:srgbClr val="C62026"/>
+                </a:solidFill>
+                <a:latin typeface="Arial" pitchFamily="34" charset="0"/>
+                <a:ea typeface="Arial" pitchFamily="34" charset="-122"/>
+                <a:cs typeface="Arial" pitchFamily="34" charset="-120"/>
+              </a:rPr>
+              <a:t>3.  </a:t>
+            </a:r>
+            <a:pPr algn="l" indent="0" marL="0">
+              <a:buNone/>
+            </a:pPr>
+            <a:r>
+              <a:rPr lang="en-US" sz="780" b="1" dirty="0">
+                <a:solidFill>
+                  <a:srgbClr val="002516"/>
+                </a:solidFill>
+                <a:latin typeface="Arial" pitchFamily="34" charset="0"/>
+                <a:ea typeface="Arial" pitchFamily="34" charset="-122"/>
+                <a:cs typeface="Arial" pitchFamily="34" charset="-120"/>
+              </a:rPr>
+              <a:t>Decide and record</a:t>
+            </a:r>
+            <a:endParaRPr lang="en-US" sz="780" dirty="0"/>
+          </a:p>
+        </p:txBody>
+      </p:sp>
+      <p:sp>
+        <p:nvSpPr>
+          <p:cNvPr id="95" name="Text 76"/>
+          <p:cNvSpPr/>
+          <p:nvPr/>
+        </p:nvSpPr>
+        <p:spPr>
+          <a:xfrm>
+            <a:off x="5413248" y="7406640"/>
+            <a:ext cx="1673352" cy="603504"/>
+          </a:xfrm>
+          <a:prstGeom prst="rect">
+            <a:avLst/>
+          </a:prstGeom>
+          <a:noFill/>
+          <a:ln/>
+        </p:spPr>
+        <p:txBody>
+          <a:bodyPr wrap="square" lIns="0" tIns="0" rIns="0" bIns="0" rtlCol="0" anchor="t"/>
+          <a:lstStyle/>
+          <a:p>
+            <a:pPr algn="l" indent="0" marL="0">
+              <a:buNone/>
+            </a:pPr>
+            <a:r>
+              <a:rPr lang="en-US" sz="630" dirty="0">
+                <a:solidFill>
+                  <a:srgbClr val="000000"/>
+                </a:solidFill>
+                <a:latin typeface="Arial" pitchFamily="34" charset="0"/>
+                <a:ea typeface="Arial" pitchFamily="34" charset="-122"/>
+                <a:cs typeface="Arial" pitchFamily="34" charset="-120"/>
+              </a:rPr>
+              <a:t>If withdrawal remains necessary, staff provide observations and a recommendation to the designated uniformed authority.</a:t>
+            </a:r>
+            <a:endParaRPr lang="en-US" sz="630" dirty="0"/>
+          </a:p>
+        </p:txBody>
+      </p:sp>
+      <p:sp>
+        <p:nvSpPr>
+          <p:cNvPr id="96" name="Shape 77"/>
+          <p:cNvSpPr/>
+          <p:nvPr/>
+        </p:nvSpPr>
+        <p:spPr>
+          <a:xfrm>
+            <a:off x="457200" y="8065008"/>
+            <a:ext cx="6647688" cy="292608"/>
+          </a:xfrm>
+          <a:prstGeom prst="rect">
+            <a:avLst/>
+          </a:prstGeom>
+          <a:solidFill>
+            <a:srgbClr val="CDD2B7">
+              <a:alpha val="45000"/>
+            </a:srgbClr>
+          </a:solidFill>
+          <a:ln/>
+        </p:spPr>
+      </p:sp>
+      <p:sp>
+        <p:nvSpPr>
+          <p:cNvPr id="97" name="Text 78"/>
+          <p:cNvSpPr/>
+          <p:nvPr/>
+        </p:nvSpPr>
+        <p:spPr>
+          <a:xfrm>
+            <a:off x="594360" y="8065008"/>
+            <a:ext cx="6373368" cy="292608"/>
+          </a:xfrm>
+          <a:prstGeom prst="rect">
+            <a:avLst/>
+          </a:prstGeom>
+          <a:noFill/>
+          <a:ln/>
+        </p:spPr>
+        <p:txBody>
+          <a:bodyPr wrap="square" lIns="0" tIns="0" rIns="0" bIns="0" rtlCol="0" anchor="ctr"/>
+          <a:lstStyle/>
+          <a:p>
+            <a:pPr algn="l" indent="0" marL="0">
+              <a:buNone/>
+            </a:pPr>
+            <a:r>
+              <a:rPr lang="en-US" sz="740" b="1" dirty="0">
+                <a:solidFill>
+                  <a:srgbClr val="002516"/>
+                </a:solidFill>
+                <a:latin typeface="Arial" pitchFamily="34" charset="0"/>
+                <a:ea typeface="Arial" pitchFamily="34" charset="-122"/>
+                <a:cs typeface="Arial" pitchFamily="34" charset="-120"/>
+              </a:rPr>
+              <a:t>Non-immediate withdrawal:  </a:t>
+            </a:r>
+            <a:pPr algn="l" indent="0" marL="0">
+              <a:buNone/>
+            </a:pPr>
+            <a:r>
+              <a:rPr lang="en-US" sz="740" dirty="0">
+                <a:solidFill>
+                  <a:srgbClr val="000000"/>
+                </a:solidFill>
+                <a:latin typeface="Arial" pitchFamily="34" charset="0"/>
+                <a:ea typeface="Arial" pitchFamily="34" charset="-122"/>
+                <a:cs typeface="Arial" pitchFamily="34" charset="-120"/>
+              </a:rPr>
+              <a:t>CI NZALC and CI NCO School discuss the case; CI NZALC recommends withdrawal to COMDT ACS for confirmation.</a:t>
+            </a:r>
+            <a:endParaRPr lang="en-US" sz="740" dirty="0"/>
+          </a:p>
+        </p:txBody>
+      </p:sp>
+      <p:sp>
+        <p:nvSpPr>
+          <p:cNvPr id="98" name="Shape 79"/>
+          <p:cNvSpPr/>
+          <p:nvPr/>
+        </p:nvSpPr>
+        <p:spPr>
+          <a:xfrm>
+            <a:off x="457200" y="8485632"/>
+            <a:ext cx="3017520" cy="237744"/>
+          </a:xfrm>
+          <a:prstGeom prst="rect">
+            <a:avLst/>
+          </a:prstGeom>
+          <a:solidFill>
+            <a:srgbClr val="002516"/>
+          </a:solidFill>
+          <a:ln/>
+        </p:spPr>
+      </p:sp>
+      <p:sp>
+        <p:nvSpPr>
+          <p:cNvPr id="99" name="Text 80"/>
+          <p:cNvSpPr/>
+          <p:nvPr/>
+        </p:nvSpPr>
+        <p:spPr>
+          <a:xfrm>
+            <a:off x="457200" y="8485632"/>
+            <a:ext cx="3017520" cy="237744"/>
+          </a:xfrm>
+          <a:prstGeom prst="rect">
+            <a:avLst/>
+          </a:prstGeom>
+          <a:noFill/>
+          <a:ln/>
+        </p:spPr>
+        <p:txBody>
+          <a:bodyPr wrap="square" lIns="0" tIns="0" rIns="0" bIns="0" rtlCol="0" anchor="ctr"/>
+          <a:lstStyle/>
+          <a:p>
+            <a:pPr algn="ctr" indent="0" marL="0">
+              <a:buNone/>
+            </a:pPr>
+            <a:r>
+              <a:rPr lang="en-US" sz="780" b="1" spc="150" kern="0" dirty="0">
+                <a:solidFill>
+                  <a:srgbClr val="FFFFFF"/>
+                </a:solidFill>
+                <a:latin typeface="Arial" pitchFamily="34" charset="0"/>
+                <a:ea typeface="Arial" pitchFamily="34" charset="-122"/>
+                <a:cs typeface="Arial" pitchFamily="34" charset="-120"/>
+              </a:rPr>
+              <a:t>6. IMMEDIATE WITHDRAWAL</a:t>
+            </a:r>
+            <a:endParaRPr lang="en-US" sz="780" dirty="0"/>
+          </a:p>
+        </p:txBody>
+      </p:sp>
+      <p:sp>
+        <p:nvSpPr>
+          <p:cNvPr id="100" name="Shape 81"/>
+          <p:cNvSpPr/>
+          <p:nvPr/>
+        </p:nvSpPr>
+        <p:spPr>
+          <a:xfrm>
+            <a:off x="457200" y="8723376"/>
+            <a:ext cx="3017520" cy="1335024"/>
+          </a:xfrm>
+          <a:prstGeom prst="rect">
+            <a:avLst/>
+          </a:prstGeom>
+          <a:solidFill>
+            <a:srgbClr val="CDD2B7">
+              <a:alpha val="28000"/>
+            </a:srgbClr>
+          </a:solidFill>
+          <a:ln/>
+        </p:spPr>
+      </p:sp>
+      <p:pic>
+        <p:nvPicPr>
+          <p:cNvPr id="101" name="Image 17" descr="preencoded.png">    </p:cNvPr>
+          <p:cNvPicPr>
+            <a:picLocks noChangeAspect="1"/>
+          </p:cNvPicPr>
+          <p:nvPr/>
+        </p:nvPicPr>
+        <p:blipFill>
+          <a:blip r:embed="rId18"/>
+          <a:stretch>
+            <a:fillRect/>
+          </a:stretch>
+        </p:blipFill>
+        <p:spPr>
+          <a:xfrm>
+            <a:off x="585216" y="8869680"/>
+            <a:ext cx="310896" cy="310896"/>
+          </a:xfrm>
+          <a:prstGeom prst="rect">
+            <a:avLst/>
+          </a:prstGeom>
+        </p:spPr>
+      </p:pic>
+      <p:sp>
+        <p:nvSpPr>
+          <p:cNvPr id="102" name="Text 82"/>
+          <p:cNvSpPr/>
+          <p:nvPr/>
+        </p:nvSpPr>
+        <p:spPr>
+          <a:xfrm>
+            <a:off x="1005840" y="8833104"/>
+            <a:ext cx="2331720" cy="1115568"/>
+          </a:xfrm>
+          <a:prstGeom prst="rect">
+            <a:avLst/>
+          </a:prstGeom>
+          <a:noFill/>
+          <a:ln/>
+        </p:spPr>
+        <p:txBody>
+          <a:bodyPr wrap="square" lIns="0" tIns="0" rIns="0" bIns="0" rtlCol="0" anchor="t"/>
+          <a:lstStyle/>
+          <a:p>
+            <a:pPr algn="l" indent="0" marL="0">
+              <a:buNone/>
+            </a:pPr>
+            <a:r>
+              <a:rPr lang="en-US" sz="730" dirty="0">
+                <a:solidFill>
+                  <a:srgbClr val="000000"/>
+                </a:solidFill>
+                <a:latin typeface="Arial" pitchFamily="34" charset="0"/>
+                <a:ea typeface="Arial" pitchFamily="34" charset="-122"/>
+                <a:cs typeface="Arial" pitchFamily="34" charset="-120"/>
+              </a:rPr>
+              <a:t>An instructor, safety staff member or medical practitioner may immediately stop or withdraw a participant to manage an immediate safety or medical risk, informing CI NZALC and CI NCO School as soon as practicable.</a:t>
+            </a:r>
+            <a:endParaRPr lang="en-US" sz="730" dirty="0"/>
+          </a:p>
+        </p:txBody>
+      </p:sp>
+      <p:sp>
+        <p:nvSpPr>
+          <p:cNvPr id="103" name="Shape 83"/>
+          <p:cNvSpPr/>
+          <p:nvPr/>
+        </p:nvSpPr>
+        <p:spPr>
+          <a:xfrm>
+            <a:off x="3630168" y="8485632"/>
+            <a:ext cx="3474720" cy="237744"/>
+          </a:xfrm>
+          <a:prstGeom prst="rect">
+            <a:avLst/>
+          </a:prstGeom>
+          <a:solidFill>
+            <a:srgbClr val="002516"/>
+          </a:solidFill>
+          <a:ln/>
+        </p:spPr>
+      </p:sp>
+      <p:sp>
+        <p:nvSpPr>
+          <p:cNvPr id="104" name="Text 84"/>
+          <p:cNvSpPr/>
+          <p:nvPr/>
+        </p:nvSpPr>
+        <p:spPr>
+          <a:xfrm>
+            <a:off x="3630168" y="8485632"/>
+            <a:ext cx="3474720" cy="237744"/>
+          </a:xfrm>
+          <a:prstGeom prst="rect">
+            <a:avLst/>
+          </a:prstGeom>
+          <a:noFill/>
+          <a:ln/>
+        </p:spPr>
+        <p:txBody>
+          <a:bodyPr wrap="square" lIns="0" tIns="0" rIns="0" bIns="0" rtlCol="0" anchor="ctr"/>
+          <a:lstStyle/>
+          <a:p>
+            <a:pPr algn="ctr" indent="0" marL="0">
+              <a:buNone/>
+            </a:pPr>
+            <a:r>
+              <a:rPr lang="en-US" sz="780" b="1" spc="150" kern="0" dirty="0">
+                <a:solidFill>
+                  <a:srgbClr val="FFFFFF"/>
+                </a:solidFill>
+                <a:latin typeface="Arial" pitchFamily="34" charset="0"/>
+                <a:ea typeface="Arial" pitchFamily="34" charset="-122"/>
+                <a:cs typeface="Arial" pitchFamily="34" charset="-120"/>
+              </a:rPr>
+              <a:t>7. RECORD OF DECISION</a:t>
+            </a:r>
+            <a:endParaRPr lang="en-US" sz="780" dirty="0"/>
+          </a:p>
+        </p:txBody>
+      </p:sp>
+      <p:sp>
+        <p:nvSpPr>
+          <p:cNvPr id="105" name="Shape 85"/>
+          <p:cNvSpPr/>
+          <p:nvPr/>
+        </p:nvSpPr>
+        <p:spPr>
+          <a:xfrm>
+            <a:off x="3630168" y="8723376"/>
+            <a:ext cx="3474720" cy="1335024"/>
           </a:xfrm>
           <a:prstGeom prst="rect">
             <a:avLst/>
@@ -3044,1394 +4136,7 @@
       </p:sp>
       <p:sp>
         <p:nvSpPr>
-          <p:cNvPr id="74" name="Shape 58"/>
-          <p:cNvSpPr/>
-          <p:nvPr/>
-        </p:nvSpPr>
-        <p:spPr>
-          <a:xfrm>
-            <a:off x="4544568" y="4334256"/>
-            <a:ext cx="155448" cy="155448"/>
-          </a:xfrm>
-          <a:prstGeom prst="rect">
-            <a:avLst/>
-          </a:prstGeom>
-          <a:solidFill>
-            <a:srgbClr val="3A4B00"/>
-          </a:solidFill>
-          <a:ln/>
-        </p:spPr>
-      </p:sp>
-      <p:sp>
-        <p:nvSpPr>
-          <p:cNvPr id="75" name="Text 59"/>
-          <p:cNvSpPr/>
-          <p:nvPr/>
-        </p:nvSpPr>
-        <p:spPr>
-          <a:xfrm>
-            <a:off x="4544568" y="4334256"/>
-            <a:ext cx="155448" cy="155448"/>
-          </a:xfrm>
-          <a:prstGeom prst="rect">
-            <a:avLst/>
-          </a:prstGeom>
-          <a:noFill/>
-          <a:ln/>
-        </p:spPr>
-        <p:txBody>
-          <a:bodyPr wrap="square" lIns="0" tIns="0" rIns="0" bIns="0" rtlCol="0" anchor="ctr"/>
-          <a:lstStyle/>
-          <a:p>
-            <a:pPr algn="ctr" indent="0" marL="0">
-              <a:buNone/>
-            </a:pPr>
-            <a:r>
-              <a:rPr lang="en-US" sz="750" b="1" dirty="0">
-                <a:solidFill>
-                  <a:srgbClr val="FFFFFF"/>
-                </a:solidFill>
-                <a:latin typeface="Arial" pitchFamily="34" charset="0"/>
-                <a:ea typeface="Arial" pitchFamily="34" charset="-122"/>
-                <a:cs typeface="Arial" pitchFamily="34" charset="-120"/>
-              </a:rPr>
-              <a:t>4</a:t>
-            </a:r>
-            <a:endParaRPr lang="en-US" sz="750" dirty="0"/>
-          </a:p>
-        </p:txBody>
-      </p:sp>
-      <p:sp>
-        <p:nvSpPr>
-          <p:cNvPr id="76" name="Shape 60"/>
-          <p:cNvSpPr/>
-          <p:nvPr/>
-        </p:nvSpPr>
-        <p:spPr>
-          <a:xfrm>
-            <a:off x="4942332" y="4352544"/>
-            <a:ext cx="365760" cy="365760"/>
-          </a:xfrm>
-          <a:prstGeom prst="ellipse">
-            <a:avLst/>
-          </a:prstGeom>
-          <a:solidFill>
-            <a:srgbClr val="002516"/>
-          </a:solidFill>
-          <a:ln/>
-        </p:spPr>
-      </p:sp>
-      <p:pic>
-        <p:nvPicPr>
-          <p:cNvPr id="77" name="Image 14" descr="preencoded.png">    </p:cNvPr>
-          <p:cNvPicPr>
-            <a:picLocks noChangeAspect="1"/>
-          </p:cNvPicPr>
-          <p:nvPr/>
-        </p:nvPicPr>
-        <p:blipFill>
-          <a:blip r:embed="rId15"/>
-          <a:stretch>
-            <a:fillRect/>
-          </a:stretch>
-        </p:blipFill>
-        <p:spPr>
-          <a:xfrm>
-            <a:off x="5024628" y="4434840"/>
-            <a:ext cx="201168" cy="201168"/>
-          </a:xfrm>
-          <a:prstGeom prst="rect">
-            <a:avLst/>
-          </a:prstGeom>
-        </p:spPr>
-      </p:pic>
-      <p:sp>
-        <p:nvSpPr>
-          <p:cNvPr id="78" name="Text 61"/>
-          <p:cNvSpPr/>
-          <p:nvPr/>
-        </p:nvSpPr>
-        <p:spPr>
-          <a:xfrm>
-            <a:off x="4526280" y="4754880"/>
-            <a:ext cx="1197864" cy="274320"/>
-          </a:xfrm>
-          <a:prstGeom prst="rect">
-            <a:avLst/>
-          </a:prstGeom>
-          <a:noFill/>
-          <a:ln/>
-        </p:spPr>
-        <p:txBody>
-          <a:bodyPr wrap="square" lIns="0" tIns="0" rIns="0" bIns="0" rtlCol="0" anchor="ctr"/>
-          <a:lstStyle/>
-          <a:p>
-            <a:pPr algn="ctr" indent="0" marL="0">
-              <a:buNone/>
-            </a:pPr>
-            <a:r>
-              <a:rPr lang="en-US" sz="700" b="1" dirty="0">
-                <a:solidFill>
-                  <a:srgbClr val="002516"/>
-                </a:solidFill>
-                <a:latin typeface="Arial" pitchFamily="34" charset="0"/>
-                <a:ea typeface="Arial" pitchFamily="34" charset="-122"/>
-                <a:cs typeface="Arial" pitchFamily="34" charset="-120"/>
-              </a:rPr>
-              <a:t>Conduct</a:t>
-            </a:r>
-            <a:endParaRPr lang="en-US" sz="700" dirty="0"/>
-          </a:p>
-        </p:txBody>
-      </p:sp>
-      <p:sp>
-        <p:nvSpPr>
-          <p:cNvPr id="79" name="Text 62"/>
-          <p:cNvSpPr/>
-          <p:nvPr/>
-        </p:nvSpPr>
-        <p:spPr>
-          <a:xfrm>
-            <a:off x="4544568" y="5029200"/>
-            <a:ext cx="1161288" cy="694944"/>
-          </a:xfrm>
-          <a:prstGeom prst="rect">
-            <a:avLst/>
-          </a:prstGeom>
-          <a:noFill/>
-          <a:ln/>
-        </p:spPr>
-        <p:txBody>
-          <a:bodyPr wrap="square" lIns="0" tIns="0" rIns="0" bIns="0" rtlCol="0" anchor="t"/>
-          <a:lstStyle/>
-          <a:p>
-            <a:pPr algn="ctr" indent="0" marL="0">
-              <a:buNone/>
-            </a:pPr>
-            <a:r>
-              <a:rPr lang="en-US" sz="610" dirty="0">
-                <a:solidFill>
-                  <a:srgbClr val="000000"/>
-                </a:solidFill>
-                <a:latin typeface="Arial" pitchFamily="34" charset="0"/>
-                <a:ea typeface="Arial" pitchFamily="34" charset="-122"/>
-                <a:cs typeface="Arial" pitchFamily="34" charset="-120"/>
-              </a:rPr>
-              <a:t>Repeated refusal, deliberate non-compliance, or behaviour that creates risk or prevents team functioning after feedback.</a:t>
-            </a:r>
-            <a:endParaRPr lang="en-US" sz="610" dirty="0"/>
-          </a:p>
-        </p:txBody>
-      </p:sp>
-      <p:sp>
-        <p:nvSpPr>
-          <p:cNvPr id="80" name="Shape 63"/>
-          <p:cNvSpPr/>
-          <p:nvPr/>
-        </p:nvSpPr>
-        <p:spPr>
-          <a:xfrm>
-            <a:off x="5833872" y="4279392"/>
-            <a:ext cx="1271016" cy="1481328"/>
-          </a:xfrm>
-          <a:prstGeom prst="rect">
-            <a:avLst/>
-          </a:prstGeom>
-          <a:solidFill>
-            <a:srgbClr val="FFFFFF"/>
-          </a:solidFill>
-          <a:ln w="9525">
-            <a:solidFill>
-              <a:srgbClr val="A89662"/>
-            </a:solidFill>
-            <a:prstDash val="solid"/>
-          </a:ln>
-        </p:spPr>
-      </p:sp>
-      <p:sp>
-        <p:nvSpPr>
-          <p:cNvPr id="81" name="Shape 64"/>
-          <p:cNvSpPr/>
-          <p:nvPr/>
-        </p:nvSpPr>
-        <p:spPr>
-          <a:xfrm>
-            <a:off x="5888736" y="4334256"/>
-            <a:ext cx="155448" cy="155448"/>
-          </a:xfrm>
-          <a:prstGeom prst="rect">
-            <a:avLst/>
-          </a:prstGeom>
-          <a:solidFill>
-            <a:srgbClr val="3A4B00"/>
-          </a:solidFill>
-          <a:ln/>
-        </p:spPr>
-      </p:sp>
-      <p:sp>
-        <p:nvSpPr>
-          <p:cNvPr id="82" name="Text 65"/>
-          <p:cNvSpPr/>
-          <p:nvPr/>
-        </p:nvSpPr>
-        <p:spPr>
-          <a:xfrm>
-            <a:off x="5888736" y="4334256"/>
-            <a:ext cx="155448" cy="155448"/>
-          </a:xfrm>
-          <a:prstGeom prst="rect">
-            <a:avLst/>
-          </a:prstGeom>
-          <a:noFill/>
-          <a:ln/>
-        </p:spPr>
-        <p:txBody>
-          <a:bodyPr wrap="square" lIns="0" tIns="0" rIns="0" bIns="0" rtlCol="0" anchor="ctr"/>
-          <a:lstStyle/>
-          <a:p>
-            <a:pPr algn="ctr" indent="0" marL="0">
-              <a:buNone/>
-            </a:pPr>
-            <a:r>
-              <a:rPr lang="en-US" sz="750" b="1" dirty="0">
-                <a:solidFill>
-                  <a:srgbClr val="FFFFFF"/>
-                </a:solidFill>
-                <a:latin typeface="Arial" pitchFamily="34" charset="0"/>
-                <a:ea typeface="Arial" pitchFamily="34" charset="-122"/>
-                <a:cs typeface="Arial" pitchFamily="34" charset="-120"/>
-              </a:rPr>
-              <a:t>5</a:t>
-            </a:r>
-            <a:endParaRPr lang="en-US" sz="750" dirty="0"/>
-          </a:p>
-        </p:txBody>
-      </p:sp>
-      <p:sp>
-        <p:nvSpPr>
-          <p:cNvPr id="83" name="Shape 66"/>
-          <p:cNvSpPr/>
-          <p:nvPr/>
-        </p:nvSpPr>
-        <p:spPr>
-          <a:xfrm>
-            <a:off x="6286500" y="4352544"/>
-            <a:ext cx="365760" cy="365760"/>
-          </a:xfrm>
-          <a:prstGeom prst="ellipse">
-            <a:avLst/>
-          </a:prstGeom>
-          <a:solidFill>
-            <a:srgbClr val="002516"/>
-          </a:solidFill>
-          <a:ln/>
-        </p:spPr>
-      </p:sp>
-      <p:pic>
-        <p:nvPicPr>
-          <p:cNvPr id="84" name="Image 15" descr="preencoded.png">    </p:cNvPr>
-          <p:cNvPicPr>
-            <a:picLocks noChangeAspect="1"/>
-          </p:cNvPicPr>
-          <p:nvPr/>
-        </p:nvPicPr>
-        <p:blipFill>
-          <a:blip r:embed="rId16"/>
-          <a:stretch>
-            <a:fillRect/>
-          </a:stretch>
-        </p:blipFill>
-        <p:spPr>
-          <a:xfrm>
-            <a:off x="6368796" y="4434840"/>
-            <a:ext cx="201168" cy="201168"/>
-          </a:xfrm>
-          <a:prstGeom prst="rect">
-            <a:avLst/>
-          </a:prstGeom>
-        </p:spPr>
-      </p:pic>
-      <p:sp>
-        <p:nvSpPr>
-          <p:cNvPr id="85" name="Text 67"/>
-          <p:cNvSpPr/>
-          <p:nvPr/>
-        </p:nvSpPr>
-        <p:spPr>
-          <a:xfrm>
-            <a:off x="5870448" y="4754880"/>
-            <a:ext cx="1197864" cy="274320"/>
-          </a:xfrm>
-          <a:prstGeom prst="rect">
-            <a:avLst/>
-          </a:prstGeom>
-          <a:noFill/>
-          <a:ln/>
-        </p:spPr>
-        <p:txBody>
-          <a:bodyPr wrap="square" lIns="0" tIns="0" rIns="0" bIns="0" rtlCol="0" anchor="ctr"/>
-          <a:lstStyle/>
-          <a:p>
-            <a:pPr algn="ctr" indent="0" marL="0">
-              <a:buNone/>
-            </a:pPr>
-            <a:r>
-              <a:rPr lang="en-US" sz="700" b="1" dirty="0">
-                <a:solidFill>
-                  <a:srgbClr val="002516"/>
-                </a:solidFill>
-                <a:latin typeface="Arial" pitchFamily="34" charset="0"/>
-                <a:ea typeface="Arial" pitchFamily="34" charset="-122"/>
-                <a:cs typeface="Arial" pitchFamily="34" charset="-120"/>
-              </a:rPr>
-              <a:t>Developmental welfare</a:t>
-            </a:r>
-            <a:endParaRPr lang="en-US" sz="700" dirty="0"/>
-          </a:p>
-        </p:txBody>
-      </p:sp>
-      <p:sp>
-        <p:nvSpPr>
-          <p:cNvPr id="86" name="Text 68"/>
-          <p:cNvSpPr/>
-          <p:nvPr/>
-        </p:nvSpPr>
-        <p:spPr>
-          <a:xfrm>
-            <a:off x="5888736" y="5029200"/>
-            <a:ext cx="1161288" cy="694944"/>
-          </a:xfrm>
-          <a:prstGeom prst="rect">
-            <a:avLst/>
-          </a:prstGeom>
-          <a:noFill/>
-          <a:ln/>
-        </p:spPr>
-        <p:txBody>
-          <a:bodyPr wrap="square" lIns="0" tIns="0" rIns="0" bIns="0" rtlCol="0" anchor="t"/>
-          <a:lstStyle/>
-          <a:p>
-            <a:pPr algn="ctr" indent="0" marL="0">
-              <a:buNone/>
-            </a:pPr>
-            <a:r>
-              <a:rPr lang="en-US" sz="610" dirty="0">
-                <a:solidFill>
-                  <a:srgbClr val="000000"/>
-                </a:solidFill>
-                <a:latin typeface="Arial" pitchFamily="34" charset="0"/>
-                <a:ea typeface="Arial" pitchFamily="34" charset="-122"/>
-                <a:cs typeface="Arial" pitchFamily="34" charset="-120"/>
-              </a:rPr>
-              <a:t>Continued participation is likely to cause harm and no longer provides meaningful developmental benefit.</a:t>
-            </a:r>
-            <a:endParaRPr lang="en-US" sz="610" dirty="0"/>
-          </a:p>
-        </p:txBody>
-      </p:sp>
-      <p:sp>
-        <p:nvSpPr>
-          <p:cNvPr id="87" name="Shape 69"/>
-          <p:cNvSpPr/>
-          <p:nvPr/>
-        </p:nvSpPr>
-        <p:spPr>
-          <a:xfrm>
-            <a:off x="457200" y="5870448"/>
-            <a:ext cx="6647688" cy="914400"/>
-          </a:xfrm>
-          <a:prstGeom prst="rect">
-            <a:avLst/>
-          </a:prstGeom>
-          <a:solidFill>
-            <a:srgbClr val="3A4B00"/>
-          </a:solidFill>
-          <a:ln/>
-        </p:spPr>
-      </p:sp>
-      <p:sp>
-        <p:nvSpPr>
-          <p:cNvPr id="88" name="Text 70"/>
-          <p:cNvSpPr/>
-          <p:nvPr/>
-        </p:nvSpPr>
-        <p:spPr>
-          <a:xfrm>
-            <a:off x="457200" y="5916168"/>
-            <a:ext cx="6647688" cy="164592"/>
-          </a:xfrm>
-          <a:prstGeom prst="rect">
-            <a:avLst/>
-          </a:prstGeom>
-          <a:noFill/>
-          <a:ln/>
-        </p:spPr>
-        <p:txBody>
-          <a:bodyPr wrap="square" lIns="0" tIns="0" rIns="0" bIns="0" rtlCol="0" anchor="ctr"/>
-          <a:lstStyle/>
-          <a:p>
-            <a:pPr algn="ctr" indent="0" marL="0">
-              <a:buNone/>
-            </a:pPr>
-            <a:r>
-              <a:rPr lang="en-US" sz="860" b="1" spc="200" kern="0" dirty="0">
-                <a:solidFill>
-                  <a:srgbClr val="CDD2B7"/>
-                </a:solidFill>
-                <a:latin typeface="Arial" pitchFamily="34" charset="0"/>
-                <a:ea typeface="Arial" pitchFamily="34" charset="-122"/>
-                <a:cs typeface="Arial" pitchFamily="34" charset="-120"/>
-              </a:rPr>
-              <a:t>4. THE WITHDRAWAL TEST</a:t>
-            </a:r>
-            <a:endParaRPr lang="en-US" sz="860" dirty="0"/>
-          </a:p>
-        </p:txBody>
-      </p:sp>
-      <p:sp>
-        <p:nvSpPr>
-          <p:cNvPr id="89" name="Text 71"/>
-          <p:cNvSpPr/>
-          <p:nvPr/>
-        </p:nvSpPr>
-        <p:spPr>
-          <a:xfrm>
-            <a:off x="777240" y="6089904"/>
-            <a:ext cx="6007608" cy="475488"/>
-          </a:xfrm>
-          <a:prstGeom prst="rect">
-            <a:avLst/>
-          </a:prstGeom>
-          <a:noFill/>
-          <a:ln/>
-        </p:spPr>
-        <p:txBody>
-          <a:bodyPr wrap="square" lIns="0" tIns="0" rIns="0" bIns="0" rtlCol="0" anchor="t"/>
-          <a:lstStyle/>
-          <a:p>
-            <a:pPr algn="ctr" indent="0" marL="0">
-              <a:buNone/>
-            </a:pPr>
-            <a:r>
-              <a:rPr lang="en-US" sz="800" b="1" i="1" dirty="0">
-                <a:solidFill>
-                  <a:srgbClr val="FFFFFF"/>
-                </a:solidFill>
-                <a:latin typeface="Arial" pitchFamily="34" charset="0"/>
-                <a:ea typeface="Arial" pitchFamily="34" charset="-122"/>
-                <a:cs typeface="Arial" pitchFamily="34" charset="-120"/>
-              </a:rPr>
-              <a:t>What specific safety requirement, required activity, or approved learning or assessment objective can no longer be safely or meaningfully achieved, and what evidence shows that reasonable coaching, team adaptation or authorised adjustment will not restore the necessary conditions?</a:t>
-            </a:r>
-            <a:endParaRPr lang="en-US" sz="800" dirty="0"/>
-          </a:p>
-        </p:txBody>
-      </p:sp>
-      <p:sp>
-        <p:nvSpPr>
-          <p:cNvPr id="90" name="Text 72"/>
-          <p:cNvSpPr/>
-          <p:nvPr/>
-        </p:nvSpPr>
-        <p:spPr>
-          <a:xfrm>
-            <a:off x="777240" y="6565392"/>
-            <a:ext cx="6007608" cy="164592"/>
-          </a:xfrm>
-          <a:prstGeom prst="rect">
-            <a:avLst/>
-          </a:prstGeom>
-          <a:noFill/>
-          <a:ln/>
-        </p:spPr>
-        <p:txBody>
-          <a:bodyPr wrap="square" lIns="0" tIns="0" rIns="0" bIns="0" rtlCol="0" anchor="ctr"/>
-          <a:lstStyle/>
-          <a:p>
-            <a:pPr algn="ctr" indent="0" marL="0">
-              <a:buNone/>
-            </a:pPr>
-            <a:r>
-              <a:rPr lang="en-US" sz="700" i="1" dirty="0">
-                <a:solidFill>
-                  <a:srgbClr val="CDD2B7"/>
-                </a:solidFill>
-                <a:latin typeface="Arial" pitchFamily="34" charset="0"/>
-                <a:ea typeface="Arial" pitchFamily="34" charset="-122"/>
-                <a:cs typeface="Arial" pitchFamily="34" charset="-120"/>
-              </a:rPr>
-              <a:t>A slower team, greater workload or frustration alone will not normally meet this threshold.</a:t>
-            </a:r>
-            <a:endParaRPr lang="en-US" sz="700" dirty="0"/>
-          </a:p>
-        </p:txBody>
-      </p:sp>
-      <p:sp>
-        <p:nvSpPr>
-          <p:cNvPr id="91" name="Shape 73"/>
-          <p:cNvSpPr/>
-          <p:nvPr/>
-        </p:nvSpPr>
-        <p:spPr>
-          <a:xfrm>
-            <a:off x="457200" y="6894576"/>
-            <a:ext cx="6647688" cy="256032"/>
-          </a:xfrm>
-          <a:prstGeom prst="rect">
-            <a:avLst/>
-          </a:prstGeom>
-          <a:solidFill>
-            <a:srgbClr val="002516"/>
-          </a:solidFill>
-          <a:ln/>
-        </p:spPr>
-      </p:sp>
-      <p:sp>
-        <p:nvSpPr>
-          <p:cNvPr id="92" name="Text 74"/>
-          <p:cNvSpPr/>
-          <p:nvPr/>
-        </p:nvSpPr>
-        <p:spPr>
-          <a:xfrm>
-            <a:off x="457200" y="6894576"/>
-            <a:ext cx="6647688" cy="256032"/>
-          </a:xfrm>
-          <a:prstGeom prst="rect">
-            <a:avLst/>
-          </a:prstGeom>
-          <a:noFill/>
-          <a:ln/>
-        </p:spPr>
-        <p:txBody>
-          <a:bodyPr wrap="square" lIns="0" tIns="0" rIns="0" bIns="0" rtlCol="0" anchor="ctr"/>
-          <a:lstStyle/>
-          <a:p>
-            <a:pPr algn="ctr" indent="0" marL="0">
-              <a:buNone/>
-            </a:pPr>
-            <a:r>
-              <a:rPr lang="en-US" sz="860" b="1" spc="150" kern="0" dirty="0">
-                <a:solidFill>
-                  <a:srgbClr val="FFFFFF"/>
-                </a:solidFill>
-                <a:latin typeface="Arial" pitchFamily="34" charset="0"/>
-                <a:ea typeface="Arial" pitchFamily="34" charset="-122"/>
-                <a:cs typeface="Arial" pitchFamily="34" charset="-120"/>
-              </a:rPr>
-              <a:t>5. DECISION PROCESS</a:t>
-            </a:r>
-            <a:endParaRPr lang="en-US" sz="860" dirty="0"/>
-          </a:p>
-        </p:txBody>
-      </p:sp>
-      <p:sp>
-        <p:nvSpPr>
-          <p:cNvPr id="93" name="Shape 75"/>
-          <p:cNvSpPr/>
-          <p:nvPr/>
-        </p:nvSpPr>
-        <p:spPr>
-          <a:xfrm>
-            <a:off x="457200" y="7260336"/>
-            <a:ext cx="310896" cy="310896"/>
-          </a:xfrm>
-          <a:prstGeom prst="ellipse">
-            <a:avLst/>
-          </a:prstGeom>
-          <a:solidFill>
-            <a:srgbClr val="FFFFFF"/>
-          </a:solidFill>
-          <a:ln w="15875">
-            <a:solidFill>
-              <a:srgbClr val="002516"/>
-            </a:solidFill>
-            <a:prstDash val="solid"/>
-          </a:ln>
-        </p:spPr>
-      </p:sp>
-      <p:pic>
-        <p:nvPicPr>
-          <p:cNvPr id="94" name="Image 16" descr="preencoded.png">    </p:cNvPr>
-          <p:cNvPicPr>
-            <a:picLocks noChangeAspect="1"/>
-          </p:cNvPicPr>
-          <p:nvPr/>
-        </p:nvPicPr>
-        <p:blipFill>
-          <a:blip r:embed="rId17"/>
-          <a:stretch>
-            <a:fillRect/>
-          </a:stretch>
-        </p:blipFill>
-        <p:spPr>
-          <a:xfrm>
-            <a:off x="521208" y="7324344"/>
-            <a:ext cx="182880" cy="182880"/>
-          </a:xfrm>
-          <a:prstGeom prst="rect">
-            <a:avLst/>
-          </a:prstGeom>
-        </p:spPr>
-      </p:pic>
-      <p:sp>
-        <p:nvSpPr>
-          <p:cNvPr id="95" name="Text 76"/>
-          <p:cNvSpPr/>
-          <p:nvPr/>
-        </p:nvSpPr>
-        <p:spPr>
-          <a:xfrm>
-            <a:off x="822960" y="7242048"/>
-            <a:ext cx="1691640" cy="164592"/>
-          </a:xfrm>
-          <a:prstGeom prst="rect">
-            <a:avLst/>
-          </a:prstGeom>
-          <a:noFill/>
-          <a:ln/>
-        </p:spPr>
-        <p:txBody>
-          <a:bodyPr wrap="square" lIns="0" tIns="0" rIns="0" bIns="0" rtlCol="0" anchor="ctr"/>
-          <a:lstStyle/>
-          <a:p>
-            <a:pPr algn="l" indent="0" marL="0">
-              <a:buNone/>
-            </a:pPr>
-            <a:r>
-              <a:rPr lang="en-US" sz="780" b="1" dirty="0">
-                <a:solidFill>
-                  <a:srgbClr val="C62026"/>
-                </a:solidFill>
-                <a:latin typeface="Arial" pitchFamily="34" charset="0"/>
-                <a:ea typeface="Arial" pitchFamily="34" charset="-122"/>
-                <a:cs typeface="Arial" pitchFamily="34" charset="-120"/>
-              </a:rPr>
-              <a:t>1.  </a:t>
-            </a:r>
-            <a:pPr algn="l" indent="0" marL="0">
-              <a:buNone/>
-            </a:pPr>
-            <a:r>
-              <a:rPr lang="en-US" sz="780" b="1" dirty="0">
-                <a:solidFill>
-                  <a:srgbClr val="002516"/>
-                </a:solidFill>
-                <a:latin typeface="Arial" pitchFamily="34" charset="0"/>
-                <a:ea typeface="Arial" pitchFamily="34" charset="-122"/>
-                <a:cs typeface="Arial" pitchFamily="34" charset="-120"/>
-              </a:rPr>
-              <a:t>Observe and enable</a:t>
-            </a:r>
-            <a:endParaRPr lang="en-US" sz="780" dirty="0"/>
-          </a:p>
-        </p:txBody>
-      </p:sp>
-      <p:sp>
-        <p:nvSpPr>
-          <p:cNvPr id="96" name="Text 77"/>
-          <p:cNvSpPr/>
-          <p:nvPr/>
-        </p:nvSpPr>
-        <p:spPr>
-          <a:xfrm>
-            <a:off x="822960" y="7406640"/>
-            <a:ext cx="1673352" cy="603504"/>
-          </a:xfrm>
-          <a:prstGeom prst="rect">
-            <a:avLst/>
-          </a:prstGeom>
-          <a:noFill/>
-          <a:ln/>
-        </p:spPr>
-        <p:txBody>
-          <a:bodyPr wrap="square" lIns="0" tIns="0" rIns="0" bIns="0" rtlCol="0" anchor="t"/>
-          <a:lstStyle/>
-          <a:p>
-            <a:pPr algn="l" indent="0" marL="0">
-              <a:buNone/>
-            </a:pPr>
-            <a:r>
-              <a:rPr lang="en-US" sz="630" dirty="0">
-                <a:solidFill>
-                  <a:srgbClr val="000000"/>
-                </a:solidFill>
-                <a:latin typeface="Arial" pitchFamily="34" charset="0"/>
-                <a:ea typeface="Arial" pitchFamily="34" charset="-122"/>
-                <a:cs typeface="Arial" pitchFamily="34" charset="-120"/>
-              </a:rPr>
-              <a:t>Identify the issue; allow the team a reasonable opportunity to recognise, respond and manage it.</a:t>
-            </a:r>
-            <a:endParaRPr lang="en-US" sz="630" dirty="0"/>
-          </a:p>
-        </p:txBody>
-      </p:sp>
-      <p:sp>
-        <p:nvSpPr>
-          <p:cNvPr id="97" name="Text 78"/>
-          <p:cNvSpPr/>
-          <p:nvPr/>
-        </p:nvSpPr>
-        <p:spPr>
-          <a:xfrm>
-            <a:off x="2478024" y="7296912"/>
-            <a:ext cx="310896" cy="219456"/>
-          </a:xfrm>
-          <a:prstGeom prst="rect">
-            <a:avLst/>
-          </a:prstGeom>
-          <a:noFill/>
-          <a:ln/>
-        </p:spPr>
-        <p:txBody>
-          <a:bodyPr wrap="square" lIns="0" tIns="0" rIns="0" bIns="0" rtlCol="0" anchor="ctr"/>
-          <a:lstStyle/>
-          <a:p>
-            <a:pPr algn="ctr" indent="0" marL="0">
-              <a:buNone/>
-            </a:pPr>
-            <a:r>
-              <a:rPr lang="en-US" sz="1000" b="1" dirty="0">
-                <a:solidFill>
-                  <a:srgbClr val="C62026"/>
-                </a:solidFill>
-                <a:latin typeface="Arial" pitchFamily="34" charset="0"/>
-                <a:ea typeface="Arial" pitchFamily="34" charset="-122"/>
-                <a:cs typeface="Arial" pitchFamily="34" charset="-120"/>
-              </a:rPr>
-              <a:t>►</a:t>
-            </a:r>
-            <a:endParaRPr lang="en-US" sz="1000" dirty="0"/>
-          </a:p>
-        </p:txBody>
-      </p:sp>
-      <p:sp>
-        <p:nvSpPr>
-          <p:cNvPr id="98" name="Shape 79"/>
-          <p:cNvSpPr/>
-          <p:nvPr/>
-        </p:nvSpPr>
-        <p:spPr>
-          <a:xfrm>
-            <a:off x="2752344" y="7260336"/>
-            <a:ext cx="310896" cy="310896"/>
-          </a:xfrm>
-          <a:prstGeom prst="ellipse">
-            <a:avLst/>
-          </a:prstGeom>
-          <a:solidFill>
-            <a:srgbClr val="FFFFFF"/>
-          </a:solidFill>
-          <a:ln w="15875">
-            <a:solidFill>
-              <a:srgbClr val="002516"/>
-            </a:solidFill>
-            <a:prstDash val="solid"/>
-          </a:ln>
-        </p:spPr>
-      </p:sp>
-      <p:pic>
-        <p:nvPicPr>
-          <p:cNvPr id="99" name="Image 17" descr="preencoded.png">    </p:cNvPr>
-          <p:cNvPicPr>
-            <a:picLocks noChangeAspect="1"/>
-          </p:cNvPicPr>
-          <p:nvPr/>
-        </p:nvPicPr>
-        <p:blipFill>
-          <a:blip r:embed="rId18"/>
-          <a:stretch>
-            <a:fillRect/>
-          </a:stretch>
-        </p:blipFill>
-        <p:spPr>
-          <a:xfrm>
-            <a:off x="2816352" y="7324344"/>
-            <a:ext cx="182880" cy="182880"/>
-          </a:xfrm>
-          <a:prstGeom prst="rect">
-            <a:avLst/>
-          </a:prstGeom>
-        </p:spPr>
-      </p:pic>
-      <p:sp>
-        <p:nvSpPr>
-          <p:cNvPr id="100" name="Text 80"/>
-          <p:cNvSpPr/>
-          <p:nvPr/>
-        </p:nvSpPr>
-        <p:spPr>
-          <a:xfrm>
-            <a:off x="3118104" y="7242048"/>
-            <a:ext cx="1691640" cy="164592"/>
-          </a:xfrm>
-          <a:prstGeom prst="rect">
-            <a:avLst/>
-          </a:prstGeom>
-          <a:noFill/>
-          <a:ln/>
-        </p:spPr>
-        <p:txBody>
-          <a:bodyPr wrap="square" lIns="0" tIns="0" rIns="0" bIns="0" rtlCol="0" anchor="ctr"/>
-          <a:lstStyle/>
-          <a:p>
-            <a:pPr algn="l" indent="0" marL="0">
-              <a:buNone/>
-            </a:pPr>
-            <a:r>
-              <a:rPr lang="en-US" sz="780" b="1" dirty="0">
-                <a:solidFill>
-                  <a:srgbClr val="C62026"/>
-                </a:solidFill>
-                <a:latin typeface="Arial" pitchFamily="34" charset="0"/>
-                <a:ea typeface="Arial" pitchFamily="34" charset="-122"/>
-                <a:cs typeface="Arial" pitchFamily="34" charset="-120"/>
-              </a:rPr>
-              <a:t>2.  </a:t>
-            </a:r>
-            <a:pPr algn="l" indent="0" marL="0">
-              <a:buNone/>
-            </a:pPr>
-            <a:r>
-              <a:rPr lang="en-US" sz="780" b="1" dirty="0">
-                <a:solidFill>
-                  <a:srgbClr val="002516"/>
-                </a:solidFill>
-                <a:latin typeface="Arial" pitchFamily="34" charset="0"/>
-                <a:ea typeface="Arial" pitchFamily="34" charset="-122"/>
-                <a:cs typeface="Arial" pitchFamily="34" charset="-120"/>
-              </a:rPr>
-              <a:t>Intervene and reassess</a:t>
-            </a:r>
-            <a:endParaRPr lang="en-US" sz="780" dirty="0"/>
-          </a:p>
-        </p:txBody>
-      </p:sp>
-      <p:sp>
-        <p:nvSpPr>
-          <p:cNvPr id="101" name="Text 81"/>
-          <p:cNvSpPr/>
-          <p:nvPr/>
-        </p:nvSpPr>
-        <p:spPr>
-          <a:xfrm>
-            <a:off x="3118104" y="7406640"/>
-            <a:ext cx="1673352" cy="603504"/>
-          </a:xfrm>
-          <a:prstGeom prst="rect">
-            <a:avLst/>
-          </a:prstGeom>
-          <a:noFill/>
-          <a:ln/>
-        </p:spPr>
-        <p:txBody>
-          <a:bodyPr wrap="square" lIns="0" tIns="0" rIns="0" bIns="0" rtlCol="0" anchor="t"/>
-          <a:lstStyle/>
-          <a:p>
-            <a:pPr algn="l" indent="0" marL="0">
-              <a:buNone/>
-            </a:pPr>
-            <a:r>
-              <a:rPr lang="en-US" sz="630" dirty="0">
-                <a:solidFill>
-                  <a:srgbClr val="000000"/>
-                </a:solidFill>
-                <a:latin typeface="Arial" pitchFamily="34" charset="0"/>
-                <a:ea typeface="Arial" pitchFamily="34" charset="-122"/>
-                <a:cs typeface="Arial" pitchFamily="34" charset="-120"/>
-              </a:rPr>
-              <a:t>Provide clear feedback; apply authorised adjustments; reassess whether safe and meaningful participation remains achievable.</a:t>
-            </a:r>
-            <a:endParaRPr lang="en-US" sz="630" dirty="0"/>
-          </a:p>
-        </p:txBody>
-      </p:sp>
-      <p:sp>
-        <p:nvSpPr>
-          <p:cNvPr id="102" name="Text 82"/>
-          <p:cNvSpPr/>
-          <p:nvPr/>
-        </p:nvSpPr>
-        <p:spPr>
-          <a:xfrm>
-            <a:off x="4773168" y="7296912"/>
-            <a:ext cx="310896" cy="219456"/>
-          </a:xfrm>
-          <a:prstGeom prst="rect">
-            <a:avLst/>
-          </a:prstGeom>
-          <a:noFill/>
-          <a:ln/>
-        </p:spPr>
-        <p:txBody>
-          <a:bodyPr wrap="square" lIns="0" tIns="0" rIns="0" bIns="0" rtlCol="0" anchor="ctr"/>
-          <a:lstStyle/>
-          <a:p>
-            <a:pPr algn="ctr" indent="0" marL="0">
-              <a:buNone/>
-            </a:pPr>
-            <a:r>
-              <a:rPr lang="en-US" sz="1000" b="1" dirty="0">
-                <a:solidFill>
-                  <a:srgbClr val="C62026"/>
-                </a:solidFill>
-                <a:latin typeface="Arial" pitchFamily="34" charset="0"/>
-                <a:ea typeface="Arial" pitchFamily="34" charset="-122"/>
-                <a:cs typeface="Arial" pitchFamily="34" charset="-120"/>
-              </a:rPr>
-              <a:t>►</a:t>
-            </a:r>
-            <a:endParaRPr lang="en-US" sz="1000" dirty="0"/>
-          </a:p>
-        </p:txBody>
-      </p:sp>
-      <p:sp>
-        <p:nvSpPr>
-          <p:cNvPr id="103" name="Shape 83"/>
-          <p:cNvSpPr/>
-          <p:nvPr/>
-        </p:nvSpPr>
-        <p:spPr>
-          <a:xfrm>
-            <a:off x="5047488" y="7260336"/>
-            <a:ext cx="310896" cy="310896"/>
-          </a:xfrm>
-          <a:prstGeom prst="ellipse">
-            <a:avLst/>
-          </a:prstGeom>
-          <a:solidFill>
-            <a:srgbClr val="FFFFFF"/>
-          </a:solidFill>
-          <a:ln w="15875">
-            <a:solidFill>
-              <a:srgbClr val="002516"/>
-            </a:solidFill>
-            <a:prstDash val="solid"/>
-          </a:ln>
-        </p:spPr>
-      </p:sp>
-      <p:pic>
-        <p:nvPicPr>
-          <p:cNvPr id="104" name="Image 18" descr="preencoded.png">    </p:cNvPr>
-          <p:cNvPicPr>
-            <a:picLocks noChangeAspect="1"/>
-          </p:cNvPicPr>
-          <p:nvPr/>
-        </p:nvPicPr>
-        <p:blipFill>
-          <a:blip r:embed="rId19"/>
-          <a:stretch>
-            <a:fillRect/>
-          </a:stretch>
-        </p:blipFill>
-        <p:spPr>
-          <a:xfrm>
-            <a:off x="5111496" y="7324344"/>
-            <a:ext cx="182880" cy="182880"/>
-          </a:xfrm>
-          <a:prstGeom prst="rect">
-            <a:avLst/>
-          </a:prstGeom>
-        </p:spPr>
-      </p:pic>
-      <p:sp>
-        <p:nvSpPr>
-          <p:cNvPr id="105" name="Text 84"/>
-          <p:cNvSpPr/>
-          <p:nvPr/>
-        </p:nvSpPr>
-        <p:spPr>
-          <a:xfrm>
-            <a:off x="5413248" y="7242048"/>
-            <a:ext cx="1691640" cy="164592"/>
-          </a:xfrm>
-          <a:prstGeom prst="rect">
-            <a:avLst/>
-          </a:prstGeom>
-          <a:noFill/>
-          <a:ln/>
-        </p:spPr>
-        <p:txBody>
-          <a:bodyPr wrap="square" lIns="0" tIns="0" rIns="0" bIns="0" rtlCol="0" anchor="ctr"/>
-          <a:lstStyle/>
-          <a:p>
-            <a:pPr algn="l" indent="0" marL="0">
-              <a:buNone/>
-            </a:pPr>
-            <a:r>
-              <a:rPr lang="en-US" sz="780" b="1" dirty="0">
-                <a:solidFill>
-                  <a:srgbClr val="C62026"/>
-                </a:solidFill>
-                <a:latin typeface="Arial" pitchFamily="34" charset="0"/>
-                <a:ea typeface="Arial" pitchFamily="34" charset="-122"/>
-                <a:cs typeface="Arial" pitchFamily="34" charset="-120"/>
-              </a:rPr>
-              <a:t>3.  </a:t>
-            </a:r>
-            <a:pPr algn="l" indent="0" marL="0">
-              <a:buNone/>
-            </a:pPr>
-            <a:r>
-              <a:rPr lang="en-US" sz="780" b="1" dirty="0">
-                <a:solidFill>
-                  <a:srgbClr val="002516"/>
-                </a:solidFill>
-                <a:latin typeface="Arial" pitchFamily="34" charset="0"/>
-                <a:ea typeface="Arial" pitchFamily="34" charset="-122"/>
-                <a:cs typeface="Arial" pitchFamily="34" charset="-120"/>
-              </a:rPr>
-              <a:t>Decide and record</a:t>
-            </a:r>
-            <a:endParaRPr lang="en-US" sz="780" dirty="0"/>
-          </a:p>
-        </p:txBody>
-      </p:sp>
-      <p:sp>
-        <p:nvSpPr>
-          <p:cNvPr id="106" name="Text 85"/>
-          <p:cNvSpPr/>
-          <p:nvPr/>
-        </p:nvSpPr>
-        <p:spPr>
-          <a:xfrm>
-            <a:off x="5413248" y="7406640"/>
-            <a:ext cx="1673352" cy="603504"/>
-          </a:xfrm>
-          <a:prstGeom prst="rect">
-            <a:avLst/>
-          </a:prstGeom>
-          <a:noFill/>
-          <a:ln/>
-        </p:spPr>
-        <p:txBody>
-          <a:bodyPr wrap="square" lIns="0" tIns="0" rIns="0" bIns="0" rtlCol="0" anchor="t"/>
-          <a:lstStyle/>
-          <a:p>
-            <a:pPr algn="l" indent="0" marL="0">
-              <a:buNone/>
-            </a:pPr>
-            <a:r>
-              <a:rPr lang="en-US" sz="630" dirty="0">
-                <a:solidFill>
-                  <a:srgbClr val="000000"/>
-                </a:solidFill>
-                <a:latin typeface="Arial" pitchFamily="34" charset="0"/>
-                <a:ea typeface="Arial" pitchFamily="34" charset="-122"/>
-                <a:cs typeface="Arial" pitchFamily="34" charset="-120"/>
-              </a:rPr>
-              <a:t>If withdrawal remains necessary, staff provide observations and a recommendation to the designated uniformed authority.</a:t>
-            </a:r>
-            <a:endParaRPr lang="en-US" sz="630" dirty="0"/>
-          </a:p>
-        </p:txBody>
-      </p:sp>
-      <p:sp>
-        <p:nvSpPr>
-          <p:cNvPr id="107" name="Shape 86"/>
-          <p:cNvSpPr/>
-          <p:nvPr/>
-        </p:nvSpPr>
-        <p:spPr>
-          <a:xfrm>
-            <a:off x="457200" y="8065008"/>
-            <a:ext cx="6647688" cy="292608"/>
-          </a:xfrm>
-          <a:prstGeom prst="rect">
-            <a:avLst/>
-          </a:prstGeom>
-          <a:solidFill>
-            <a:srgbClr val="CDD2B7">
-              <a:alpha val="45000"/>
-            </a:srgbClr>
-          </a:solidFill>
-          <a:ln/>
-        </p:spPr>
-      </p:sp>
-      <p:sp>
-        <p:nvSpPr>
-          <p:cNvPr id="108" name="Text 87"/>
-          <p:cNvSpPr/>
-          <p:nvPr/>
-        </p:nvSpPr>
-        <p:spPr>
-          <a:xfrm>
-            <a:off x="594360" y="8065008"/>
-            <a:ext cx="6373368" cy="292608"/>
-          </a:xfrm>
-          <a:prstGeom prst="rect">
-            <a:avLst/>
-          </a:prstGeom>
-          <a:noFill/>
-          <a:ln/>
-        </p:spPr>
-        <p:txBody>
-          <a:bodyPr wrap="square" lIns="0" tIns="0" rIns="0" bIns="0" rtlCol="0" anchor="ctr"/>
-          <a:lstStyle/>
-          <a:p>
-            <a:pPr algn="l" indent="0" marL="0">
-              <a:buNone/>
-            </a:pPr>
-            <a:r>
-              <a:rPr lang="en-US" sz="740" b="1" dirty="0">
-                <a:solidFill>
-                  <a:srgbClr val="002516"/>
-                </a:solidFill>
-                <a:latin typeface="Arial" pitchFamily="34" charset="0"/>
-                <a:ea typeface="Arial" pitchFamily="34" charset="-122"/>
-                <a:cs typeface="Arial" pitchFamily="34" charset="-120"/>
-              </a:rPr>
-              <a:t>Non-immediate withdrawal:  </a:t>
-            </a:r>
-            <a:pPr algn="l" indent="0" marL="0">
-              <a:buNone/>
-            </a:pPr>
-            <a:r>
-              <a:rPr lang="en-US" sz="740" dirty="0">
-                <a:solidFill>
-                  <a:srgbClr val="000000"/>
-                </a:solidFill>
-                <a:latin typeface="Arial" pitchFamily="34" charset="0"/>
-                <a:ea typeface="Arial" pitchFamily="34" charset="-122"/>
-                <a:cs typeface="Arial" pitchFamily="34" charset="-120"/>
-              </a:rPr>
-              <a:t>CI NZALC and CI NCO School discuss the case; CI NZALC recommends withdrawal to COMDT ACS for confirmation.</a:t>
-            </a:r>
-            <a:endParaRPr lang="en-US" sz="740" dirty="0"/>
-          </a:p>
-        </p:txBody>
-      </p:sp>
-      <p:sp>
-        <p:nvSpPr>
-          <p:cNvPr id="109" name="Shape 88"/>
-          <p:cNvSpPr/>
-          <p:nvPr/>
-        </p:nvSpPr>
-        <p:spPr>
-          <a:xfrm>
-            <a:off x="457200" y="8485632"/>
-            <a:ext cx="3017520" cy="237744"/>
-          </a:xfrm>
-          <a:prstGeom prst="rect">
-            <a:avLst/>
-          </a:prstGeom>
-          <a:solidFill>
-            <a:srgbClr val="002516"/>
-          </a:solidFill>
-          <a:ln/>
-        </p:spPr>
-      </p:sp>
-      <p:sp>
-        <p:nvSpPr>
-          <p:cNvPr id="110" name="Text 89"/>
-          <p:cNvSpPr/>
-          <p:nvPr/>
-        </p:nvSpPr>
-        <p:spPr>
-          <a:xfrm>
-            <a:off x="457200" y="8485632"/>
-            <a:ext cx="3017520" cy="237744"/>
-          </a:xfrm>
-          <a:prstGeom prst="rect">
-            <a:avLst/>
-          </a:prstGeom>
-          <a:noFill/>
-          <a:ln/>
-        </p:spPr>
-        <p:txBody>
-          <a:bodyPr wrap="square" lIns="0" tIns="0" rIns="0" bIns="0" rtlCol="0" anchor="ctr"/>
-          <a:lstStyle/>
-          <a:p>
-            <a:pPr algn="ctr" indent="0" marL="0">
-              <a:buNone/>
-            </a:pPr>
-            <a:r>
-              <a:rPr lang="en-US" sz="780" b="1" spc="150" kern="0" dirty="0">
-                <a:solidFill>
-                  <a:srgbClr val="FFFFFF"/>
-                </a:solidFill>
-                <a:latin typeface="Arial" pitchFamily="34" charset="0"/>
-                <a:ea typeface="Arial" pitchFamily="34" charset="-122"/>
-                <a:cs typeface="Arial" pitchFamily="34" charset="-120"/>
-              </a:rPr>
-              <a:t>6. IMMEDIATE WITHDRAWAL</a:t>
-            </a:r>
-            <a:endParaRPr lang="en-US" sz="780" dirty="0"/>
-          </a:p>
-        </p:txBody>
-      </p:sp>
-      <p:sp>
-        <p:nvSpPr>
-          <p:cNvPr id="111" name="Shape 90"/>
-          <p:cNvSpPr/>
-          <p:nvPr/>
-        </p:nvSpPr>
-        <p:spPr>
-          <a:xfrm>
-            <a:off x="457200" y="8723376"/>
-            <a:ext cx="3017520" cy="1335024"/>
-          </a:xfrm>
-          <a:prstGeom prst="rect">
-            <a:avLst/>
-          </a:prstGeom>
-          <a:solidFill>
-            <a:srgbClr val="CDD2B7">
-              <a:alpha val="28000"/>
-            </a:srgbClr>
-          </a:solidFill>
-          <a:ln/>
-        </p:spPr>
-      </p:sp>
-      <p:pic>
-        <p:nvPicPr>
-          <p:cNvPr id="112" name="Image 19" descr="preencoded.png">    </p:cNvPr>
-          <p:cNvPicPr>
-            <a:picLocks noChangeAspect="1"/>
-          </p:cNvPicPr>
-          <p:nvPr/>
-        </p:nvPicPr>
-        <p:blipFill>
-          <a:blip r:embed="rId20"/>
-          <a:stretch>
-            <a:fillRect/>
-          </a:stretch>
-        </p:blipFill>
-        <p:spPr>
-          <a:xfrm>
-            <a:off x="585216" y="8869680"/>
-            <a:ext cx="310896" cy="310896"/>
-          </a:xfrm>
-          <a:prstGeom prst="rect">
-            <a:avLst/>
-          </a:prstGeom>
-        </p:spPr>
-      </p:pic>
-      <p:sp>
-        <p:nvSpPr>
-          <p:cNvPr id="113" name="Text 91"/>
-          <p:cNvSpPr/>
-          <p:nvPr/>
-        </p:nvSpPr>
-        <p:spPr>
-          <a:xfrm>
-            <a:off x="1005840" y="8833104"/>
-            <a:ext cx="2331720" cy="1115568"/>
-          </a:xfrm>
-          <a:prstGeom prst="rect">
-            <a:avLst/>
-          </a:prstGeom>
-          <a:noFill/>
-          <a:ln/>
-        </p:spPr>
-        <p:txBody>
-          <a:bodyPr wrap="square" lIns="0" tIns="0" rIns="0" bIns="0" rtlCol="0" anchor="t"/>
-          <a:lstStyle/>
-          <a:p>
-            <a:pPr algn="l" indent="0" marL="0">
-              <a:buNone/>
-            </a:pPr>
-            <a:r>
-              <a:rPr lang="en-US" sz="730" dirty="0">
-                <a:solidFill>
-                  <a:srgbClr val="000000"/>
-                </a:solidFill>
-                <a:latin typeface="Arial" pitchFamily="34" charset="0"/>
-                <a:ea typeface="Arial" pitchFamily="34" charset="-122"/>
-                <a:cs typeface="Arial" pitchFamily="34" charset="-120"/>
-              </a:rPr>
-              <a:t>An instructor, safety staff member or medical practitioner may immediately stop or withdraw a participant to manage an immediate safety or medical risk, informing CI NZALC and CI NCO School as soon as practicable.</a:t>
-            </a:r>
-            <a:endParaRPr lang="en-US" sz="730" dirty="0"/>
-          </a:p>
-        </p:txBody>
-      </p:sp>
-      <p:sp>
-        <p:nvSpPr>
-          <p:cNvPr id="114" name="Shape 92"/>
-          <p:cNvSpPr/>
-          <p:nvPr/>
-        </p:nvSpPr>
-        <p:spPr>
-          <a:xfrm>
-            <a:off x="3630168" y="8485632"/>
-            <a:ext cx="3474720" cy="237744"/>
-          </a:xfrm>
-          <a:prstGeom prst="rect">
-            <a:avLst/>
-          </a:prstGeom>
-          <a:solidFill>
-            <a:srgbClr val="002516"/>
-          </a:solidFill>
-          <a:ln/>
-        </p:spPr>
-      </p:sp>
-      <p:sp>
-        <p:nvSpPr>
-          <p:cNvPr id="115" name="Text 93"/>
-          <p:cNvSpPr/>
-          <p:nvPr/>
-        </p:nvSpPr>
-        <p:spPr>
-          <a:xfrm>
-            <a:off x="3630168" y="8485632"/>
-            <a:ext cx="3474720" cy="237744"/>
-          </a:xfrm>
-          <a:prstGeom prst="rect">
-            <a:avLst/>
-          </a:prstGeom>
-          <a:noFill/>
-          <a:ln/>
-        </p:spPr>
-        <p:txBody>
-          <a:bodyPr wrap="square" lIns="0" tIns="0" rIns="0" bIns="0" rtlCol="0" anchor="ctr"/>
-          <a:lstStyle/>
-          <a:p>
-            <a:pPr algn="ctr" indent="0" marL="0">
-              <a:buNone/>
-            </a:pPr>
-            <a:r>
-              <a:rPr lang="en-US" sz="780" b="1" spc="150" kern="0" dirty="0">
-                <a:solidFill>
-                  <a:srgbClr val="FFFFFF"/>
-                </a:solidFill>
-                <a:latin typeface="Arial" pitchFamily="34" charset="0"/>
-                <a:ea typeface="Arial" pitchFamily="34" charset="-122"/>
-                <a:cs typeface="Arial" pitchFamily="34" charset="-120"/>
-              </a:rPr>
-              <a:t>7. RECORD OF DECISION</a:t>
-            </a:r>
-            <a:endParaRPr lang="en-US" sz="780" dirty="0"/>
-          </a:p>
-        </p:txBody>
-      </p:sp>
-      <p:sp>
-        <p:nvSpPr>
-          <p:cNvPr id="116" name="Shape 94"/>
-          <p:cNvSpPr/>
-          <p:nvPr/>
-        </p:nvSpPr>
-        <p:spPr>
-          <a:xfrm>
-            <a:off x="3630168" y="8723376"/>
-            <a:ext cx="3474720" cy="1335024"/>
-          </a:xfrm>
-          <a:prstGeom prst="rect">
-            <a:avLst/>
-          </a:prstGeom>
-          <a:solidFill>
-            <a:srgbClr val="FFFFFF"/>
-          </a:solidFill>
-          <a:ln w="9525">
-            <a:solidFill>
-              <a:srgbClr val="A89662"/>
-            </a:solidFill>
-            <a:prstDash val="solid"/>
-          </a:ln>
-        </p:spPr>
-      </p:sp>
-      <p:sp>
-        <p:nvSpPr>
-          <p:cNvPr id="117" name="Text 95"/>
+          <p:cNvPr id="106" name="Text 86"/>
           <p:cNvSpPr/>
           <p:nvPr/>
         </p:nvSpPr>
@@ -4470,7 +4175,7 @@
       </p:sp>
       <p:sp>
         <p:nvSpPr>
-          <p:cNvPr id="118" name="Text 96"/>
+          <p:cNvPr id="107" name="Text 87"/>
           <p:cNvSpPr/>
           <p:nvPr/>
         </p:nvSpPr>
@@ -4509,7 +4214,7 @@
       </p:sp>
       <p:sp>
         <p:nvSpPr>
-          <p:cNvPr id="119" name="Text 97"/>
+          <p:cNvPr id="108" name="Text 88"/>
           <p:cNvSpPr/>
           <p:nvPr/>
         </p:nvSpPr>
@@ -4548,7 +4253,7 @@
       </p:sp>
       <p:sp>
         <p:nvSpPr>
-          <p:cNvPr id="120" name="Text 98"/>
+          <p:cNvPr id="109" name="Text 89"/>
           <p:cNvSpPr/>
           <p:nvPr/>
         </p:nvSpPr>
@@ -4587,7 +4292,7 @@
       </p:sp>
       <p:sp>
         <p:nvSpPr>
-          <p:cNvPr id="121" name="Text 99"/>
+          <p:cNvPr id="110" name="Text 90"/>
           <p:cNvSpPr/>
           <p:nvPr/>
         </p:nvSpPr>
@@ -4626,7 +4331,7 @@
       </p:sp>
       <p:sp>
         <p:nvSpPr>
-          <p:cNvPr id="122" name="Text 100"/>
+          <p:cNvPr id="111" name="Text 91"/>
           <p:cNvSpPr/>
           <p:nvPr/>
         </p:nvSpPr>
@@ -4665,7 +4370,7 @@
       </p:sp>
       <p:sp>
         <p:nvSpPr>
-          <p:cNvPr id="123" name="Text 101"/>
+          <p:cNvPr id="112" name="Text 92"/>
           <p:cNvSpPr/>
           <p:nvPr/>
         </p:nvSpPr>
@@ -4704,7 +4409,7 @@
       </p:sp>
       <p:sp>
         <p:nvSpPr>
-          <p:cNvPr id="124" name="Text 102"/>
+          <p:cNvPr id="113" name="Text 93"/>
           <p:cNvSpPr/>
           <p:nvPr/>
         </p:nvSpPr>
@@ -4743,7 +4448,7 @@
       </p:sp>
       <p:sp>
         <p:nvSpPr>
-          <p:cNvPr id="125" name="Text 103"/>
+          <p:cNvPr id="114" name="Text 94"/>
           <p:cNvSpPr/>
           <p:nvPr/>
         </p:nvSpPr>
@@ -4782,7 +4487,7 @@
       </p:sp>
       <p:sp>
         <p:nvSpPr>
-          <p:cNvPr id="126" name="Text 104"/>
+          <p:cNvPr id="115" name="Text 95"/>
           <p:cNvSpPr/>
           <p:nvPr/>
         </p:nvSpPr>
@@ -4821,7 +4526,7 @@
       </p:sp>
       <p:sp>
         <p:nvSpPr>
-          <p:cNvPr id="127" name="Text 105"/>
+          <p:cNvPr id="116" name="Text 96"/>
           <p:cNvSpPr/>
           <p:nvPr/>
         </p:nvSpPr>
@@ -4860,7 +4565,7 @@
       </p:sp>
       <p:sp>
         <p:nvSpPr>
-          <p:cNvPr id="128" name="Text 106"/>
+          <p:cNvPr id="117" name="Text 97"/>
           <p:cNvSpPr/>
           <p:nvPr/>
         </p:nvSpPr>

</xml_diff>

<commit_message>
Visual model brevity pass: 30-second field readability
Removed UNCLASSIFIED marks, 1-Page Visual Model line and version
footer; two-line subtitle. All sections tightened per direction:
one-line purpose, shorter governing principle, protects-captions
removed, tightened grounds and test wording, one-line decision steps
(Observe / Intervene / Decide), shortened immediate-withdrawal text
and record checklist. Reclaimed space used for larger type.

Co-Authored-By: Claude Fable 5 <noreply@anthropic.com>
Claude-Session: https://claude.ai/code/session_01YLo1WfwUDkbwfJEF3ZNVbB
</commit_message>
<xml_diff>
--- a/output/withdrawal-sop-visual.pptx
+++ b/output/withdrawal-sop-visual.pptx
@@ -875,165 +875,9 @@
           <a:chExt cx="0" cy="0"/>
         </a:xfrm>
       </p:grpSpPr>
-      <p:sp>
-        <p:nvSpPr>
-          <p:cNvPr id="2" name="Text 0"/>
-          <p:cNvSpPr/>
-          <p:nvPr/>
-        </p:nvSpPr>
-        <p:spPr>
-          <a:xfrm>
-            <a:off x="0" y="18288"/>
-            <a:ext cx="7562088" cy="164592"/>
-          </a:xfrm>
-          <a:prstGeom prst="rect">
-            <a:avLst/>
-          </a:prstGeom>
-          <a:noFill/>
-          <a:ln/>
-        </p:spPr>
-        <p:txBody>
-          <a:bodyPr wrap="square" lIns="0" tIns="0" rIns="0" bIns="0" rtlCol="0" anchor="ctr"/>
-          <a:lstStyle/>
-          <a:p>
-            <a:pPr algn="ctr" indent="0" marL="0">
-              <a:buNone/>
-            </a:pPr>
-            <a:r>
-              <a:rPr lang="en-US" sz="750" b="1" spc="400" kern="0" dirty="0">
-                <a:solidFill>
-                  <a:srgbClr val="000000"/>
-                </a:solidFill>
-                <a:latin typeface="Arial" pitchFamily="34" charset="0"/>
-                <a:ea typeface="Arial" pitchFamily="34" charset="-122"/>
-                <a:cs typeface="Arial" pitchFamily="34" charset="-120"/>
-              </a:rPr>
-              <a:t>UNCLASSIFIED</a:t>
-            </a:r>
-            <a:endParaRPr lang="en-US" sz="750" dirty="0"/>
-          </a:p>
-        </p:txBody>
-      </p:sp>
-      <p:sp>
-        <p:nvSpPr>
-          <p:cNvPr id="3" name="Text 1"/>
-          <p:cNvSpPr/>
-          <p:nvPr/>
-        </p:nvSpPr>
-        <p:spPr>
-          <a:xfrm>
-            <a:off x="0" y="10506456"/>
-            <a:ext cx="7562088" cy="164592"/>
-          </a:xfrm>
-          <a:prstGeom prst="rect">
-            <a:avLst/>
-          </a:prstGeom>
-          <a:noFill/>
-          <a:ln/>
-        </p:spPr>
-        <p:txBody>
-          <a:bodyPr wrap="square" lIns="0" tIns="0" rIns="0" bIns="0" rtlCol="0" anchor="ctr"/>
-          <a:lstStyle/>
-          <a:p>
-            <a:pPr algn="ctr" indent="0" marL="0">
-              <a:buNone/>
-            </a:pPr>
-            <a:r>
-              <a:rPr lang="en-US" sz="750" b="1" spc="400" kern="0" dirty="0">
-                <a:solidFill>
-                  <a:srgbClr val="000000"/>
-                </a:solidFill>
-                <a:latin typeface="Arial" pitchFamily="34" charset="0"/>
-                <a:ea typeface="Arial" pitchFamily="34" charset="-122"/>
-                <a:cs typeface="Arial" pitchFamily="34" charset="-120"/>
-              </a:rPr>
-              <a:t>UNCLASSIFIED</a:t>
-            </a:r>
-            <a:endParaRPr lang="en-US" sz="750" dirty="0"/>
-          </a:p>
-        </p:txBody>
-      </p:sp>
-      <p:sp>
-        <p:nvSpPr>
-          <p:cNvPr id="4" name="Text 2"/>
-          <p:cNvSpPr/>
-          <p:nvPr/>
-        </p:nvSpPr>
-        <p:spPr>
-          <a:xfrm>
-            <a:off x="457200" y="10506456"/>
-            <a:ext cx="2377440" cy="164592"/>
-          </a:xfrm>
-          <a:prstGeom prst="rect">
-            <a:avLst/>
-          </a:prstGeom>
-          <a:noFill/>
-          <a:ln/>
-        </p:spPr>
-        <p:txBody>
-          <a:bodyPr wrap="square" lIns="0" tIns="0" rIns="0" bIns="0" rtlCol="0" anchor="ctr"/>
-          <a:lstStyle/>
-          <a:p>
-            <a:pPr algn="l" indent="0" marL="0">
-              <a:buNone/>
-            </a:pPr>
-            <a:r>
-              <a:rPr lang="en-US" sz="600" dirty="0">
-                <a:solidFill>
-                  <a:srgbClr val="000000"/>
-                </a:solidFill>
-                <a:latin typeface="Arial" pitchFamily="34" charset="0"/>
-                <a:ea typeface="Arial" pitchFamily="34" charset="-122"/>
-                <a:cs typeface="Arial" pitchFamily="34" charset="-120"/>
-              </a:rPr>
-              <a:t>Army Command School  ·  ACS 2026</a:t>
-            </a:r>
-            <a:endParaRPr lang="en-US" sz="600" dirty="0"/>
-          </a:p>
-        </p:txBody>
-      </p:sp>
-      <p:sp>
-        <p:nvSpPr>
-          <p:cNvPr id="5" name="Text 3"/>
-          <p:cNvSpPr/>
-          <p:nvPr/>
-        </p:nvSpPr>
-        <p:spPr>
-          <a:xfrm>
-            <a:off x="5212080" y="10506456"/>
-            <a:ext cx="1892808" cy="164592"/>
-          </a:xfrm>
-          <a:prstGeom prst="rect">
-            <a:avLst/>
-          </a:prstGeom>
-          <a:noFill/>
-          <a:ln/>
-        </p:spPr>
-        <p:txBody>
-          <a:bodyPr wrap="square" lIns="0" tIns="0" rIns="0" bIns="0" rtlCol="0" anchor="ctr"/>
-          <a:lstStyle/>
-          <a:p>
-            <a:pPr algn="r" indent="0" marL="0">
-              <a:buNone/>
-            </a:pPr>
-            <a:r>
-              <a:rPr lang="en-US" sz="600" dirty="0">
-                <a:solidFill>
-                  <a:srgbClr val="000000"/>
-                </a:solidFill>
-                <a:latin typeface="Arial" pitchFamily="34" charset="0"/>
-                <a:ea typeface="Arial" pitchFamily="34" charset="-122"/>
-                <a:cs typeface="Arial" pitchFamily="34" charset="-120"/>
-              </a:rPr>
-              <a:t>Draft v0.1  ·  July 2026</a:t>
-            </a:r>
-            <a:endParaRPr lang="en-US" sz="600" dirty="0"/>
-          </a:p>
-        </p:txBody>
-      </p:sp>
       <p:pic>
         <p:nvPicPr>
-          <p:cNvPr id="6" name="Image 0" descr="/tmp/claude-0/-home-user-PUP/2d4cec0e-a52e-5368-bb54-803c6f37698d/scratchpad/logo-trimmed.png">    </p:cNvPr>
+          <p:cNvPr id="2" name="Image 0" descr="/tmp/claude-0/-home-user-PUP/2d4cec0e-a52e-5368-bb54-803c6f37698d/scratchpad/logo-trimmed.png">    </p:cNvPr>
           <p:cNvPicPr>
             <a:picLocks noChangeAspect="1"/>
           </p:cNvPicPr>
@@ -1047,7 +891,7 @@
         </p:blipFill>
         <p:spPr>
           <a:xfrm>
-            <a:off x="457200" y="292608"/>
+            <a:off x="457200" y="384048"/>
             <a:ext cx="960120" cy="232258"/>
           </a:xfrm>
           <a:prstGeom prst="rect">
@@ -1057,13 +901,13 @@
       </p:pic>
       <p:sp>
         <p:nvSpPr>
-          <p:cNvPr id="7" name="Text 4"/>
-          <p:cNvSpPr/>
-          <p:nvPr/>
-        </p:nvSpPr>
-        <p:spPr>
-          <a:xfrm>
-            <a:off x="1572768" y="237744"/>
+          <p:cNvPr id="3" name="Text 0"/>
+          <p:cNvSpPr/>
+          <p:nvPr/>
+        </p:nvSpPr>
+        <p:spPr>
+          <a:xfrm>
+            <a:off x="1572768" y="292608"/>
             <a:ext cx="5532120" cy="237744"/>
           </a:xfrm>
           <a:prstGeom prst="rect">
@@ -1096,14 +940,14 @@
       </p:sp>
       <p:sp>
         <p:nvSpPr>
-          <p:cNvPr id="8" name="Text 5"/>
-          <p:cNvSpPr/>
-          <p:nvPr/>
-        </p:nvSpPr>
-        <p:spPr>
-          <a:xfrm>
-            <a:off x="1572768" y="484632"/>
-            <a:ext cx="5532120" cy="164592"/>
+          <p:cNvPr id="4" name="Text 1"/>
+          <p:cNvSpPr/>
+          <p:nvPr/>
+        </p:nvSpPr>
+        <p:spPr>
+          <a:xfrm>
+            <a:off x="1572768" y="539496"/>
+            <a:ext cx="5532120" cy="155448"/>
           </a:xfrm>
           <a:prstGeom prst="rect">
             <a:avLst/>
@@ -1119,7 +963,7 @@
               <a:buNone/>
             </a:pPr>
             <a:r>
-              <a:rPr lang="en-US" sz="760" b="1" i="1" dirty="0">
+              <a:rPr lang="en-US" sz="860" b="1" i="1" dirty="0">
                 <a:solidFill>
                   <a:srgbClr val="3A4B00"/>
                 </a:solidFill>
@@ -1127,8 +971,33 @@
                 <a:ea typeface="Arial" pitchFamily="34" charset="-122"/>
                 <a:cs typeface="Arial" pitchFamily="34" charset="-120"/>
               </a:rPr>
-              <a:t>1-Page Visual Model</a:t>
-            </a:r>
+              <a:t>Warrant Officers Adventure Race</a:t>
+            </a:r>
+            <a:endParaRPr lang="en-US" sz="860" dirty="0"/>
+          </a:p>
+        </p:txBody>
+      </p:sp>
+      <p:sp>
+        <p:nvSpPr>
+          <p:cNvPr id="5" name="Text 2"/>
+          <p:cNvSpPr/>
+          <p:nvPr/>
+        </p:nvSpPr>
+        <p:spPr>
+          <a:xfrm>
+            <a:off x="1572768" y="694944"/>
+            <a:ext cx="5532120" cy="146304"/>
+          </a:xfrm>
+          <a:prstGeom prst="rect">
+            <a:avLst/>
+          </a:prstGeom>
+          <a:noFill/>
+          <a:ln/>
+        </p:spPr>
+        <p:txBody>
+          <a:bodyPr wrap="square" lIns="0" tIns="0" rIns="0" bIns="0" rtlCol="0" anchor="ctr"/>
+          <a:lstStyle/>
+          <a:p>
             <a:pPr algn="l" indent="0" marL="0">
               <a:buNone/>
             </a:pPr>
@@ -1141,7 +1010,7 @@
                 <a:ea typeface="Arial" pitchFamily="34" charset="-122"/>
                 <a:cs typeface="Arial" pitchFamily="34" charset="-120"/>
               </a:rPr>
-              <a:t>   ·   Warrant Officers Adventure Race   ·   NZ Army Leadership Centre | Army Command School</a:t>
+              <a:t>NZ Army Leadership Centre | Army Command School</a:t>
             </a:r>
             <a:endParaRPr lang="en-US" sz="760" dirty="0"/>
           </a:p>
@@ -1149,13 +1018,13 @@
       </p:sp>
       <p:sp>
         <p:nvSpPr>
-          <p:cNvPr id="9" name="Shape 6"/>
-          <p:cNvSpPr/>
-          <p:nvPr/>
-        </p:nvSpPr>
-        <p:spPr>
-          <a:xfrm>
-            <a:off x="457200" y="768096"/>
+          <p:cNvPr id="6" name="Shape 3"/>
+          <p:cNvSpPr/>
+          <p:nvPr/>
+        </p:nvSpPr>
+        <p:spPr>
+          <a:xfrm>
+            <a:off x="457200" y="932688"/>
             <a:ext cx="6647688" cy="0"/>
           </a:xfrm>
           <a:prstGeom prst="line">
@@ -1172,7 +1041,7 @@
       </p:sp>
       <p:pic>
         <p:nvPicPr>
-          <p:cNvPr id="10" name="Image 1" descr="preencoded.png">    </p:cNvPr>
+          <p:cNvPr id="7" name="Image 1" descr="preencoded.png">    </p:cNvPr>
           <p:cNvPicPr>
             <a:picLocks noChangeAspect="1"/>
           </p:cNvPicPr>
@@ -1186,7 +1055,7 @@
         </p:blipFill>
         <p:spPr>
           <a:xfrm>
-            <a:off x="457200" y="896112"/>
+            <a:off x="457200" y="1115568"/>
             <a:ext cx="274320" cy="274320"/>
           </a:xfrm>
           <a:prstGeom prst="rect">
@@ -1196,14 +1065,112 @@
       </p:pic>
       <p:sp>
         <p:nvSpPr>
+          <p:cNvPr id="8" name="Text 4"/>
+          <p:cNvSpPr/>
+          <p:nvPr/>
+        </p:nvSpPr>
+        <p:spPr>
+          <a:xfrm>
+            <a:off x="841248" y="1097280"/>
+            <a:ext cx="3776472" cy="182880"/>
+          </a:xfrm>
+          <a:prstGeom prst="rect">
+            <a:avLst/>
+          </a:prstGeom>
+          <a:noFill/>
+          <a:ln/>
+        </p:spPr>
+        <p:txBody>
+          <a:bodyPr wrap="square" lIns="0" tIns="0" rIns="0" bIns="0" rtlCol="0" anchor="ctr"/>
+          <a:lstStyle/>
+          <a:p>
+            <a:pPr algn="l" indent="0" marL="0">
+              <a:buNone/>
+            </a:pPr>
+            <a:r>
+              <a:rPr lang="en-US" sz="1000" b="1" spc="150" kern="0" dirty="0">
+                <a:solidFill>
+                  <a:srgbClr val="002516"/>
+                </a:solidFill>
+                <a:latin typeface="Arial" pitchFamily="34" charset="0"/>
+                <a:ea typeface="Arial" pitchFamily="34" charset="-122"/>
+                <a:cs typeface="Arial" pitchFamily="34" charset="-120"/>
+              </a:rPr>
+              <a:t>1. PURPOSE</a:t>
+            </a:r>
+            <a:endParaRPr lang="en-US" sz="1000" dirty="0"/>
+          </a:p>
+        </p:txBody>
+      </p:sp>
+      <p:sp>
+        <p:nvSpPr>
+          <p:cNvPr id="9" name="Text 5"/>
+          <p:cNvSpPr/>
+          <p:nvPr/>
+        </p:nvSpPr>
+        <p:spPr>
+          <a:xfrm>
+            <a:off x="841248" y="1280160"/>
+            <a:ext cx="3730752" cy="329184"/>
+          </a:xfrm>
+          <a:prstGeom prst="rect">
+            <a:avLst/>
+          </a:prstGeom>
+          <a:noFill/>
+          <a:ln/>
+        </p:spPr>
+        <p:txBody>
+          <a:bodyPr wrap="square" lIns="0" tIns="0" rIns="0" bIns="0" rtlCol="0" anchor="t"/>
+          <a:lstStyle/>
+          <a:p>
+            <a:pPr algn="l" indent="0" marL="0">
+              <a:buNone/>
+            </a:pPr>
+            <a:r>
+              <a:rPr lang="en-US" sz="860" dirty="0">
+                <a:solidFill>
+                  <a:srgbClr val="000000"/>
+                </a:solidFill>
+                <a:latin typeface="Arial" pitchFamily="34" charset="0"/>
+                <a:ea typeface="Arial" pitchFamily="34" charset="-122"/>
+                <a:cs typeface="Arial" pitchFamily="34" charset="-120"/>
+              </a:rPr>
+              <a:t>Provide a fair, consistent and defensible process for participant withdrawal.</a:t>
+            </a:r>
+            <a:endParaRPr lang="en-US" sz="860" dirty="0"/>
+          </a:p>
+        </p:txBody>
+      </p:sp>
+      <p:sp>
+        <p:nvSpPr>
+          <p:cNvPr id="10" name="Shape 6"/>
+          <p:cNvSpPr/>
+          <p:nvPr/>
+        </p:nvSpPr>
+        <p:spPr>
+          <a:xfrm>
+            <a:off x="457200" y="1755648"/>
+            <a:ext cx="4160520" cy="274320"/>
+          </a:xfrm>
+          <a:prstGeom prst="rect">
+            <a:avLst/>
+          </a:prstGeom>
+          <a:solidFill>
+            <a:srgbClr val="002516"/>
+          </a:solidFill>
+          <a:ln/>
+        </p:spPr>
+      </p:sp>
+      <p:sp>
+        <p:nvSpPr>
           <p:cNvPr id="11" name="Text 7"/>
           <p:cNvSpPr/>
           <p:nvPr/>
         </p:nvSpPr>
         <p:spPr>
           <a:xfrm>
-            <a:off x="822960" y="896112"/>
-            <a:ext cx="3794760" cy="182880"/>
+            <a:off x="457200" y="1755648"/>
+            <a:ext cx="4160520" cy="274320"/>
           </a:xfrm>
           <a:prstGeom prst="rect">
             <a:avLst/>
@@ -1215,109 +1182,11 @@
           <a:bodyPr wrap="square" lIns="0" tIns="0" rIns="0" bIns="0" rtlCol="0" anchor="ctr"/>
           <a:lstStyle/>
           <a:p>
-            <a:pPr algn="l" indent="0" marL="0">
-              <a:buNone/>
-            </a:pPr>
-            <a:r>
-              <a:rPr lang="en-US" sz="950" b="1" spc="150" kern="0" dirty="0">
-                <a:solidFill>
-                  <a:srgbClr val="002516"/>
-                </a:solidFill>
-                <a:latin typeface="Arial" pitchFamily="34" charset="0"/>
-                <a:ea typeface="Arial" pitchFamily="34" charset="-122"/>
-                <a:cs typeface="Arial" pitchFamily="34" charset="-120"/>
-              </a:rPr>
-              <a:t>1. PURPOSE</a:t>
-            </a:r>
-            <a:endParaRPr lang="en-US" sz="950" dirty="0"/>
-          </a:p>
-        </p:txBody>
-      </p:sp>
-      <p:sp>
-        <p:nvSpPr>
-          <p:cNvPr id="12" name="Text 8"/>
-          <p:cNvSpPr/>
-          <p:nvPr/>
-        </p:nvSpPr>
-        <p:spPr>
-          <a:xfrm>
-            <a:off x="822960" y="1078992"/>
-            <a:ext cx="3749040" cy="566928"/>
-          </a:xfrm>
-          <a:prstGeom prst="rect">
-            <a:avLst/>
-          </a:prstGeom>
-          <a:noFill/>
-          <a:ln/>
-        </p:spPr>
-        <p:txBody>
-          <a:bodyPr wrap="square" lIns="0" tIns="0" rIns="0" bIns="0" rtlCol="0" anchor="t"/>
-          <a:lstStyle/>
-          <a:p>
-            <a:pPr algn="l" indent="0" marL="0">
-              <a:buNone/>
-            </a:pPr>
-            <a:r>
-              <a:rPr lang="en-US" sz="780" dirty="0">
-                <a:solidFill>
-                  <a:srgbClr val="000000"/>
-                </a:solidFill>
-                <a:latin typeface="Arial" pitchFamily="34" charset="0"/>
-                <a:ea typeface="Arial" pitchFamily="34" charset="-122"/>
-                <a:cs typeface="Arial" pitchFamily="34" charset="-120"/>
-              </a:rPr>
-              <a:t>Provide a consistent, fair and defensible process for deciding whether a participant is withdrawn from the Adventure Race for safety, medical, conduct or performance reasons.</a:t>
-            </a:r>
-            <a:endParaRPr lang="en-US" sz="780" dirty="0"/>
-          </a:p>
-        </p:txBody>
-      </p:sp>
-      <p:sp>
-        <p:nvSpPr>
-          <p:cNvPr id="13" name="Shape 9"/>
-          <p:cNvSpPr/>
-          <p:nvPr/>
-        </p:nvSpPr>
-        <p:spPr>
-          <a:xfrm>
-            <a:off x="457200" y="1755648"/>
-            <a:ext cx="4160520" cy="237744"/>
-          </a:xfrm>
-          <a:prstGeom prst="rect">
-            <a:avLst/>
-          </a:prstGeom>
-          <a:solidFill>
-            <a:srgbClr val="002516"/>
-          </a:solidFill>
-          <a:ln/>
-        </p:spPr>
-      </p:sp>
-      <p:sp>
-        <p:nvSpPr>
-          <p:cNvPr id="14" name="Text 10"/>
-          <p:cNvSpPr/>
-          <p:nvPr/>
-        </p:nvSpPr>
-        <p:spPr>
-          <a:xfrm>
-            <a:off x="457200" y="1755648"/>
-            <a:ext cx="4160520" cy="237744"/>
-          </a:xfrm>
-          <a:prstGeom prst="rect">
-            <a:avLst/>
-          </a:prstGeom>
-          <a:noFill/>
-          <a:ln/>
-        </p:spPr>
-        <p:txBody>
-          <a:bodyPr wrap="square" lIns="0" tIns="0" rIns="0" bIns="0" rtlCol="0" anchor="ctr"/>
-          <a:lstStyle/>
-          <a:p>
             <a:pPr algn="ctr" indent="0" marL="0">
               <a:buNone/>
             </a:pPr>
             <a:r>
-              <a:rPr lang="en-US" sz="860" b="1" spc="150" kern="0" dirty="0">
+              <a:rPr lang="en-US" sz="900" b="1" spc="150" kern="0" dirty="0">
                 <a:solidFill>
                   <a:srgbClr val="FFFFFF"/>
                 </a:solidFill>
@@ -1327,20 +1196,20 @@
               </a:rPr>
               <a:t>2. GOVERNING PRINCIPLE</a:t>
             </a:r>
-            <a:endParaRPr lang="en-US" sz="860" dirty="0"/>
-          </a:p>
-        </p:txBody>
-      </p:sp>
-      <p:sp>
-        <p:nvSpPr>
-          <p:cNvPr id="15" name="Shape 11"/>
-          <p:cNvSpPr/>
-          <p:nvPr/>
-        </p:nvSpPr>
-        <p:spPr>
-          <a:xfrm>
-            <a:off x="457200" y="1993392"/>
-            <a:ext cx="4160520" cy="1810512"/>
+            <a:endParaRPr lang="en-US" sz="900" dirty="0"/>
+          </a:p>
+        </p:txBody>
+      </p:sp>
+      <p:sp>
+        <p:nvSpPr>
+          <p:cNvPr id="12" name="Shape 8"/>
+          <p:cNvSpPr/>
+          <p:nvPr/>
+        </p:nvSpPr>
+        <p:spPr>
+          <a:xfrm>
+            <a:off x="457200" y="2029968"/>
+            <a:ext cx="4160520" cy="1828800"/>
           </a:xfrm>
           <a:prstGeom prst="rect">
             <a:avLst/>
@@ -1355,14 +1224,14 @@
       </p:sp>
       <p:sp>
         <p:nvSpPr>
-          <p:cNvPr id="16" name="Text 12"/>
-          <p:cNvSpPr/>
-          <p:nvPr/>
-        </p:nvSpPr>
-        <p:spPr>
-          <a:xfrm>
-            <a:off x="585216" y="2084832"/>
-            <a:ext cx="3904488" cy="658368"/>
+          <p:cNvPr id="13" name="Text 9"/>
+          <p:cNvSpPr/>
+          <p:nvPr/>
+        </p:nvSpPr>
+        <p:spPr>
+          <a:xfrm>
+            <a:off x="603504" y="2139696"/>
+            <a:ext cx="3867912" cy="603504"/>
           </a:xfrm>
           <a:prstGeom prst="rect">
             <a:avLst/>
@@ -1378,7 +1247,7 @@
               <a:buNone/>
             </a:pPr>
             <a:r>
-              <a:rPr lang="en-US" sz="770" dirty="0">
+              <a:rPr lang="en-US" sz="820" dirty="0">
                 <a:solidFill>
                   <a:srgbClr val="000000"/>
                 </a:solidFill>
@@ -1386,22 +1255,22 @@
                 <a:ea typeface="Arial" pitchFamily="34" charset="-122"/>
                 <a:cs typeface="Arial" pitchFamily="34" charset="-120"/>
               </a:rPr>
-              <a:t>The Adventure Race deliberately exposes participants and teams to pressure, fatigue, adversity, uncertainty and interpersonal friction in support of approved learning objectives. Withdrawal is justified only where a participant's condition, capability or conduct materially prevents:</a:t>
-            </a:r>
-            <a:endParaRPr lang="en-US" sz="770" dirty="0"/>
-          </a:p>
-        </p:txBody>
-      </p:sp>
-      <p:sp>
-        <p:nvSpPr>
-          <p:cNvPr id="17" name="Shape 13"/>
-          <p:cNvSpPr/>
-          <p:nvPr/>
-        </p:nvSpPr>
-        <p:spPr>
-          <a:xfrm>
-            <a:off x="912876" y="2834640"/>
-            <a:ext cx="475488" cy="475488"/>
+              <a:t>The Adventure Race deliberately creates pressure, fatigue, uncertainty and adversity to achieve approved learning objectives. Withdrawal is justified only where a participant's condition or conduct materially prevents:</a:t>
+            </a:r>
+            <a:endParaRPr lang="en-US" sz="820" dirty="0"/>
+          </a:p>
+        </p:txBody>
+      </p:sp>
+      <p:sp>
+        <p:nvSpPr>
+          <p:cNvPr id="14" name="Shape 10"/>
+          <p:cNvSpPr/>
+          <p:nvPr/>
+        </p:nvSpPr>
+        <p:spPr>
+          <a:xfrm>
+            <a:off x="903732" y="2788920"/>
+            <a:ext cx="493776" cy="493776"/>
           </a:xfrm>
           <a:prstGeom prst="ellipse">
             <a:avLst/>
@@ -1419,7 +1288,7 @@
       </p:sp>
       <p:pic>
         <p:nvPicPr>
-          <p:cNvPr id="18" name="Image 2" descr="preencoded.png">    </p:cNvPr>
+          <p:cNvPr id="15" name="Image 2" descr="preencoded.png">    </p:cNvPr>
           <p:cNvPicPr>
             <a:picLocks noChangeAspect="1"/>
           </p:cNvPicPr>
@@ -1433,8 +1302,8 @@
         </p:blipFill>
         <p:spPr>
           <a:xfrm>
-            <a:off x="1022604" y="2944368"/>
-            <a:ext cx="256032" cy="256032"/>
+            <a:off x="1018032" y="2903220"/>
+            <a:ext cx="265176" cy="265176"/>
           </a:xfrm>
           <a:prstGeom prst="rect">
             <a:avLst/>
@@ -1443,14 +1312,14 @@
       </p:pic>
       <p:sp>
         <p:nvSpPr>
-          <p:cNvPr id="19" name="Text 14"/>
-          <p:cNvSpPr/>
-          <p:nvPr/>
-        </p:nvSpPr>
-        <p:spPr>
-          <a:xfrm>
-            <a:off x="502920" y="3346704"/>
-            <a:ext cx="1295400" cy="402336"/>
+          <p:cNvPr id="16" name="Text 11"/>
+          <p:cNvSpPr/>
+          <p:nvPr/>
+        </p:nvSpPr>
+        <p:spPr>
+          <a:xfrm>
+            <a:off x="502920" y="3328416"/>
+            <a:ext cx="1295400" cy="457200"/>
           </a:xfrm>
           <a:prstGeom prst="rect">
             <a:avLst/>
@@ -1466,7 +1335,7 @@
               <a:buNone/>
             </a:pPr>
             <a:r>
-              <a:rPr lang="en-US" sz="660" b="1" dirty="0">
+              <a:rPr lang="en-US" sz="690" b="1" dirty="0">
                 <a:solidFill>
                   <a:srgbClr val="002516"/>
                 </a:solidFill>
@@ -1476,19 +1345,19 @@
               </a:rPr>
               <a:t>Safe participation</a:t>
             </a:r>
-            <a:endParaRPr lang="en-US" sz="660" dirty="0"/>
-          </a:p>
-        </p:txBody>
-      </p:sp>
-      <p:sp>
-        <p:nvSpPr>
-          <p:cNvPr id="20" name="Shape 15"/>
-          <p:cNvSpPr/>
-          <p:nvPr/>
-        </p:nvSpPr>
-        <p:spPr>
-          <a:xfrm>
-            <a:off x="1615440" y="3072384"/>
+            <a:endParaRPr lang="en-US" sz="690" dirty="0"/>
+          </a:p>
+        </p:txBody>
+      </p:sp>
+      <p:sp>
+        <p:nvSpPr>
+          <p:cNvPr id="17" name="Shape 12"/>
+          <p:cNvSpPr/>
+          <p:nvPr/>
+        </p:nvSpPr>
+        <p:spPr>
+          <a:xfrm>
+            <a:off x="1615440" y="3035808"/>
             <a:ext cx="457200" cy="0"/>
           </a:xfrm>
           <a:prstGeom prst="line">
@@ -1505,14 +1374,14 @@
       </p:sp>
       <p:sp>
         <p:nvSpPr>
-          <p:cNvPr id="21" name="Shape 16"/>
-          <p:cNvSpPr/>
-          <p:nvPr/>
-        </p:nvSpPr>
-        <p:spPr>
-          <a:xfrm>
-            <a:off x="2299716" y="2834640"/>
-            <a:ext cx="475488" cy="475488"/>
+          <p:cNvPr id="18" name="Shape 13"/>
+          <p:cNvSpPr/>
+          <p:nvPr/>
+        </p:nvSpPr>
+        <p:spPr>
+          <a:xfrm>
+            <a:off x="2290572" y="2788920"/>
+            <a:ext cx="493776" cy="493776"/>
           </a:xfrm>
           <a:prstGeom prst="ellipse">
             <a:avLst/>
@@ -1530,7 +1399,7 @@
       </p:sp>
       <p:pic>
         <p:nvPicPr>
-          <p:cNvPr id="22" name="Image 3" descr="preencoded.png">    </p:cNvPr>
+          <p:cNvPr id="19" name="Image 3" descr="preencoded.png">    </p:cNvPr>
           <p:cNvPicPr>
             <a:picLocks noChangeAspect="1"/>
           </p:cNvPicPr>
@@ -1544,8 +1413,8 @@
         </p:blipFill>
         <p:spPr>
           <a:xfrm>
-            <a:off x="2409444" y="2944368"/>
-            <a:ext cx="256032" cy="256032"/>
+            <a:off x="2404872" y="2903220"/>
+            <a:ext cx="265176" cy="265176"/>
           </a:xfrm>
           <a:prstGeom prst="rect">
             <a:avLst/>
@@ -1554,14 +1423,14 @@
       </p:pic>
       <p:sp>
         <p:nvSpPr>
-          <p:cNvPr id="23" name="Text 17"/>
-          <p:cNvSpPr/>
-          <p:nvPr/>
-        </p:nvSpPr>
-        <p:spPr>
-          <a:xfrm>
-            <a:off x="1889760" y="3346704"/>
-            <a:ext cx="1295400" cy="402336"/>
+          <p:cNvPr id="20" name="Text 14"/>
+          <p:cNvSpPr/>
+          <p:nvPr/>
+        </p:nvSpPr>
+        <p:spPr>
+          <a:xfrm>
+            <a:off x="1889760" y="3328416"/>
+            <a:ext cx="1295400" cy="457200"/>
           </a:xfrm>
           <a:prstGeom prst="rect">
             <a:avLst/>
@@ -1577,7 +1446,7 @@
               <a:buNone/>
             </a:pPr>
             <a:r>
-              <a:rPr lang="en-US" sz="660" b="1" dirty="0">
+              <a:rPr lang="en-US" sz="690" b="1" dirty="0">
                 <a:solidFill>
                   <a:srgbClr val="002516"/>
                 </a:solidFill>
@@ -1587,19 +1456,19 @@
               </a:rPr>
               <a:t>The intended learning and assessment conditions</a:t>
             </a:r>
-            <a:endParaRPr lang="en-US" sz="660" dirty="0"/>
-          </a:p>
-        </p:txBody>
-      </p:sp>
-      <p:sp>
-        <p:nvSpPr>
-          <p:cNvPr id="24" name="Shape 18"/>
-          <p:cNvSpPr/>
-          <p:nvPr/>
-        </p:nvSpPr>
-        <p:spPr>
-          <a:xfrm>
-            <a:off x="3002280" y="3072384"/>
+            <a:endParaRPr lang="en-US" sz="690" dirty="0"/>
+          </a:p>
+        </p:txBody>
+      </p:sp>
+      <p:sp>
+        <p:nvSpPr>
+          <p:cNvPr id="21" name="Shape 15"/>
+          <p:cNvSpPr/>
+          <p:nvPr/>
+        </p:nvSpPr>
+        <p:spPr>
+          <a:xfrm>
+            <a:off x="3002280" y="3035808"/>
             <a:ext cx="457200" cy="0"/>
           </a:xfrm>
           <a:prstGeom prst="line">
@@ -1616,14 +1485,14 @@
       </p:sp>
       <p:sp>
         <p:nvSpPr>
-          <p:cNvPr id="25" name="Shape 19"/>
-          <p:cNvSpPr/>
-          <p:nvPr/>
-        </p:nvSpPr>
-        <p:spPr>
-          <a:xfrm>
-            <a:off x="3686556" y="2834640"/>
-            <a:ext cx="475488" cy="475488"/>
+          <p:cNvPr id="22" name="Shape 16"/>
+          <p:cNvSpPr/>
+          <p:nvPr/>
+        </p:nvSpPr>
+        <p:spPr>
+          <a:xfrm>
+            <a:off x="3677412" y="2788920"/>
+            <a:ext cx="493776" cy="493776"/>
           </a:xfrm>
           <a:prstGeom prst="ellipse">
             <a:avLst/>
@@ -1641,7 +1510,7 @@
       </p:sp>
       <p:pic>
         <p:nvPicPr>
-          <p:cNvPr id="26" name="Image 4" descr="preencoded.png">    </p:cNvPr>
+          <p:cNvPr id="23" name="Image 4" descr="preencoded.png">    </p:cNvPr>
           <p:cNvPicPr>
             <a:picLocks noChangeAspect="1"/>
           </p:cNvPicPr>
@@ -1655,8 +1524,8 @@
         </p:blipFill>
         <p:spPr>
           <a:xfrm>
-            <a:off x="3796284" y="2944368"/>
-            <a:ext cx="256032" cy="256032"/>
+            <a:off x="3791712" y="2903220"/>
+            <a:ext cx="265176" cy="265176"/>
           </a:xfrm>
           <a:prstGeom prst="rect">
             <a:avLst/>
@@ -1665,14 +1534,14 @@
       </p:pic>
       <p:sp>
         <p:nvSpPr>
-          <p:cNvPr id="27" name="Text 20"/>
-          <p:cNvSpPr/>
-          <p:nvPr/>
-        </p:nvSpPr>
-        <p:spPr>
-          <a:xfrm>
-            <a:off x="3276600" y="3346704"/>
-            <a:ext cx="1295400" cy="402336"/>
+          <p:cNvPr id="24" name="Text 17"/>
+          <p:cNvSpPr/>
+          <p:nvPr/>
+        </p:nvSpPr>
+        <p:spPr>
+          <a:xfrm>
+            <a:off x="3276600" y="3328416"/>
+            <a:ext cx="1295400" cy="457200"/>
           </a:xfrm>
           <a:prstGeom prst="rect">
             <a:avLst/>
@@ -1688,7 +1557,7 @@
               <a:buNone/>
             </a:pPr>
             <a:r>
-              <a:rPr lang="en-US" sz="660" b="1" dirty="0">
+              <a:rPr lang="en-US" sz="690" b="1" dirty="0">
                 <a:solidFill>
                   <a:srgbClr val="002516"/>
                 </a:solidFill>
@@ -1698,20 +1567,20 @@
               </a:rPr>
               <a:t>The safe and effective conduct of the activity</a:t>
             </a:r>
-            <a:endParaRPr lang="en-US" sz="660" dirty="0"/>
-          </a:p>
-        </p:txBody>
-      </p:sp>
-      <p:sp>
-        <p:nvSpPr>
-          <p:cNvPr id="28" name="Shape 21"/>
-          <p:cNvSpPr/>
-          <p:nvPr/>
-        </p:nvSpPr>
-        <p:spPr>
-          <a:xfrm>
-            <a:off x="4773168" y="896112"/>
-            <a:ext cx="2331720" cy="237744"/>
+            <a:endParaRPr lang="en-US" sz="690" dirty="0"/>
+          </a:p>
+        </p:txBody>
+      </p:sp>
+      <p:sp>
+        <p:nvSpPr>
+          <p:cNvPr id="25" name="Shape 18"/>
+          <p:cNvSpPr/>
+          <p:nvPr/>
+        </p:nvSpPr>
+        <p:spPr>
+          <a:xfrm>
+            <a:off x="4773168" y="1097280"/>
+            <a:ext cx="2331720" cy="274320"/>
           </a:xfrm>
           <a:prstGeom prst="rect">
             <a:avLst/>
@@ -1724,14 +1593,14 @@
       </p:sp>
       <p:sp>
         <p:nvSpPr>
-          <p:cNvPr id="29" name="Text 22"/>
-          <p:cNvSpPr/>
-          <p:nvPr/>
-        </p:nvSpPr>
-        <p:spPr>
-          <a:xfrm>
-            <a:off x="4773168" y="896112"/>
-            <a:ext cx="2331720" cy="237744"/>
+          <p:cNvPr id="26" name="Text 19"/>
+          <p:cNvSpPr/>
+          <p:nvPr/>
+        </p:nvSpPr>
+        <p:spPr>
+          <a:xfrm>
+            <a:off x="4773168" y="1097280"/>
+            <a:ext cx="2331720" cy="274320"/>
           </a:xfrm>
           <a:prstGeom prst="rect">
             <a:avLst/>
@@ -1747,7 +1616,7 @@
               <a:buNone/>
             </a:pPr>
             <a:r>
-              <a:rPr lang="en-US" sz="760" b="1" spc="150" kern="0" dirty="0">
+              <a:rPr lang="en-US" sz="780" b="1" spc="150" kern="0" dirty="0">
                 <a:solidFill>
                   <a:srgbClr val="FFFFFF"/>
                 </a:solidFill>
@@ -1757,20 +1626,20 @@
               </a:rPr>
               <a:t>NOT GROUNDS BY THEMSELVES</a:t>
             </a:r>
-            <a:endParaRPr lang="en-US" sz="760" dirty="0"/>
-          </a:p>
-        </p:txBody>
-      </p:sp>
-      <p:sp>
-        <p:nvSpPr>
-          <p:cNvPr id="30" name="Shape 23"/>
-          <p:cNvSpPr/>
-          <p:nvPr/>
-        </p:nvSpPr>
-        <p:spPr>
-          <a:xfrm>
-            <a:off x="4773168" y="1133856"/>
-            <a:ext cx="2331720" cy="2670048"/>
+            <a:endParaRPr lang="en-US" sz="780" dirty="0"/>
+          </a:p>
+        </p:txBody>
+      </p:sp>
+      <p:sp>
+        <p:nvSpPr>
+          <p:cNvPr id="27" name="Shape 20"/>
+          <p:cNvSpPr/>
+          <p:nvPr/>
+        </p:nvSpPr>
+        <p:spPr>
+          <a:xfrm>
+            <a:off x="4773168" y="1371600"/>
+            <a:ext cx="2331720" cy="2487168"/>
           </a:xfrm>
           <a:prstGeom prst="rect">
             <a:avLst/>
@@ -1788,7 +1657,7 @@
       </p:sp>
       <p:pic>
         <p:nvPicPr>
-          <p:cNvPr id="31" name="Image 5" descr="preencoded.png">    </p:cNvPr>
+          <p:cNvPr id="28" name="Image 5" descr="preencoded.png">    </p:cNvPr>
           <p:cNvPicPr>
             <a:picLocks noChangeAspect="1"/>
           </p:cNvPicPr>
@@ -1802,7 +1671,7 @@
         </p:blipFill>
         <p:spPr>
           <a:xfrm>
-            <a:off x="4882896" y="1243584"/>
+            <a:off x="4882896" y="1499616"/>
             <a:ext cx="201168" cy="201168"/>
           </a:xfrm>
           <a:prstGeom prst="rect">
@@ -1812,14 +1681,14 @@
       </p:pic>
       <p:sp>
         <p:nvSpPr>
-          <p:cNvPr id="32" name="Text 24"/>
-          <p:cNvSpPr/>
-          <p:nvPr/>
-        </p:nvSpPr>
-        <p:spPr>
-          <a:xfrm>
-            <a:off x="5157216" y="1207008"/>
-            <a:ext cx="1856232" cy="292608"/>
+          <p:cNvPr id="29" name="Text 21"/>
+          <p:cNvSpPr/>
+          <p:nvPr/>
+        </p:nvSpPr>
+        <p:spPr>
+          <a:xfrm>
+            <a:off x="5157216" y="1463040"/>
+            <a:ext cx="1856232" cy="274320"/>
           </a:xfrm>
           <a:prstGeom prst="rect">
             <a:avLst/>
@@ -1835,7 +1704,7 @@
               <a:buNone/>
             </a:pPr>
             <a:r>
-              <a:rPr lang="en-US" sz="720" dirty="0">
+              <a:rPr lang="en-US" sz="740" dirty="0">
                 <a:solidFill>
                   <a:srgbClr val="000000"/>
                 </a:solidFill>
@@ -1845,19 +1714,19 @@
               </a:rPr>
               <a:t>Slower pace than peers</a:t>
             </a:r>
-            <a:endParaRPr lang="en-US" sz="720" dirty="0"/>
-          </a:p>
-        </p:txBody>
-      </p:sp>
-      <p:sp>
-        <p:nvSpPr>
-          <p:cNvPr id="33" name="Shape 25"/>
-          <p:cNvSpPr/>
-          <p:nvPr/>
-        </p:nvSpPr>
-        <p:spPr>
-          <a:xfrm>
-            <a:off x="4882896" y="1527048"/>
+            <a:endParaRPr lang="en-US" sz="740" dirty="0"/>
+          </a:p>
+        </p:txBody>
+      </p:sp>
+      <p:sp>
+        <p:nvSpPr>
+          <p:cNvPr id="30" name="Shape 22"/>
+          <p:cNvSpPr/>
+          <p:nvPr/>
+        </p:nvSpPr>
+        <p:spPr>
+          <a:xfrm>
+            <a:off x="4882896" y="1764792"/>
             <a:ext cx="2112264" cy="0"/>
           </a:xfrm>
           <a:prstGeom prst="line">
@@ -1874,7 +1743,7 @@
       </p:sp>
       <p:pic>
         <p:nvPicPr>
-          <p:cNvPr id="34" name="Image 6" descr="preencoded.png">    </p:cNvPr>
+          <p:cNvPr id="31" name="Image 6" descr="preencoded.png">    </p:cNvPr>
           <p:cNvPicPr>
             <a:picLocks noChangeAspect="1"/>
           </p:cNvPicPr>
@@ -1888,7 +1757,7 @@
         </p:blipFill>
         <p:spPr>
           <a:xfrm>
-            <a:off x="4882896" y="1609344"/>
+            <a:off x="4882896" y="1837944"/>
             <a:ext cx="201168" cy="201168"/>
           </a:xfrm>
           <a:prstGeom prst="rect">
@@ -1898,14 +1767,14 @@
       </p:pic>
       <p:sp>
         <p:nvSpPr>
-          <p:cNvPr id="35" name="Text 26"/>
-          <p:cNvSpPr/>
-          <p:nvPr/>
-        </p:nvSpPr>
-        <p:spPr>
-          <a:xfrm>
-            <a:off x="5157216" y="1572768"/>
-            <a:ext cx="1856232" cy="292608"/>
+          <p:cNvPr id="32" name="Text 23"/>
+          <p:cNvSpPr/>
+          <p:nvPr/>
+        </p:nvSpPr>
+        <p:spPr>
+          <a:xfrm>
+            <a:off x="5157216" y="1801368"/>
+            <a:ext cx="1856232" cy="274320"/>
           </a:xfrm>
           <a:prstGeom prst="rect">
             <a:avLst/>
@@ -1921,7 +1790,7 @@
               <a:buNone/>
             </a:pPr>
             <a:r>
-              <a:rPr lang="en-US" sz="720" dirty="0">
+              <a:rPr lang="en-US" sz="740" dirty="0">
                 <a:solidFill>
                   <a:srgbClr val="000000"/>
                 </a:solidFill>
@@ -1931,19 +1800,19 @@
               </a:rPr>
               <a:t>Need for reasonable assistance</a:t>
             </a:r>
-            <a:endParaRPr lang="en-US" sz="720" dirty="0"/>
-          </a:p>
-        </p:txBody>
-      </p:sp>
-      <p:sp>
-        <p:nvSpPr>
-          <p:cNvPr id="36" name="Shape 27"/>
-          <p:cNvSpPr/>
-          <p:nvPr/>
-        </p:nvSpPr>
-        <p:spPr>
-          <a:xfrm>
-            <a:off x="4882896" y="1892808"/>
+            <a:endParaRPr lang="en-US" sz="740" dirty="0"/>
+          </a:p>
+        </p:txBody>
+      </p:sp>
+      <p:sp>
+        <p:nvSpPr>
+          <p:cNvPr id="33" name="Shape 24"/>
+          <p:cNvSpPr/>
+          <p:nvPr/>
+        </p:nvSpPr>
+        <p:spPr>
+          <a:xfrm>
+            <a:off x="4882896" y="2103120"/>
             <a:ext cx="2112264" cy="0"/>
           </a:xfrm>
           <a:prstGeom prst="line">
@@ -1960,7 +1829,7 @@
       </p:sp>
       <p:pic>
         <p:nvPicPr>
-          <p:cNvPr id="37" name="Image 7" descr="preencoded.png">    </p:cNvPr>
+          <p:cNvPr id="34" name="Image 7" descr="preencoded.png">    </p:cNvPr>
           <p:cNvPicPr>
             <a:picLocks noChangeAspect="1"/>
           </p:cNvPicPr>
@@ -1974,7 +1843,7 @@
         </p:blipFill>
         <p:spPr>
           <a:xfrm>
-            <a:off x="4882896" y="1975104"/>
+            <a:off x="4882896" y="2176272"/>
             <a:ext cx="201168" cy="201168"/>
           </a:xfrm>
           <a:prstGeom prst="rect">
@@ -1984,14 +1853,14 @@
       </p:pic>
       <p:sp>
         <p:nvSpPr>
-          <p:cNvPr id="38" name="Text 28"/>
-          <p:cNvSpPr/>
-          <p:nvPr/>
-        </p:nvSpPr>
-        <p:spPr>
-          <a:xfrm>
-            <a:off x="5157216" y="1938528"/>
-            <a:ext cx="1856232" cy="292608"/>
+          <p:cNvPr id="35" name="Text 25"/>
+          <p:cNvSpPr/>
+          <p:nvPr/>
+        </p:nvSpPr>
+        <p:spPr>
+          <a:xfrm>
+            <a:off x="5157216" y="2139696"/>
+            <a:ext cx="1856232" cy="274320"/>
           </a:xfrm>
           <a:prstGeom prst="rect">
             <a:avLst/>
@@ -2007,7 +1876,7 @@
               <a:buNone/>
             </a:pPr>
             <a:r>
-              <a:rPr lang="en-US" sz="720" dirty="0">
+              <a:rPr lang="en-US" sz="740" dirty="0">
                 <a:solidFill>
                   <a:srgbClr val="000000"/>
                 </a:solidFill>
@@ -2017,19 +1886,19 @@
               </a:rPr>
               <a:t>Redistribution of equipment</a:t>
             </a:r>
-            <a:endParaRPr lang="en-US" sz="720" dirty="0"/>
-          </a:p>
-        </p:txBody>
-      </p:sp>
-      <p:sp>
-        <p:nvSpPr>
-          <p:cNvPr id="39" name="Shape 29"/>
-          <p:cNvSpPr/>
-          <p:nvPr/>
-        </p:nvSpPr>
-        <p:spPr>
-          <a:xfrm>
-            <a:off x="4882896" y="2258568"/>
+            <a:endParaRPr lang="en-US" sz="740" dirty="0"/>
+          </a:p>
+        </p:txBody>
+      </p:sp>
+      <p:sp>
+        <p:nvSpPr>
+          <p:cNvPr id="36" name="Shape 26"/>
+          <p:cNvSpPr/>
+          <p:nvPr/>
+        </p:nvSpPr>
+        <p:spPr>
+          <a:xfrm>
+            <a:off x="4882896" y="2441448"/>
             <a:ext cx="2112264" cy="0"/>
           </a:xfrm>
           <a:prstGeom prst="line">
@@ -2046,7 +1915,7 @@
       </p:sp>
       <p:pic>
         <p:nvPicPr>
-          <p:cNvPr id="40" name="Image 8" descr="preencoded.png">    </p:cNvPr>
+          <p:cNvPr id="37" name="Image 8" descr="preencoded.png">    </p:cNvPr>
           <p:cNvPicPr>
             <a:picLocks noChangeAspect="1"/>
           </p:cNvPicPr>
@@ -2060,7 +1929,7 @@
         </p:blipFill>
         <p:spPr>
           <a:xfrm>
-            <a:off x="4882896" y="2340864"/>
+            <a:off x="4882896" y="2514600"/>
             <a:ext cx="201168" cy="201168"/>
           </a:xfrm>
           <a:prstGeom prst="rect">
@@ -2070,14 +1939,14 @@
       </p:pic>
       <p:sp>
         <p:nvSpPr>
-          <p:cNvPr id="41" name="Text 30"/>
-          <p:cNvSpPr/>
-          <p:nvPr/>
-        </p:nvSpPr>
-        <p:spPr>
-          <a:xfrm>
-            <a:off x="5157216" y="2304288"/>
-            <a:ext cx="1856232" cy="292608"/>
+          <p:cNvPr id="38" name="Text 27"/>
+          <p:cNvSpPr/>
+          <p:nvPr/>
+        </p:nvSpPr>
+        <p:spPr>
+          <a:xfrm>
+            <a:off x="5157216" y="2478024"/>
+            <a:ext cx="1856232" cy="274320"/>
           </a:xfrm>
           <a:prstGeom prst="rect">
             <a:avLst/>
@@ -2093,7 +1962,7 @@
               <a:buNone/>
             </a:pPr>
             <a:r>
-              <a:rPr lang="en-US" sz="720" dirty="0">
+              <a:rPr lang="en-US" sz="740" dirty="0">
                 <a:solidFill>
                   <a:srgbClr val="000000"/>
                 </a:solidFill>
@@ -2103,19 +1972,19 @@
               </a:rPr>
               <a:t>Increased workload on others</a:t>
             </a:r>
-            <a:endParaRPr lang="en-US" sz="720" dirty="0"/>
-          </a:p>
-        </p:txBody>
-      </p:sp>
-      <p:sp>
-        <p:nvSpPr>
-          <p:cNvPr id="42" name="Shape 31"/>
-          <p:cNvSpPr/>
-          <p:nvPr/>
-        </p:nvSpPr>
-        <p:spPr>
-          <a:xfrm>
-            <a:off x="4882896" y="2624328"/>
+            <a:endParaRPr lang="en-US" sz="740" dirty="0"/>
+          </a:p>
+        </p:txBody>
+      </p:sp>
+      <p:sp>
+        <p:nvSpPr>
+          <p:cNvPr id="39" name="Shape 28"/>
+          <p:cNvSpPr/>
+          <p:nvPr/>
+        </p:nvSpPr>
+        <p:spPr>
+          <a:xfrm>
+            <a:off x="4882896" y="2779776"/>
             <a:ext cx="2112264" cy="0"/>
           </a:xfrm>
           <a:prstGeom prst="line">
@@ -2132,7 +2001,7 @@
       </p:sp>
       <p:pic>
         <p:nvPicPr>
-          <p:cNvPr id="43" name="Image 9" descr="preencoded.png">    </p:cNvPr>
+          <p:cNvPr id="40" name="Image 9" descr="preencoded.png">    </p:cNvPr>
           <p:cNvPicPr>
             <a:picLocks noChangeAspect="1"/>
           </p:cNvPicPr>
@@ -2146,7 +2015,7 @@
         </p:blipFill>
         <p:spPr>
           <a:xfrm>
-            <a:off x="4882896" y="2706624"/>
+            <a:off x="4882896" y="2852928"/>
             <a:ext cx="201168" cy="201168"/>
           </a:xfrm>
           <a:prstGeom prst="rect">
@@ -2156,14 +2025,14 @@
       </p:pic>
       <p:sp>
         <p:nvSpPr>
-          <p:cNvPr id="44" name="Text 32"/>
-          <p:cNvSpPr/>
-          <p:nvPr/>
-        </p:nvSpPr>
-        <p:spPr>
-          <a:xfrm>
-            <a:off x="5157216" y="2670048"/>
-            <a:ext cx="1856232" cy="292608"/>
+          <p:cNvPr id="41" name="Text 29"/>
+          <p:cNvSpPr/>
+          <p:nvPr/>
+        </p:nvSpPr>
+        <p:spPr>
+          <a:xfrm>
+            <a:off x="5157216" y="2816352"/>
+            <a:ext cx="1856232" cy="274320"/>
           </a:xfrm>
           <a:prstGeom prst="rect">
             <a:avLst/>
@@ -2179,7 +2048,7 @@
               <a:buNone/>
             </a:pPr>
             <a:r>
-              <a:rPr lang="en-US" sz="720" dirty="0">
+              <a:rPr lang="en-US" sz="740" dirty="0">
                 <a:solidFill>
                   <a:srgbClr val="000000"/>
                 </a:solidFill>
@@ -2189,19 +2058,19 @@
               </a:rPr>
               <a:t>Frustration or interpersonal friction</a:t>
             </a:r>
-            <a:endParaRPr lang="en-US" sz="720" dirty="0"/>
-          </a:p>
-        </p:txBody>
-      </p:sp>
-      <p:sp>
-        <p:nvSpPr>
-          <p:cNvPr id="45" name="Shape 33"/>
-          <p:cNvSpPr/>
-          <p:nvPr/>
-        </p:nvSpPr>
-        <p:spPr>
-          <a:xfrm>
-            <a:off x="4882896" y="2990088"/>
+            <a:endParaRPr lang="en-US" sz="740" dirty="0"/>
+          </a:p>
+        </p:txBody>
+      </p:sp>
+      <p:sp>
+        <p:nvSpPr>
+          <p:cNvPr id="42" name="Shape 30"/>
+          <p:cNvSpPr/>
+          <p:nvPr/>
+        </p:nvSpPr>
+        <p:spPr>
+          <a:xfrm>
+            <a:off x="4882896" y="3118104"/>
             <a:ext cx="2112264" cy="0"/>
           </a:xfrm>
           <a:prstGeom prst="line">
@@ -2218,7 +2087,7 @@
       </p:sp>
       <p:pic>
         <p:nvPicPr>
-          <p:cNvPr id="46" name="Image 10" descr="preencoded.png">    </p:cNvPr>
+          <p:cNvPr id="43" name="Image 10" descr="preencoded.png">    </p:cNvPr>
           <p:cNvPicPr>
             <a:picLocks noChangeAspect="1"/>
           </p:cNvPicPr>
@@ -2232,7 +2101,7 @@
         </p:blipFill>
         <p:spPr>
           <a:xfrm>
-            <a:off x="4882896" y="3072384"/>
+            <a:off x="4882896" y="3191256"/>
             <a:ext cx="201168" cy="201168"/>
           </a:xfrm>
           <a:prstGeom prst="rect">
@@ -2242,14 +2111,14 @@
       </p:pic>
       <p:sp>
         <p:nvSpPr>
-          <p:cNvPr id="47" name="Text 34"/>
-          <p:cNvSpPr/>
-          <p:nvPr/>
-        </p:nvSpPr>
-        <p:spPr>
-          <a:xfrm>
-            <a:off x="5157216" y="3035808"/>
-            <a:ext cx="1856232" cy="292608"/>
+          <p:cNvPr id="44" name="Text 31"/>
+          <p:cNvSpPr/>
+          <p:nvPr/>
+        </p:nvSpPr>
+        <p:spPr>
+          <a:xfrm>
+            <a:off x="5157216" y="3154680"/>
+            <a:ext cx="1856232" cy="274320"/>
           </a:xfrm>
           <a:prstGeom prst="rect">
             <a:avLst/>
@@ -2265,7 +2134,7 @@
               <a:buNone/>
             </a:pPr>
             <a:r>
-              <a:rPr lang="en-US" sz="720" dirty="0">
+              <a:rPr lang="en-US" sz="740" dirty="0">
                 <a:solidFill>
                   <a:srgbClr val="000000"/>
                 </a:solidFill>
@@ -2275,20 +2144,20 @@
               </a:rPr>
               <a:t>Need to adjust pace, roles or plan</a:t>
             </a:r>
-            <a:endParaRPr lang="en-US" sz="720" dirty="0"/>
-          </a:p>
-        </p:txBody>
-      </p:sp>
-      <p:sp>
-        <p:nvSpPr>
-          <p:cNvPr id="48" name="Shape 35"/>
-          <p:cNvSpPr/>
-          <p:nvPr/>
-        </p:nvSpPr>
-        <p:spPr>
-          <a:xfrm>
-            <a:off x="4864608" y="3456432"/>
-            <a:ext cx="2148840" cy="256032"/>
+            <a:endParaRPr lang="en-US" sz="740" dirty="0"/>
+          </a:p>
+        </p:txBody>
+      </p:sp>
+      <p:sp>
+        <p:nvSpPr>
+          <p:cNvPr id="45" name="Shape 32"/>
+          <p:cNvSpPr/>
+          <p:nvPr/>
+        </p:nvSpPr>
+        <p:spPr>
+          <a:xfrm>
+            <a:off x="4864608" y="3529584"/>
+            <a:ext cx="2148840" cy="237744"/>
           </a:xfrm>
           <a:prstGeom prst="rect">
             <a:avLst/>
@@ -2303,14 +2172,14 @@
       </p:sp>
       <p:sp>
         <p:nvSpPr>
-          <p:cNvPr id="49" name="Text 36"/>
-          <p:cNvSpPr/>
-          <p:nvPr/>
-        </p:nvSpPr>
-        <p:spPr>
-          <a:xfrm>
-            <a:off x="4864608" y="3456432"/>
-            <a:ext cx="2148840" cy="256032"/>
+          <p:cNvPr id="46" name="Text 33"/>
+          <p:cNvSpPr/>
+          <p:nvPr/>
+        </p:nvSpPr>
+        <p:spPr>
+          <a:xfrm>
+            <a:off x="4864608" y="3529584"/>
+            <a:ext cx="2148840" cy="237744"/>
           </a:xfrm>
           <a:prstGeom prst="rect">
             <a:avLst/>
@@ -2326,7 +2195,7 @@
               <a:buNone/>
             </a:pPr>
             <a:r>
-              <a:rPr lang="en-US" sz="680" b="1" i="1" dirty="0">
+              <a:rPr lang="en-US" sz="720" b="1" i="1" dirty="0">
                 <a:solidFill>
                   <a:srgbClr val="002516"/>
                 </a:solidFill>
@@ -2334,22 +2203,22 @@
                 <a:ea typeface="Arial" pitchFamily="34" charset="-122"/>
                 <a:cs typeface="Arial" pitchFamily="34" charset="-120"/>
               </a:rPr>
-              <a:t>These are normal developmental effects.</a:t>
-            </a:r>
-            <a:endParaRPr lang="en-US" sz="680" dirty="0"/>
-          </a:p>
-        </p:txBody>
-      </p:sp>
-      <p:sp>
-        <p:nvSpPr>
-          <p:cNvPr id="50" name="Shape 37"/>
-          <p:cNvSpPr/>
-          <p:nvPr/>
-        </p:nvSpPr>
-        <p:spPr>
-          <a:xfrm>
-            <a:off x="457200" y="3950208"/>
-            <a:ext cx="6647688" cy="256032"/>
+              <a:t>Normal developmental effects.</a:t>
+            </a:r>
+            <a:endParaRPr lang="en-US" sz="720" dirty="0"/>
+          </a:p>
+        </p:txBody>
+      </p:sp>
+      <p:sp>
+        <p:nvSpPr>
+          <p:cNvPr id="47" name="Shape 34"/>
+          <p:cNvSpPr/>
+          <p:nvPr/>
+        </p:nvSpPr>
+        <p:spPr>
+          <a:xfrm>
+            <a:off x="457200" y="4096512"/>
+            <a:ext cx="6647688" cy="274320"/>
           </a:xfrm>
           <a:prstGeom prst="rect">
             <a:avLst/>
@@ -2362,14 +2231,14 @@
       </p:sp>
       <p:sp>
         <p:nvSpPr>
-          <p:cNvPr id="51" name="Text 38"/>
-          <p:cNvSpPr/>
-          <p:nvPr/>
-        </p:nvSpPr>
-        <p:spPr>
-          <a:xfrm>
-            <a:off x="457200" y="3950208"/>
-            <a:ext cx="6647688" cy="256032"/>
+          <p:cNvPr id="48" name="Text 35"/>
+          <p:cNvSpPr/>
+          <p:nvPr/>
+        </p:nvSpPr>
+        <p:spPr>
+          <a:xfrm>
+            <a:off x="457200" y="4096512"/>
+            <a:ext cx="6647688" cy="274320"/>
           </a:xfrm>
           <a:prstGeom prst="rect">
             <a:avLst/>
@@ -2385,7 +2254,7 @@
               <a:buNone/>
             </a:pPr>
             <a:r>
-              <a:rPr lang="en-US" sz="860" b="1" spc="150" kern="0" dirty="0">
+              <a:rPr lang="en-US" sz="900" b="1" spc="150" kern="0" dirty="0">
                 <a:solidFill>
                   <a:srgbClr val="FFFFFF"/>
                 </a:solidFill>
@@ -2395,20 +2264,20 @@
               </a:rPr>
               <a:t>3. GROUNDS FOR WITHDRAWAL</a:t>
             </a:r>
-            <a:endParaRPr lang="en-US" sz="860" dirty="0"/>
-          </a:p>
-        </p:txBody>
-      </p:sp>
-      <p:sp>
-        <p:nvSpPr>
-          <p:cNvPr id="52" name="Shape 39"/>
-          <p:cNvSpPr/>
-          <p:nvPr/>
-        </p:nvSpPr>
-        <p:spPr>
-          <a:xfrm>
-            <a:off x="457200" y="4279392"/>
-            <a:ext cx="2142744" cy="1481328"/>
+            <a:endParaRPr lang="en-US" sz="900" dirty="0"/>
+          </a:p>
+        </p:txBody>
+      </p:sp>
+      <p:sp>
+        <p:nvSpPr>
+          <p:cNvPr id="49" name="Shape 36"/>
+          <p:cNvSpPr/>
+          <p:nvPr/>
+        </p:nvSpPr>
+        <p:spPr>
+          <a:xfrm>
+            <a:off x="457200" y="4443984"/>
+            <a:ext cx="2142744" cy="1225296"/>
           </a:xfrm>
           <a:prstGeom prst="rect">
             <a:avLst/>
@@ -2426,13 +2295,13 @@
       </p:sp>
       <p:sp>
         <p:nvSpPr>
-          <p:cNvPr id="53" name="Shape 40"/>
-          <p:cNvSpPr/>
-          <p:nvPr/>
-        </p:nvSpPr>
-        <p:spPr>
-          <a:xfrm>
-            <a:off x="530352" y="4352544"/>
+          <p:cNvPr id="50" name="Shape 37"/>
+          <p:cNvSpPr/>
+          <p:nvPr/>
+        </p:nvSpPr>
+        <p:spPr>
+          <a:xfrm>
+            <a:off x="530352" y="4517136"/>
             <a:ext cx="173736" cy="173736"/>
           </a:xfrm>
           <a:prstGeom prst="rect">
@@ -2446,13 +2315,13 @@
       </p:sp>
       <p:sp>
         <p:nvSpPr>
-          <p:cNvPr id="54" name="Text 41"/>
-          <p:cNvSpPr/>
-          <p:nvPr/>
-        </p:nvSpPr>
-        <p:spPr>
-          <a:xfrm>
-            <a:off x="530352" y="4352544"/>
+          <p:cNvPr id="51" name="Text 38"/>
+          <p:cNvSpPr/>
+          <p:nvPr/>
+        </p:nvSpPr>
+        <p:spPr>
+          <a:xfrm>
+            <a:off x="530352" y="4517136"/>
             <a:ext cx="173736" cy="173736"/>
           </a:xfrm>
           <a:prstGeom prst="rect">
@@ -2485,13 +2354,13 @@
       </p:sp>
       <p:sp>
         <p:nvSpPr>
-          <p:cNvPr id="55" name="Shape 42"/>
-          <p:cNvSpPr/>
-          <p:nvPr/>
-        </p:nvSpPr>
-        <p:spPr>
-          <a:xfrm>
-            <a:off x="1336548" y="4352544"/>
+          <p:cNvPr id="52" name="Shape 39"/>
+          <p:cNvSpPr/>
+          <p:nvPr/>
+        </p:nvSpPr>
+        <p:spPr>
+          <a:xfrm>
+            <a:off x="1336548" y="4517136"/>
             <a:ext cx="384048" cy="384048"/>
           </a:xfrm>
           <a:prstGeom prst="ellipse">
@@ -2505,7 +2374,7 @@
       </p:sp>
       <p:pic>
         <p:nvPicPr>
-          <p:cNvPr id="56" name="Image 11" descr="preencoded.png">    </p:cNvPr>
+          <p:cNvPr id="53" name="Image 11" descr="preencoded.png">    </p:cNvPr>
           <p:cNvPicPr>
             <a:picLocks noChangeAspect="1"/>
           </p:cNvPicPr>
@@ -2519,7 +2388,7 @@
         </p:blipFill>
         <p:spPr>
           <a:xfrm>
-            <a:off x="1423416" y="4439412"/>
+            <a:off x="1423416" y="4604004"/>
             <a:ext cx="210312" cy="210312"/>
           </a:xfrm>
           <a:prstGeom prst="rect">
@@ -2529,13 +2398,13 @@
       </p:pic>
       <p:sp>
         <p:nvSpPr>
-          <p:cNvPr id="57" name="Text 43"/>
-          <p:cNvSpPr/>
-          <p:nvPr/>
-        </p:nvSpPr>
-        <p:spPr>
-          <a:xfrm>
-            <a:off x="512064" y="4773168"/>
+          <p:cNvPr id="54" name="Text 40"/>
+          <p:cNvSpPr/>
+          <p:nvPr/>
+        </p:nvSpPr>
+        <p:spPr>
+          <a:xfrm>
+            <a:off x="512064" y="4937760"/>
             <a:ext cx="2033016" cy="182880"/>
           </a:xfrm>
           <a:prstGeom prst="rect">
@@ -2552,7 +2421,7 @@
               <a:buNone/>
             </a:pPr>
             <a:r>
-              <a:rPr lang="en-US" sz="820" b="1" dirty="0">
+              <a:rPr lang="en-US" sz="880" b="1" dirty="0">
                 <a:solidFill>
                   <a:srgbClr val="002516"/>
                 </a:solidFill>
@@ -2560,77 +2429,38 @@
                 <a:ea typeface="Arial" pitchFamily="34" charset="-122"/>
                 <a:cs typeface="Arial" pitchFamily="34" charset="-120"/>
               </a:rPr>
-              <a:t>Medical and safety</a:t>
-            </a:r>
-            <a:endParaRPr lang="en-US" sz="820" dirty="0"/>
-          </a:p>
-        </p:txBody>
-      </p:sp>
-      <p:sp>
-        <p:nvSpPr>
-          <p:cNvPr id="58" name="Text 44"/>
-          <p:cNvSpPr/>
-          <p:nvPr/>
-        </p:nvSpPr>
-        <p:spPr>
-          <a:xfrm>
-            <a:off x="512064" y="4956048"/>
-            <a:ext cx="2033016" cy="146304"/>
-          </a:xfrm>
-          <a:prstGeom prst="rect">
-            <a:avLst/>
-          </a:prstGeom>
-          <a:noFill/>
-          <a:ln/>
-        </p:spPr>
-        <p:txBody>
-          <a:bodyPr wrap="square" lIns="0" tIns="0" rIns="0" bIns="0" rtlCol="0" anchor="ctr"/>
+              <a:t>Medical &amp; Safety</a:t>
+            </a:r>
+            <a:endParaRPr lang="en-US" sz="880" dirty="0"/>
+          </a:p>
+        </p:txBody>
+      </p:sp>
+      <p:sp>
+        <p:nvSpPr>
+          <p:cNvPr id="55" name="Text 41"/>
+          <p:cNvSpPr/>
+          <p:nvPr/>
+        </p:nvSpPr>
+        <p:spPr>
+          <a:xfrm>
+            <a:off x="585216" y="5138928"/>
+            <a:ext cx="1886712" cy="475488"/>
+          </a:xfrm>
+          <a:prstGeom prst="rect">
+            <a:avLst/>
+          </a:prstGeom>
+          <a:noFill/>
+          <a:ln/>
+        </p:spPr>
+        <p:txBody>
+          <a:bodyPr wrap="square" lIns="0" tIns="0" rIns="0" bIns="0" rtlCol="0" anchor="t"/>
           <a:lstStyle/>
           <a:p>
             <a:pPr algn="ctr" indent="0" marL="0">
               <a:buNone/>
             </a:pPr>
             <a:r>
-              <a:rPr lang="en-US" sz="660" i="1" dirty="0">
-                <a:solidFill>
-                  <a:srgbClr val="C62026"/>
-                </a:solidFill>
-                <a:latin typeface="Arial" pitchFamily="34" charset="0"/>
-                <a:ea typeface="Arial" pitchFamily="34" charset="-122"/>
-                <a:cs typeface="Arial" pitchFamily="34" charset="-120"/>
-              </a:rPr>
-              <a:t>Protects the individual</a:t>
-            </a:r>
-            <a:endParaRPr lang="en-US" sz="660" dirty="0"/>
-          </a:p>
-        </p:txBody>
-      </p:sp>
-      <p:sp>
-        <p:nvSpPr>
-          <p:cNvPr id="59" name="Text 45"/>
-          <p:cNvSpPr/>
-          <p:nvPr/>
-        </p:nvSpPr>
-        <p:spPr>
-          <a:xfrm>
-            <a:off x="566928" y="5138928"/>
-            <a:ext cx="1923288" cy="585216"/>
-          </a:xfrm>
-          <a:prstGeom prst="rect">
-            <a:avLst/>
-          </a:prstGeom>
-          <a:noFill/>
-          <a:ln/>
-        </p:spPr>
-        <p:txBody>
-          <a:bodyPr wrap="square" lIns="0" tIns="0" rIns="0" bIns="0" rtlCol="0" anchor="t"/>
-          <a:lstStyle/>
-          <a:p>
-            <a:pPr algn="ctr" indent="0" marL="0">
-              <a:buNone/>
-            </a:pPr>
-            <a:r>
-              <a:rPr lang="en-US" sz="680" dirty="0">
+              <a:rPr lang="en-US" sz="740" dirty="0">
                 <a:solidFill>
                   <a:srgbClr val="000000"/>
                 </a:solidFill>
@@ -2640,20 +2470,20 @@
               </a:rPr>
               <a:t>The participant cannot continue safely because of a medical condition or safety risk.</a:t>
             </a:r>
-            <a:endParaRPr lang="en-US" sz="680" dirty="0"/>
-          </a:p>
-        </p:txBody>
-      </p:sp>
-      <p:sp>
-        <p:nvSpPr>
-          <p:cNvPr id="60" name="Shape 46"/>
-          <p:cNvSpPr/>
-          <p:nvPr/>
-        </p:nvSpPr>
-        <p:spPr>
-          <a:xfrm>
-            <a:off x="2709672" y="4279392"/>
-            <a:ext cx="2142744" cy="1481328"/>
+            <a:endParaRPr lang="en-US" sz="740" dirty="0"/>
+          </a:p>
+        </p:txBody>
+      </p:sp>
+      <p:sp>
+        <p:nvSpPr>
+          <p:cNvPr id="56" name="Shape 42"/>
+          <p:cNvSpPr/>
+          <p:nvPr/>
+        </p:nvSpPr>
+        <p:spPr>
+          <a:xfrm>
+            <a:off x="2709672" y="4443984"/>
+            <a:ext cx="2142744" cy="1225296"/>
           </a:xfrm>
           <a:prstGeom prst="rect">
             <a:avLst/>
@@ -2671,13 +2501,13 @@
       </p:sp>
       <p:sp>
         <p:nvSpPr>
-          <p:cNvPr id="61" name="Shape 47"/>
-          <p:cNvSpPr/>
-          <p:nvPr/>
-        </p:nvSpPr>
-        <p:spPr>
-          <a:xfrm>
-            <a:off x="2782824" y="4352544"/>
+          <p:cNvPr id="57" name="Shape 43"/>
+          <p:cNvSpPr/>
+          <p:nvPr/>
+        </p:nvSpPr>
+        <p:spPr>
+          <a:xfrm>
+            <a:off x="2782824" y="4517136"/>
             <a:ext cx="173736" cy="173736"/>
           </a:xfrm>
           <a:prstGeom prst="rect">
@@ -2691,13 +2521,13 @@
       </p:sp>
       <p:sp>
         <p:nvSpPr>
-          <p:cNvPr id="62" name="Text 48"/>
-          <p:cNvSpPr/>
-          <p:nvPr/>
-        </p:nvSpPr>
-        <p:spPr>
-          <a:xfrm>
-            <a:off x="2782824" y="4352544"/>
+          <p:cNvPr id="58" name="Text 44"/>
+          <p:cNvSpPr/>
+          <p:nvPr/>
+        </p:nvSpPr>
+        <p:spPr>
+          <a:xfrm>
+            <a:off x="2782824" y="4517136"/>
             <a:ext cx="173736" cy="173736"/>
           </a:xfrm>
           <a:prstGeom prst="rect">
@@ -2730,13 +2560,13 @@
       </p:sp>
       <p:sp>
         <p:nvSpPr>
-          <p:cNvPr id="63" name="Shape 49"/>
-          <p:cNvSpPr/>
-          <p:nvPr/>
-        </p:nvSpPr>
-        <p:spPr>
-          <a:xfrm>
-            <a:off x="3589020" y="4352544"/>
+          <p:cNvPr id="59" name="Shape 45"/>
+          <p:cNvSpPr/>
+          <p:nvPr/>
+        </p:nvSpPr>
+        <p:spPr>
+          <a:xfrm>
+            <a:off x="3589020" y="4517136"/>
             <a:ext cx="384048" cy="384048"/>
           </a:xfrm>
           <a:prstGeom prst="ellipse">
@@ -2750,7 +2580,7 @@
       </p:sp>
       <p:pic>
         <p:nvPicPr>
-          <p:cNvPr id="64" name="Image 12" descr="preencoded.png">    </p:cNvPr>
+          <p:cNvPr id="60" name="Image 12" descr="preencoded.png">    </p:cNvPr>
           <p:cNvPicPr>
             <a:picLocks noChangeAspect="1"/>
           </p:cNvPicPr>
@@ -2764,7 +2594,7 @@
         </p:blipFill>
         <p:spPr>
           <a:xfrm>
-            <a:off x="3675888" y="4439412"/>
+            <a:off x="3675888" y="4604004"/>
             <a:ext cx="210312" cy="210312"/>
           </a:xfrm>
           <a:prstGeom prst="rect">
@@ -2774,13 +2604,13 @@
       </p:pic>
       <p:sp>
         <p:nvSpPr>
-          <p:cNvPr id="65" name="Text 50"/>
-          <p:cNvSpPr/>
-          <p:nvPr/>
-        </p:nvSpPr>
-        <p:spPr>
-          <a:xfrm>
-            <a:off x="2764536" y="4773168"/>
+          <p:cNvPr id="61" name="Text 46"/>
+          <p:cNvSpPr/>
+          <p:nvPr/>
+        </p:nvSpPr>
+        <p:spPr>
+          <a:xfrm>
+            <a:off x="2764536" y="4937760"/>
             <a:ext cx="2033016" cy="182880"/>
           </a:xfrm>
           <a:prstGeom prst="rect">
@@ -2797,7 +2627,7 @@
               <a:buNone/>
             </a:pPr>
             <a:r>
-              <a:rPr lang="en-US" sz="820" b="1" dirty="0">
+              <a:rPr lang="en-US" sz="880" b="1" dirty="0">
                 <a:solidFill>
                   <a:srgbClr val="002516"/>
                 </a:solidFill>
@@ -2805,77 +2635,38 @@
                 <a:ea typeface="Arial" pitchFamily="34" charset="-122"/>
                 <a:cs typeface="Arial" pitchFamily="34" charset="-120"/>
               </a:rPr>
-              <a:t>Learning and assessment</a:t>
-            </a:r>
-            <a:endParaRPr lang="en-US" sz="820" dirty="0"/>
-          </a:p>
-        </p:txBody>
-      </p:sp>
-      <p:sp>
-        <p:nvSpPr>
-          <p:cNvPr id="66" name="Text 51"/>
-          <p:cNvSpPr/>
-          <p:nvPr/>
-        </p:nvSpPr>
-        <p:spPr>
-          <a:xfrm>
-            <a:off x="2764536" y="4956048"/>
-            <a:ext cx="2033016" cy="146304"/>
-          </a:xfrm>
-          <a:prstGeom prst="rect">
-            <a:avLst/>
-          </a:prstGeom>
-          <a:noFill/>
-          <a:ln/>
-        </p:spPr>
-        <p:txBody>
-          <a:bodyPr wrap="square" lIns="0" tIns="0" rIns="0" bIns="0" rtlCol="0" anchor="ctr"/>
+              <a:t>Learning &amp; Assessment</a:t>
+            </a:r>
+            <a:endParaRPr lang="en-US" sz="880" dirty="0"/>
+          </a:p>
+        </p:txBody>
+      </p:sp>
+      <p:sp>
+        <p:nvSpPr>
+          <p:cNvPr id="62" name="Text 47"/>
+          <p:cNvSpPr/>
+          <p:nvPr/>
+        </p:nvSpPr>
+        <p:spPr>
+          <a:xfrm>
+            <a:off x="2837688" y="5138928"/>
+            <a:ext cx="1886712" cy="475488"/>
+          </a:xfrm>
+          <a:prstGeom prst="rect">
+            <a:avLst/>
+          </a:prstGeom>
+          <a:noFill/>
+          <a:ln/>
+        </p:spPr>
+        <p:txBody>
+          <a:bodyPr wrap="square" lIns="0" tIns="0" rIns="0" bIns="0" rtlCol="0" anchor="t"/>
           <a:lstStyle/>
           <a:p>
             <a:pPr algn="ctr" indent="0" marL="0">
               <a:buNone/>
             </a:pPr>
             <a:r>
-              <a:rPr lang="en-US" sz="660" i="1" dirty="0">
-                <a:solidFill>
-                  <a:srgbClr val="C62026"/>
-                </a:solidFill>
-                <a:latin typeface="Arial" pitchFamily="34" charset="0"/>
-                <a:ea typeface="Arial" pitchFamily="34" charset="-122"/>
-                <a:cs typeface="Arial" pitchFamily="34" charset="-120"/>
-              </a:rPr>
-              <a:t>Protects the learning environment</a:t>
-            </a:r>
-            <a:endParaRPr lang="en-US" sz="660" dirty="0"/>
-          </a:p>
-        </p:txBody>
-      </p:sp>
-      <p:sp>
-        <p:nvSpPr>
-          <p:cNvPr id="67" name="Text 52"/>
-          <p:cNvSpPr/>
-          <p:nvPr/>
-        </p:nvSpPr>
-        <p:spPr>
-          <a:xfrm>
-            <a:off x="2819400" y="5138928"/>
-            <a:ext cx="1923288" cy="585216"/>
-          </a:xfrm>
-          <a:prstGeom prst="rect">
-            <a:avLst/>
-          </a:prstGeom>
-          <a:noFill/>
-          <a:ln/>
-        </p:spPr>
-        <p:txBody>
-          <a:bodyPr wrap="square" lIns="0" tIns="0" rIns="0" bIns="0" rtlCol="0" anchor="t"/>
-          <a:lstStyle/>
-          <a:p>
-            <a:pPr algn="ctr" indent="0" marL="0">
-              <a:buNone/>
-            </a:pPr>
-            <a:r>
-              <a:rPr lang="en-US" sz="680" dirty="0">
+              <a:rPr lang="en-US" sz="740" dirty="0">
                 <a:solidFill>
                   <a:srgbClr val="000000"/>
                 </a:solidFill>
@@ -2883,22 +2674,22 @@
                 <a:ea typeface="Arial" pitchFamily="34" charset="-122"/>
                 <a:cs typeface="Arial" pitchFamily="34" charset="-120"/>
               </a:rPr>
-              <a:t>Continued participation by the participant prevents the activity from providing the intended learning and assessment conditions.</a:t>
-            </a:r>
-            <a:endParaRPr lang="en-US" sz="680" dirty="0"/>
-          </a:p>
-        </p:txBody>
-      </p:sp>
-      <p:sp>
-        <p:nvSpPr>
-          <p:cNvPr id="68" name="Shape 53"/>
-          <p:cNvSpPr/>
-          <p:nvPr/>
-        </p:nvSpPr>
-        <p:spPr>
-          <a:xfrm>
-            <a:off x="4962144" y="4279392"/>
-            <a:ext cx="2142744" cy="1481328"/>
+              <a:t>Continued participation prevents the intended learning and assessment conditions.</a:t>
+            </a:r>
+            <a:endParaRPr lang="en-US" sz="740" dirty="0"/>
+          </a:p>
+        </p:txBody>
+      </p:sp>
+      <p:sp>
+        <p:nvSpPr>
+          <p:cNvPr id="63" name="Shape 48"/>
+          <p:cNvSpPr/>
+          <p:nvPr/>
+        </p:nvSpPr>
+        <p:spPr>
+          <a:xfrm>
+            <a:off x="4962144" y="4443984"/>
+            <a:ext cx="2142744" cy="1225296"/>
           </a:xfrm>
           <a:prstGeom prst="rect">
             <a:avLst/>
@@ -2916,13 +2707,13 @@
       </p:sp>
       <p:sp>
         <p:nvSpPr>
-          <p:cNvPr id="69" name="Shape 54"/>
-          <p:cNvSpPr/>
-          <p:nvPr/>
-        </p:nvSpPr>
-        <p:spPr>
-          <a:xfrm>
-            <a:off x="5035296" y="4352544"/>
+          <p:cNvPr id="64" name="Shape 49"/>
+          <p:cNvSpPr/>
+          <p:nvPr/>
+        </p:nvSpPr>
+        <p:spPr>
+          <a:xfrm>
+            <a:off x="5035296" y="4517136"/>
             <a:ext cx="173736" cy="173736"/>
           </a:xfrm>
           <a:prstGeom prst="rect">
@@ -2936,13 +2727,13 @@
       </p:sp>
       <p:sp>
         <p:nvSpPr>
-          <p:cNvPr id="70" name="Text 55"/>
-          <p:cNvSpPr/>
-          <p:nvPr/>
-        </p:nvSpPr>
-        <p:spPr>
-          <a:xfrm>
-            <a:off x="5035296" y="4352544"/>
+          <p:cNvPr id="65" name="Text 50"/>
+          <p:cNvSpPr/>
+          <p:nvPr/>
+        </p:nvSpPr>
+        <p:spPr>
+          <a:xfrm>
+            <a:off x="5035296" y="4517136"/>
             <a:ext cx="173736" cy="173736"/>
           </a:xfrm>
           <a:prstGeom prst="rect">
@@ -2975,13 +2766,13 @@
       </p:sp>
       <p:sp>
         <p:nvSpPr>
-          <p:cNvPr id="71" name="Shape 56"/>
-          <p:cNvSpPr/>
-          <p:nvPr/>
-        </p:nvSpPr>
-        <p:spPr>
-          <a:xfrm>
-            <a:off x="5841492" y="4352544"/>
+          <p:cNvPr id="66" name="Shape 51"/>
+          <p:cNvSpPr/>
+          <p:nvPr/>
+        </p:nvSpPr>
+        <p:spPr>
+          <a:xfrm>
+            <a:off x="5841492" y="4517136"/>
             <a:ext cx="384048" cy="384048"/>
           </a:xfrm>
           <a:prstGeom prst="ellipse">
@@ -2995,7 +2786,7 @@
       </p:sp>
       <p:pic>
         <p:nvPicPr>
-          <p:cNvPr id="72" name="Image 13" descr="preencoded.png">    </p:cNvPr>
+          <p:cNvPr id="67" name="Image 13" descr="preencoded.png">    </p:cNvPr>
           <p:cNvPicPr>
             <a:picLocks noChangeAspect="1"/>
           </p:cNvPicPr>
@@ -3009,7 +2800,7 @@
         </p:blipFill>
         <p:spPr>
           <a:xfrm>
-            <a:off x="5928360" y="4439412"/>
+            <a:off x="5928360" y="4604004"/>
             <a:ext cx="210312" cy="210312"/>
           </a:xfrm>
           <a:prstGeom prst="rect">
@@ -3019,14 +2810,190 @@
       </p:pic>
       <p:sp>
         <p:nvSpPr>
+          <p:cNvPr id="68" name="Text 52"/>
+          <p:cNvSpPr/>
+          <p:nvPr/>
+        </p:nvSpPr>
+        <p:spPr>
+          <a:xfrm>
+            <a:off x="5017008" y="4937760"/>
+            <a:ext cx="2033016" cy="182880"/>
+          </a:xfrm>
+          <a:prstGeom prst="rect">
+            <a:avLst/>
+          </a:prstGeom>
+          <a:noFill/>
+          <a:ln/>
+        </p:spPr>
+        <p:txBody>
+          <a:bodyPr wrap="square" lIns="0" tIns="0" rIns="0" bIns="0" rtlCol="0" anchor="ctr"/>
+          <a:lstStyle/>
+          <a:p>
+            <a:pPr algn="ctr" indent="0" marL="0">
+              <a:buNone/>
+            </a:pPr>
+            <a:r>
+              <a:rPr lang="en-US" sz="880" b="1" dirty="0">
+                <a:solidFill>
+                  <a:srgbClr val="002516"/>
+                </a:solidFill>
+                <a:latin typeface="Arial" pitchFamily="34" charset="0"/>
+                <a:ea typeface="Arial" pitchFamily="34" charset="-122"/>
+                <a:cs typeface="Arial" pitchFamily="34" charset="-120"/>
+              </a:rPr>
+              <a:t>Conduct</a:t>
+            </a:r>
+            <a:endParaRPr lang="en-US" sz="880" dirty="0"/>
+          </a:p>
+        </p:txBody>
+      </p:sp>
+      <p:sp>
+        <p:nvSpPr>
+          <p:cNvPr id="69" name="Text 53"/>
+          <p:cNvSpPr/>
+          <p:nvPr/>
+        </p:nvSpPr>
+        <p:spPr>
+          <a:xfrm>
+            <a:off x="5090160" y="5138928"/>
+            <a:ext cx="1886712" cy="475488"/>
+          </a:xfrm>
+          <a:prstGeom prst="rect">
+            <a:avLst/>
+          </a:prstGeom>
+          <a:noFill/>
+          <a:ln/>
+        </p:spPr>
+        <p:txBody>
+          <a:bodyPr wrap="square" lIns="0" tIns="0" rIns="0" bIns="0" rtlCol="0" anchor="t"/>
+          <a:lstStyle/>
+          <a:p>
+            <a:pPr algn="ctr" indent="0" marL="0">
+              <a:buNone/>
+            </a:pPr>
+            <a:r>
+              <a:rPr lang="en-US" sz="740" dirty="0">
+                <a:solidFill>
+                  <a:srgbClr val="000000"/>
+                </a:solidFill>
+                <a:latin typeface="Arial" pitchFamily="34" charset="0"/>
+                <a:ea typeface="Arial" pitchFamily="34" charset="-122"/>
+                <a:cs typeface="Arial" pitchFamily="34" charset="-120"/>
+              </a:rPr>
+              <a:t>The participant refuses lawful instructions or prevents the safe and effective conduct of the activity.</a:t>
+            </a:r>
+            <a:endParaRPr lang="en-US" sz="740" dirty="0"/>
+          </a:p>
+        </p:txBody>
+      </p:sp>
+      <p:sp>
+        <p:nvSpPr>
+          <p:cNvPr id="70" name="Shape 54"/>
+          <p:cNvSpPr/>
+          <p:nvPr/>
+        </p:nvSpPr>
+        <p:spPr>
+          <a:xfrm>
+            <a:off x="457200" y="5870448"/>
+            <a:ext cx="6647688" cy="859536"/>
+          </a:xfrm>
+          <a:prstGeom prst="rect">
+            <a:avLst/>
+          </a:prstGeom>
+          <a:solidFill>
+            <a:srgbClr val="3A4B00"/>
+          </a:solidFill>
+          <a:ln/>
+        </p:spPr>
+      </p:sp>
+      <p:sp>
+        <p:nvSpPr>
+          <p:cNvPr id="71" name="Text 55"/>
+          <p:cNvSpPr/>
+          <p:nvPr/>
+        </p:nvSpPr>
+        <p:spPr>
+          <a:xfrm>
+            <a:off x="457200" y="5925312"/>
+            <a:ext cx="6647688" cy="164592"/>
+          </a:xfrm>
+          <a:prstGeom prst="rect">
+            <a:avLst/>
+          </a:prstGeom>
+          <a:noFill/>
+          <a:ln/>
+        </p:spPr>
+        <p:txBody>
+          <a:bodyPr wrap="square" lIns="0" tIns="0" rIns="0" bIns="0" rtlCol="0" anchor="ctr"/>
+          <a:lstStyle/>
+          <a:p>
+            <a:pPr algn="ctr" indent="0" marL="0">
+              <a:buNone/>
+            </a:pPr>
+            <a:r>
+              <a:rPr lang="en-US" sz="900" b="1" spc="200" kern="0" dirty="0">
+                <a:solidFill>
+                  <a:srgbClr val="CDD2B7"/>
+                </a:solidFill>
+                <a:latin typeface="Arial" pitchFamily="34" charset="0"/>
+                <a:ea typeface="Arial" pitchFamily="34" charset="-122"/>
+                <a:cs typeface="Arial" pitchFamily="34" charset="-120"/>
+              </a:rPr>
+              <a:t>4. THE WITHDRAWAL TEST</a:t>
+            </a:r>
+            <a:endParaRPr lang="en-US" sz="900" dirty="0"/>
+          </a:p>
+        </p:txBody>
+      </p:sp>
+      <p:sp>
+        <p:nvSpPr>
+          <p:cNvPr id="72" name="Text 56"/>
+          <p:cNvSpPr/>
+          <p:nvPr/>
+        </p:nvSpPr>
+        <p:spPr>
+          <a:xfrm>
+            <a:off x="868680" y="6108192"/>
+            <a:ext cx="5824728" cy="365760"/>
+          </a:xfrm>
+          <a:prstGeom prst="rect">
+            <a:avLst/>
+          </a:prstGeom>
+          <a:noFill/>
+          <a:ln/>
+        </p:spPr>
+        <p:txBody>
+          <a:bodyPr wrap="square" lIns="0" tIns="0" rIns="0" bIns="0" rtlCol="0" anchor="t"/>
+          <a:lstStyle/>
+          <a:p>
+            <a:pPr algn="ctr" indent="0" marL="0">
+              <a:buNone/>
+            </a:pPr>
+            <a:r>
+              <a:rPr lang="en-US" sz="880" b="1" i="1" dirty="0">
+                <a:solidFill>
+                  <a:srgbClr val="FFFFFF"/>
+                </a:solidFill>
+                <a:latin typeface="Arial" pitchFamily="34" charset="0"/>
+                <a:ea typeface="Arial" pitchFamily="34" charset="-122"/>
+                <a:cs typeface="Arial" pitchFamily="34" charset="-120"/>
+              </a:rPr>
+              <a:t>What specific requirement or learning objective can no longer be safely or meaningfully achieved, and why will coaching or authorised adjustment not restore it?</a:t>
+            </a:r>
+            <a:endParaRPr lang="en-US" sz="880" dirty="0"/>
+          </a:p>
+        </p:txBody>
+      </p:sp>
+      <p:sp>
+        <p:nvSpPr>
           <p:cNvPr id="73" name="Text 57"/>
           <p:cNvSpPr/>
           <p:nvPr/>
         </p:nvSpPr>
         <p:spPr>
           <a:xfrm>
-            <a:off x="5017008" y="4773168"/>
-            <a:ext cx="2033016" cy="182880"/>
+            <a:off x="868680" y="6492240"/>
+            <a:ext cx="5824728" cy="164592"/>
           </a:xfrm>
           <a:prstGeom prst="rect">
             <a:avLst/>
@@ -3042,30 +3009,50 @@
               <a:buNone/>
             </a:pPr>
             <a:r>
-              <a:rPr lang="en-US" sz="820" b="1" dirty="0">
-                <a:solidFill>
-                  <a:srgbClr val="002516"/>
-                </a:solidFill>
-                <a:latin typeface="Arial" pitchFamily="34" charset="0"/>
-                <a:ea typeface="Arial" pitchFamily="34" charset="-122"/>
-                <a:cs typeface="Arial" pitchFamily="34" charset="-120"/>
-              </a:rPr>
-              <a:t>Conduct</a:t>
-            </a:r>
-            <a:endParaRPr lang="en-US" sz="820" dirty="0"/>
-          </a:p>
-        </p:txBody>
-      </p:sp>
-      <p:sp>
-        <p:nvSpPr>
-          <p:cNvPr id="74" name="Text 58"/>
-          <p:cNvSpPr/>
-          <p:nvPr/>
-        </p:nvSpPr>
-        <p:spPr>
-          <a:xfrm>
-            <a:off x="5017008" y="4956048"/>
-            <a:ext cx="2033016" cy="146304"/>
+              <a:rPr lang="en-US" sz="740" i="1" dirty="0">
+                <a:solidFill>
+                  <a:srgbClr val="CDD2B7"/>
+                </a:solidFill>
+                <a:latin typeface="Arial" pitchFamily="34" charset="0"/>
+                <a:ea typeface="Arial" pitchFamily="34" charset="-122"/>
+                <a:cs typeface="Arial" pitchFamily="34" charset="-120"/>
+              </a:rPr>
+              <a:t>A slower team, greater workload or frustration alone do not meet this threshold.</a:t>
+            </a:r>
+            <a:endParaRPr lang="en-US" sz="740" dirty="0"/>
+          </a:p>
+        </p:txBody>
+      </p:sp>
+      <p:sp>
+        <p:nvSpPr>
+          <p:cNvPr id="74" name="Shape 58"/>
+          <p:cNvSpPr/>
+          <p:nvPr/>
+        </p:nvSpPr>
+        <p:spPr>
+          <a:xfrm>
+            <a:off x="457200" y="6894576"/>
+            <a:ext cx="6647688" cy="274320"/>
+          </a:xfrm>
+          <a:prstGeom prst="rect">
+            <a:avLst/>
+          </a:prstGeom>
+          <a:solidFill>
+            <a:srgbClr val="002516"/>
+          </a:solidFill>
+          <a:ln/>
+        </p:spPr>
+      </p:sp>
+      <p:sp>
+        <p:nvSpPr>
+          <p:cNvPr id="75" name="Text 59"/>
+          <p:cNvSpPr/>
+          <p:nvPr/>
+        </p:nvSpPr>
+        <p:spPr>
+          <a:xfrm>
+            <a:off x="457200" y="6894576"/>
+            <a:ext cx="6647688" cy="274320"/>
           </a:xfrm>
           <a:prstGeom prst="rect">
             <a:avLst/>
@@ -3081,56 +3068,17 @@
               <a:buNone/>
             </a:pPr>
             <a:r>
-              <a:rPr lang="en-US" sz="660" i="1" dirty="0">
-                <a:solidFill>
-                  <a:srgbClr val="C62026"/>
-                </a:solidFill>
-                <a:latin typeface="Arial" pitchFamily="34" charset="0"/>
-                <a:ea typeface="Arial" pitchFamily="34" charset="-122"/>
-                <a:cs typeface="Arial" pitchFamily="34" charset="-120"/>
-              </a:rPr>
-              <a:t>Protects the activity</a:t>
-            </a:r>
-            <a:endParaRPr lang="en-US" sz="660" dirty="0"/>
-          </a:p>
-        </p:txBody>
-      </p:sp>
-      <p:sp>
-        <p:nvSpPr>
-          <p:cNvPr id="75" name="Text 59"/>
-          <p:cNvSpPr/>
-          <p:nvPr/>
-        </p:nvSpPr>
-        <p:spPr>
-          <a:xfrm>
-            <a:off x="5071872" y="5138928"/>
-            <a:ext cx="1923288" cy="585216"/>
-          </a:xfrm>
-          <a:prstGeom prst="rect">
-            <a:avLst/>
-          </a:prstGeom>
-          <a:noFill/>
-          <a:ln/>
-        </p:spPr>
-        <p:txBody>
-          <a:bodyPr wrap="square" lIns="0" tIns="0" rIns="0" bIns="0" rtlCol="0" anchor="t"/>
-          <a:lstStyle/>
-          <a:p>
-            <a:pPr algn="ctr" indent="0" marL="0">
-              <a:buNone/>
-            </a:pPr>
-            <a:r>
-              <a:rPr lang="en-US" sz="680" dirty="0">
-                <a:solidFill>
-                  <a:srgbClr val="000000"/>
-                </a:solidFill>
-                <a:latin typeface="Arial" pitchFamily="34" charset="0"/>
-                <a:ea typeface="Arial" pitchFamily="34" charset="-122"/>
-                <a:cs typeface="Arial" pitchFamily="34" charset="-120"/>
-              </a:rPr>
-              <a:t>The participant refuses to follow lawful instructions or behaves in a way that prevents the safe and effective conduct of the activity.</a:t>
-            </a:r>
-            <a:endParaRPr lang="en-US" sz="680" dirty="0"/>
+              <a:rPr lang="en-US" sz="900" b="1" spc="150" kern="0" dirty="0">
+                <a:solidFill>
+                  <a:srgbClr val="FFFFFF"/>
+                </a:solidFill>
+                <a:latin typeface="Arial" pitchFamily="34" charset="0"/>
+                <a:ea typeface="Arial" pitchFamily="34" charset="-122"/>
+                <a:cs typeface="Arial" pitchFamily="34" charset="-120"/>
+              </a:rPr>
+              <a:t>5. DECISION PROCESS</a:t>
+            </a:r>
+            <a:endParaRPr lang="en-US" sz="900" dirty="0"/>
           </a:p>
         </p:txBody>
       </p:sp>
@@ -3142,204 +3090,8 @@
         </p:nvSpPr>
         <p:spPr>
           <a:xfrm>
-            <a:off x="457200" y="5870448"/>
-            <a:ext cx="6647688" cy="914400"/>
-          </a:xfrm>
-          <a:prstGeom prst="rect">
-            <a:avLst/>
-          </a:prstGeom>
-          <a:solidFill>
-            <a:srgbClr val="3A4B00"/>
-          </a:solidFill>
-          <a:ln/>
-        </p:spPr>
-      </p:sp>
-      <p:sp>
-        <p:nvSpPr>
-          <p:cNvPr id="77" name="Text 61"/>
-          <p:cNvSpPr/>
-          <p:nvPr/>
-        </p:nvSpPr>
-        <p:spPr>
-          <a:xfrm>
-            <a:off x="457200" y="5916168"/>
-            <a:ext cx="6647688" cy="164592"/>
-          </a:xfrm>
-          <a:prstGeom prst="rect">
-            <a:avLst/>
-          </a:prstGeom>
-          <a:noFill/>
-          <a:ln/>
-        </p:spPr>
-        <p:txBody>
-          <a:bodyPr wrap="square" lIns="0" tIns="0" rIns="0" bIns="0" rtlCol="0" anchor="ctr"/>
-          <a:lstStyle/>
-          <a:p>
-            <a:pPr algn="ctr" indent="0" marL="0">
-              <a:buNone/>
-            </a:pPr>
-            <a:r>
-              <a:rPr lang="en-US" sz="860" b="1" spc="200" kern="0" dirty="0">
-                <a:solidFill>
-                  <a:srgbClr val="CDD2B7"/>
-                </a:solidFill>
-                <a:latin typeface="Arial" pitchFamily="34" charset="0"/>
-                <a:ea typeface="Arial" pitchFamily="34" charset="-122"/>
-                <a:cs typeface="Arial" pitchFamily="34" charset="-120"/>
-              </a:rPr>
-              <a:t>4. THE WITHDRAWAL TEST</a:t>
-            </a:r>
-            <a:endParaRPr lang="en-US" sz="860" dirty="0"/>
-          </a:p>
-        </p:txBody>
-      </p:sp>
-      <p:sp>
-        <p:nvSpPr>
-          <p:cNvPr id="78" name="Text 62"/>
-          <p:cNvSpPr/>
-          <p:nvPr/>
-        </p:nvSpPr>
-        <p:spPr>
-          <a:xfrm>
-            <a:off x="777240" y="6089904"/>
-            <a:ext cx="6007608" cy="475488"/>
-          </a:xfrm>
-          <a:prstGeom prst="rect">
-            <a:avLst/>
-          </a:prstGeom>
-          <a:noFill/>
-          <a:ln/>
-        </p:spPr>
-        <p:txBody>
-          <a:bodyPr wrap="square" lIns="0" tIns="0" rIns="0" bIns="0" rtlCol="0" anchor="t"/>
-          <a:lstStyle/>
-          <a:p>
-            <a:pPr algn="ctr" indent="0" marL="0">
-              <a:buNone/>
-            </a:pPr>
-            <a:r>
-              <a:rPr lang="en-US" sz="800" b="1" i="1" dirty="0">
-                <a:solidFill>
-                  <a:srgbClr val="FFFFFF"/>
-                </a:solidFill>
-                <a:latin typeface="Arial" pitchFamily="34" charset="0"/>
-                <a:ea typeface="Arial" pitchFamily="34" charset="-122"/>
-                <a:cs typeface="Arial" pitchFamily="34" charset="-120"/>
-              </a:rPr>
-              <a:t>What specific safety requirement, required activity, or approved learning or assessment objective can no longer be safely or meaningfully achieved, and what evidence shows that reasonable coaching, team adaptation or authorised adjustment will not restore the necessary conditions?</a:t>
-            </a:r>
-            <a:endParaRPr lang="en-US" sz="800" dirty="0"/>
-          </a:p>
-        </p:txBody>
-      </p:sp>
-      <p:sp>
-        <p:nvSpPr>
-          <p:cNvPr id="79" name="Text 63"/>
-          <p:cNvSpPr/>
-          <p:nvPr/>
-        </p:nvSpPr>
-        <p:spPr>
-          <a:xfrm>
-            <a:off x="777240" y="6565392"/>
-            <a:ext cx="6007608" cy="164592"/>
-          </a:xfrm>
-          <a:prstGeom prst="rect">
-            <a:avLst/>
-          </a:prstGeom>
-          <a:noFill/>
-          <a:ln/>
-        </p:spPr>
-        <p:txBody>
-          <a:bodyPr wrap="square" lIns="0" tIns="0" rIns="0" bIns="0" rtlCol="0" anchor="ctr"/>
-          <a:lstStyle/>
-          <a:p>
-            <a:pPr algn="ctr" indent="0" marL="0">
-              <a:buNone/>
-            </a:pPr>
-            <a:r>
-              <a:rPr lang="en-US" sz="700" i="1" dirty="0">
-                <a:solidFill>
-                  <a:srgbClr val="CDD2B7"/>
-                </a:solidFill>
-                <a:latin typeface="Arial" pitchFamily="34" charset="0"/>
-                <a:ea typeface="Arial" pitchFamily="34" charset="-122"/>
-                <a:cs typeface="Arial" pitchFamily="34" charset="-120"/>
-              </a:rPr>
-              <a:t>A slower team, greater workload or frustration alone will not normally meet this threshold.</a:t>
-            </a:r>
-            <a:endParaRPr lang="en-US" sz="700" dirty="0"/>
-          </a:p>
-        </p:txBody>
-      </p:sp>
-      <p:sp>
-        <p:nvSpPr>
-          <p:cNvPr id="80" name="Shape 64"/>
-          <p:cNvSpPr/>
-          <p:nvPr/>
-        </p:nvSpPr>
-        <p:spPr>
-          <a:xfrm>
-            <a:off x="457200" y="6894576"/>
-            <a:ext cx="6647688" cy="256032"/>
-          </a:xfrm>
-          <a:prstGeom prst="rect">
-            <a:avLst/>
-          </a:prstGeom>
-          <a:solidFill>
-            <a:srgbClr val="002516"/>
-          </a:solidFill>
-          <a:ln/>
-        </p:spPr>
-      </p:sp>
-      <p:sp>
-        <p:nvSpPr>
-          <p:cNvPr id="81" name="Text 65"/>
-          <p:cNvSpPr/>
-          <p:nvPr/>
-        </p:nvSpPr>
-        <p:spPr>
-          <a:xfrm>
-            <a:off x="457200" y="6894576"/>
-            <a:ext cx="6647688" cy="256032"/>
-          </a:xfrm>
-          <a:prstGeom prst="rect">
-            <a:avLst/>
-          </a:prstGeom>
-          <a:noFill/>
-          <a:ln/>
-        </p:spPr>
-        <p:txBody>
-          <a:bodyPr wrap="square" lIns="0" tIns="0" rIns="0" bIns="0" rtlCol="0" anchor="ctr"/>
-          <a:lstStyle/>
-          <a:p>
-            <a:pPr algn="ctr" indent="0" marL="0">
-              <a:buNone/>
-            </a:pPr>
-            <a:r>
-              <a:rPr lang="en-US" sz="860" b="1" spc="150" kern="0" dirty="0">
-                <a:solidFill>
-                  <a:srgbClr val="FFFFFF"/>
-                </a:solidFill>
-                <a:latin typeface="Arial" pitchFamily="34" charset="0"/>
-                <a:ea typeface="Arial" pitchFamily="34" charset="-122"/>
-                <a:cs typeface="Arial" pitchFamily="34" charset="-120"/>
-              </a:rPr>
-              <a:t>5. DECISION PROCESS</a:t>
-            </a:r>
-            <a:endParaRPr lang="en-US" sz="860" dirty="0"/>
-          </a:p>
-        </p:txBody>
-      </p:sp>
-      <p:sp>
-        <p:nvSpPr>
-          <p:cNvPr id="82" name="Shape 66"/>
-          <p:cNvSpPr/>
-          <p:nvPr/>
-        </p:nvSpPr>
-        <p:spPr>
-          <a:xfrm>
-            <a:off x="457200" y="7260336"/>
-            <a:ext cx="310896" cy="310896"/>
+            <a:off x="457200" y="7296912"/>
+            <a:ext cx="347472" cy="347472"/>
           </a:xfrm>
           <a:prstGeom prst="ellipse">
             <a:avLst/>
@@ -3357,7 +3109,7 @@
       </p:sp>
       <p:pic>
         <p:nvPicPr>
-          <p:cNvPr id="83" name="Image 14" descr="preencoded.png">    </p:cNvPr>
+          <p:cNvPr id="77" name="Image 14" descr="preencoded.png">    </p:cNvPr>
           <p:cNvPicPr>
             <a:picLocks noChangeAspect="1"/>
           </p:cNvPicPr>
@@ -3371,8 +3123,8 @@
         </p:blipFill>
         <p:spPr>
           <a:xfrm>
-            <a:off x="521208" y="7324344"/>
-            <a:ext cx="182880" cy="182880"/>
+            <a:off x="534924" y="7374636"/>
+            <a:ext cx="192024" cy="192024"/>
           </a:xfrm>
           <a:prstGeom prst="rect">
             <a:avLst/>
@@ -3381,14 +3133,14 @@
       </p:pic>
       <p:sp>
         <p:nvSpPr>
-          <p:cNvPr id="84" name="Text 67"/>
-          <p:cNvSpPr/>
-          <p:nvPr/>
-        </p:nvSpPr>
-        <p:spPr>
-          <a:xfrm>
-            <a:off x="822960" y="7242048"/>
-            <a:ext cx="1691640" cy="164592"/>
+          <p:cNvPr id="78" name="Text 61"/>
+          <p:cNvSpPr/>
+          <p:nvPr/>
+        </p:nvSpPr>
+        <p:spPr>
+          <a:xfrm>
+            <a:off x="877824" y="7278624"/>
+            <a:ext cx="1636776" cy="182880"/>
           </a:xfrm>
           <a:prstGeom prst="rect">
             <a:avLst/>
@@ -3404,7 +3156,7 @@
               <a:buNone/>
             </a:pPr>
             <a:r>
-              <a:rPr lang="en-US" sz="780" b="1" dirty="0">
+              <a:rPr lang="en-US" sz="900" b="1" dirty="0">
                 <a:solidFill>
                   <a:srgbClr val="C62026"/>
                 </a:solidFill>
@@ -3418,7 +3170,7 @@
               <a:buNone/>
             </a:pPr>
             <a:r>
-              <a:rPr lang="en-US" sz="780" b="1" dirty="0">
+              <a:rPr lang="en-US" sz="900" b="1" dirty="0">
                 <a:solidFill>
                   <a:srgbClr val="002516"/>
                 </a:solidFill>
@@ -3426,22 +3178,22 @@
                 <a:ea typeface="Arial" pitchFamily="34" charset="-122"/>
                 <a:cs typeface="Arial" pitchFamily="34" charset="-120"/>
               </a:rPr>
-              <a:t>Observe and enable</a:t>
-            </a:r>
-            <a:endParaRPr lang="en-US" sz="780" dirty="0"/>
-          </a:p>
-        </p:txBody>
-      </p:sp>
-      <p:sp>
-        <p:nvSpPr>
-          <p:cNvPr id="85" name="Text 68"/>
-          <p:cNvSpPr/>
-          <p:nvPr/>
-        </p:nvSpPr>
-        <p:spPr>
-          <a:xfrm>
-            <a:off x="822960" y="7406640"/>
-            <a:ext cx="1673352" cy="603504"/>
+              <a:t>Observe</a:t>
+            </a:r>
+            <a:endParaRPr lang="en-US" sz="900" dirty="0"/>
+          </a:p>
+        </p:txBody>
+      </p:sp>
+      <p:sp>
+        <p:nvSpPr>
+          <p:cNvPr id="79" name="Text 62"/>
+          <p:cNvSpPr/>
+          <p:nvPr/>
+        </p:nvSpPr>
+        <p:spPr>
+          <a:xfrm>
+            <a:off x="877824" y="7470648"/>
+            <a:ext cx="1618488" cy="402336"/>
           </a:xfrm>
           <a:prstGeom prst="rect">
             <a:avLst/>
@@ -3457,7 +3209,7 @@
               <a:buNone/>
             </a:pPr>
             <a:r>
-              <a:rPr lang="en-US" sz="630" dirty="0">
+              <a:rPr lang="en-US" sz="720" dirty="0">
                 <a:solidFill>
                   <a:srgbClr val="000000"/>
                 </a:solidFill>
@@ -3465,21 +3217,21 @@
                 <a:ea typeface="Arial" pitchFamily="34" charset="-122"/>
                 <a:cs typeface="Arial" pitchFamily="34" charset="-120"/>
               </a:rPr>
-              <a:t>Identify the issue; allow the team a reasonable opportunity to recognise, respond and manage it.</a:t>
-            </a:r>
-            <a:endParaRPr lang="en-US" sz="630" dirty="0"/>
-          </a:p>
-        </p:txBody>
-      </p:sp>
-      <p:sp>
-        <p:nvSpPr>
-          <p:cNvPr id="86" name="Text 69"/>
-          <p:cNvSpPr/>
-          <p:nvPr/>
-        </p:nvSpPr>
-        <p:spPr>
-          <a:xfrm>
-            <a:off x="2478024" y="7296912"/>
+              <a:t>Identify the issue and allow the team to respond.</a:t>
+            </a:r>
+            <a:endParaRPr lang="en-US" sz="720" dirty="0"/>
+          </a:p>
+        </p:txBody>
+      </p:sp>
+      <p:sp>
+        <p:nvSpPr>
+          <p:cNvPr id="80" name="Text 63"/>
+          <p:cNvSpPr/>
+          <p:nvPr/>
+        </p:nvSpPr>
+        <p:spPr>
+          <a:xfrm>
+            <a:off x="2478024" y="7351776"/>
             <a:ext cx="310896" cy="219456"/>
           </a:xfrm>
           <a:prstGeom prst="rect">
@@ -3512,14 +3264,14 @@
       </p:sp>
       <p:sp>
         <p:nvSpPr>
-          <p:cNvPr id="87" name="Shape 70"/>
-          <p:cNvSpPr/>
-          <p:nvPr/>
-        </p:nvSpPr>
-        <p:spPr>
-          <a:xfrm>
-            <a:off x="2752344" y="7260336"/>
-            <a:ext cx="310896" cy="310896"/>
+          <p:cNvPr id="81" name="Shape 64"/>
+          <p:cNvSpPr/>
+          <p:nvPr/>
+        </p:nvSpPr>
+        <p:spPr>
+          <a:xfrm>
+            <a:off x="2752344" y="7296912"/>
+            <a:ext cx="347472" cy="347472"/>
           </a:xfrm>
           <a:prstGeom prst="ellipse">
             <a:avLst/>
@@ -3537,7 +3289,7 @@
       </p:sp>
       <p:pic>
         <p:nvPicPr>
-          <p:cNvPr id="88" name="Image 15" descr="preencoded.png">    </p:cNvPr>
+          <p:cNvPr id="82" name="Image 15" descr="preencoded.png">    </p:cNvPr>
           <p:cNvPicPr>
             <a:picLocks noChangeAspect="1"/>
           </p:cNvPicPr>
@@ -3551,8 +3303,8 @@
         </p:blipFill>
         <p:spPr>
           <a:xfrm>
-            <a:off x="2816352" y="7324344"/>
-            <a:ext cx="182880" cy="182880"/>
+            <a:off x="2830068" y="7374636"/>
+            <a:ext cx="192024" cy="192024"/>
           </a:xfrm>
           <a:prstGeom prst="rect">
             <a:avLst/>
@@ -3561,14 +3313,14 @@
       </p:pic>
       <p:sp>
         <p:nvSpPr>
-          <p:cNvPr id="89" name="Text 71"/>
-          <p:cNvSpPr/>
-          <p:nvPr/>
-        </p:nvSpPr>
-        <p:spPr>
-          <a:xfrm>
-            <a:off x="3118104" y="7242048"/>
-            <a:ext cx="1691640" cy="164592"/>
+          <p:cNvPr id="83" name="Text 65"/>
+          <p:cNvSpPr/>
+          <p:nvPr/>
+        </p:nvSpPr>
+        <p:spPr>
+          <a:xfrm>
+            <a:off x="3172968" y="7278624"/>
+            <a:ext cx="1636776" cy="182880"/>
           </a:xfrm>
           <a:prstGeom prst="rect">
             <a:avLst/>
@@ -3584,7 +3336,7 @@
               <a:buNone/>
             </a:pPr>
             <a:r>
-              <a:rPr lang="en-US" sz="780" b="1" dirty="0">
+              <a:rPr lang="en-US" sz="900" b="1" dirty="0">
                 <a:solidFill>
                   <a:srgbClr val="C62026"/>
                 </a:solidFill>
@@ -3598,7 +3350,7 @@
               <a:buNone/>
             </a:pPr>
             <a:r>
-              <a:rPr lang="en-US" sz="780" b="1" dirty="0">
+              <a:rPr lang="en-US" sz="900" b="1" dirty="0">
                 <a:solidFill>
                   <a:srgbClr val="002516"/>
                 </a:solidFill>
@@ -3606,22 +3358,22 @@
                 <a:ea typeface="Arial" pitchFamily="34" charset="-122"/>
                 <a:cs typeface="Arial" pitchFamily="34" charset="-120"/>
               </a:rPr>
-              <a:t>Intervene and reassess</a:t>
-            </a:r>
-            <a:endParaRPr lang="en-US" sz="780" dirty="0"/>
-          </a:p>
-        </p:txBody>
-      </p:sp>
-      <p:sp>
-        <p:nvSpPr>
-          <p:cNvPr id="90" name="Text 72"/>
-          <p:cNvSpPr/>
-          <p:nvPr/>
-        </p:nvSpPr>
-        <p:spPr>
-          <a:xfrm>
-            <a:off x="3118104" y="7406640"/>
-            <a:ext cx="1673352" cy="603504"/>
+              <a:t>Intervene</a:t>
+            </a:r>
+            <a:endParaRPr lang="en-US" sz="900" dirty="0"/>
+          </a:p>
+        </p:txBody>
+      </p:sp>
+      <p:sp>
+        <p:nvSpPr>
+          <p:cNvPr id="84" name="Text 66"/>
+          <p:cNvSpPr/>
+          <p:nvPr/>
+        </p:nvSpPr>
+        <p:spPr>
+          <a:xfrm>
+            <a:off x="3172968" y="7470648"/>
+            <a:ext cx="1618488" cy="402336"/>
           </a:xfrm>
           <a:prstGeom prst="rect">
             <a:avLst/>
@@ -3637,7 +3389,7 @@
               <a:buNone/>
             </a:pPr>
             <a:r>
-              <a:rPr lang="en-US" sz="630" dirty="0">
+              <a:rPr lang="en-US" sz="720" dirty="0">
                 <a:solidFill>
                   <a:srgbClr val="000000"/>
                 </a:solidFill>
@@ -3645,21 +3397,21 @@
                 <a:ea typeface="Arial" pitchFamily="34" charset="-122"/>
                 <a:cs typeface="Arial" pitchFamily="34" charset="-120"/>
               </a:rPr>
-              <a:t>Provide clear feedback; apply authorised adjustments; reassess whether safe and meaningful participation remains achievable.</a:t>
-            </a:r>
-            <a:endParaRPr lang="en-US" sz="630" dirty="0"/>
-          </a:p>
-        </p:txBody>
-      </p:sp>
-      <p:sp>
-        <p:nvSpPr>
-          <p:cNvPr id="91" name="Text 73"/>
-          <p:cNvSpPr/>
-          <p:nvPr/>
-        </p:nvSpPr>
-        <p:spPr>
-          <a:xfrm>
-            <a:off x="4773168" y="7296912"/>
+              <a:t>Coach, apply authorised adjustments and reassess.</a:t>
+            </a:r>
+            <a:endParaRPr lang="en-US" sz="720" dirty="0"/>
+          </a:p>
+        </p:txBody>
+      </p:sp>
+      <p:sp>
+        <p:nvSpPr>
+          <p:cNvPr id="85" name="Text 67"/>
+          <p:cNvSpPr/>
+          <p:nvPr/>
+        </p:nvSpPr>
+        <p:spPr>
+          <a:xfrm>
+            <a:off x="4773168" y="7351776"/>
             <a:ext cx="310896" cy="219456"/>
           </a:xfrm>
           <a:prstGeom prst="rect">
@@ -3692,14 +3444,14 @@
       </p:sp>
       <p:sp>
         <p:nvSpPr>
-          <p:cNvPr id="92" name="Shape 74"/>
-          <p:cNvSpPr/>
-          <p:nvPr/>
-        </p:nvSpPr>
-        <p:spPr>
-          <a:xfrm>
-            <a:off x="5047488" y="7260336"/>
-            <a:ext cx="310896" cy="310896"/>
+          <p:cNvPr id="86" name="Shape 68"/>
+          <p:cNvSpPr/>
+          <p:nvPr/>
+        </p:nvSpPr>
+        <p:spPr>
+          <a:xfrm>
+            <a:off x="5047488" y="7296912"/>
+            <a:ext cx="347472" cy="347472"/>
           </a:xfrm>
           <a:prstGeom prst="ellipse">
             <a:avLst/>
@@ -3717,7 +3469,7 @@
       </p:sp>
       <p:pic>
         <p:nvPicPr>
-          <p:cNvPr id="93" name="Image 16" descr="preencoded.png">    </p:cNvPr>
+          <p:cNvPr id="87" name="Image 16" descr="preencoded.png">    </p:cNvPr>
           <p:cNvPicPr>
             <a:picLocks noChangeAspect="1"/>
           </p:cNvPicPr>
@@ -3731,8 +3483,8 @@
         </p:blipFill>
         <p:spPr>
           <a:xfrm>
-            <a:off x="5111496" y="7324344"/>
-            <a:ext cx="182880" cy="182880"/>
+            <a:off x="5125212" y="7374636"/>
+            <a:ext cx="192024" cy="192024"/>
           </a:xfrm>
           <a:prstGeom prst="rect">
             <a:avLst/>
@@ -3741,14 +3493,14 @@
       </p:pic>
       <p:sp>
         <p:nvSpPr>
-          <p:cNvPr id="94" name="Text 75"/>
-          <p:cNvSpPr/>
-          <p:nvPr/>
-        </p:nvSpPr>
-        <p:spPr>
-          <a:xfrm>
-            <a:off x="5413248" y="7242048"/>
-            <a:ext cx="1691640" cy="164592"/>
+          <p:cNvPr id="88" name="Text 69"/>
+          <p:cNvSpPr/>
+          <p:nvPr/>
+        </p:nvSpPr>
+        <p:spPr>
+          <a:xfrm>
+            <a:off x="5468112" y="7278624"/>
+            <a:ext cx="1636776" cy="182880"/>
           </a:xfrm>
           <a:prstGeom prst="rect">
             <a:avLst/>
@@ -3764,7 +3516,7 @@
               <a:buNone/>
             </a:pPr>
             <a:r>
-              <a:rPr lang="en-US" sz="780" b="1" dirty="0">
+              <a:rPr lang="en-US" sz="900" b="1" dirty="0">
                 <a:solidFill>
                   <a:srgbClr val="C62026"/>
                 </a:solidFill>
@@ -3778,7 +3530,7 @@
               <a:buNone/>
             </a:pPr>
             <a:r>
-              <a:rPr lang="en-US" sz="780" b="1" dirty="0">
+              <a:rPr lang="en-US" sz="900" b="1" dirty="0">
                 <a:solidFill>
                   <a:srgbClr val="002516"/>
                 </a:solidFill>
@@ -3786,22 +3538,22 @@
                 <a:ea typeface="Arial" pitchFamily="34" charset="-122"/>
                 <a:cs typeface="Arial" pitchFamily="34" charset="-120"/>
               </a:rPr>
-              <a:t>Decide and record</a:t>
-            </a:r>
-            <a:endParaRPr lang="en-US" sz="780" dirty="0"/>
-          </a:p>
-        </p:txBody>
-      </p:sp>
-      <p:sp>
-        <p:nvSpPr>
-          <p:cNvPr id="95" name="Text 76"/>
-          <p:cNvSpPr/>
-          <p:nvPr/>
-        </p:nvSpPr>
-        <p:spPr>
-          <a:xfrm>
-            <a:off x="5413248" y="7406640"/>
-            <a:ext cx="1673352" cy="603504"/>
+              <a:t>Decide</a:t>
+            </a:r>
+            <a:endParaRPr lang="en-US" sz="900" dirty="0"/>
+          </a:p>
+        </p:txBody>
+      </p:sp>
+      <p:sp>
+        <p:nvSpPr>
+          <p:cNvPr id="89" name="Text 70"/>
+          <p:cNvSpPr/>
+          <p:nvPr/>
+        </p:nvSpPr>
+        <p:spPr>
+          <a:xfrm>
+            <a:off x="5468112" y="7470648"/>
+            <a:ext cx="1618488" cy="402336"/>
           </a:xfrm>
           <a:prstGeom prst="rect">
             <a:avLst/>
@@ -3817,7 +3569,7 @@
               <a:buNone/>
             </a:pPr>
             <a:r>
-              <a:rPr lang="en-US" sz="630" dirty="0">
+              <a:rPr lang="en-US" sz="720" dirty="0">
                 <a:solidFill>
                   <a:srgbClr val="000000"/>
                 </a:solidFill>
@@ -3825,22 +3577,22 @@
                 <a:ea typeface="Arial" pitchFamily="34" charset="-122"/>
                 <a:cs typeface="Arial" pitchFamily="34" charset="-120"/>
               </a:rPr>
-              <a:t>If withdrawal remains necessary, staff provide observations and a recommendation to the designated uniformed authority.</a:t>
-            </a:r>
-            <a:endParaRPr lang="en-US" sz="630" dirty="0"/>
-          </a:p>
-        </p:txBody>
-      </p:sp>
-      <p:sp>
-        <p:nvSpPr>
-          <p:cNvPr id="96" name="Shape 77"/>
-          <p:cNvSpPr/>
-          <p:nvPr/>
-        </p:nvSpPr>
-        <p:spPr>
-          <a:xfrm>
-            <a:off x="457200" y="8065008"/>
-            <a:ext cx="6647688" cy="292608"/>
+              <a:t>Recommend withdrawal to the designated authority.</a:t>
+            </a:r>
+            <a:endParaRPr lang="en-US" sz="720" dirty="0"/>
+          </a:p>
+        </p:txBody>
+      </p:sp>
+      <p:sp>
+        <p:nvSpPr>
+          <p:cNvPr id="90" name="Shape 71"/>
+          <p:cNvSpPr/>
+          <p:nvPr/>
+        </p:nvSpPr>
+        <p:spPr>
+          <a:xfrm>
+            <a:off x="457200" y="7955280"/>
+            <a:ext cx="6647688" cy="310896"/>
           </a:xfrm>
           <a:prstGeom prst="rect">
             <a:avLst/>
@@ -3855,14 +3607,14 @@
       </p:sp>
       <p:sp>
         <p:nvSpPr>
-          <p:cNvPr id="97" name="Text 78"/>
-          <p:cNvSpPr/>
-          <p:nvPr/>
-        </p:nvSpPr>
-        <p:spPr>
-          <a:xfrm>
-            <a:off x="594360" y="8065008"/>
-            <a:ext cx="6373368" cy="292608"/>
+          <p:cNvPr id="91" name="Text 72"/>
+          <p:cNvSpPr/>
+          <p:nvPr/>
+        </p:nvSpPr>
+        <p:spPr>
+          <a:xfrm>
+            <a:off x="594360" y="7955280"/>
+            <a:ext cx="6373368" cy="310896"/>
           </a:xfrm>
           <a:prstGeom prst="rect">
             <a:avLst/>
@@ -3878,7 +3630,7 @@
               <a:buNone/>
             </a:pPr>
             <a:r>
-              <a:rPr lang="en-US" sz="740" b="1" dirty="0">
+              <a:rPr lang="en-US" sz="760" b="1" dirty="0">
                 <a:solidFill>
                   <a:srgbClr val="002516"/>
                 </a:solidFill>
@@ -3892,7 +3644,7 @@
               <a:buNone/>
             </a:pPr>
             <a:r>
-              <a:rPr lang="en-US" sz="740" dirty="0">
+              <a:rPr lang="en-US" sz="760" dirty="0">
                 <a:solidFill>
                   <a:srgbClr val="000000"/>
                 </a:solidFill>
@@ -3902,20 +3654,20 @@
               </a:rPr>
               <a:t>CI NZALC and CI NCO School discuss the case; CI NZALC recommends withdrawal to COMDT ACS for confirmation.</a:t>
             </a:r>
-            <a:endParaRPr lang="en-US" sz="740" dirty="0"/>
-          </a:p>
-        </p:txBody>
-      </p:sp>
-      <p:sp>
-        <p:nvSpPr>
-          <p:cNvPr id="98" name="Shape 79"/>
-          <p:cNvSpPr/>
-          <p:nvPr/>
-        </p:nvSpPr>
-        <p:spPr>
-          <a:xfrm>
-            <a:off x="457200" y="8485632"/>
-            <a:ext cx="3017520" cy="237744"/>
+            <a:endParaRPr lang="en-US" sz="760" dirty="0"/>
+          </a:p>
+        </p:txBody>
+      </p:sp>
+      <p:sp>
+        <p:nvSpPr>
+          <p:cNvPr id="92" name="Shape 73"/>
+          <p:cNvSpPr/>
+          <p:nvPr/>
+        </p:nvSpPr>
+        <p:spPr>
+          <a:xfrm>
+            <a:off x="457200" y="8467344"/>
+            <a:ext cx="3017520" cy="256032"/>
           </a:xfrm>
           <a:prstGeom prst="rect">
             <a:avLst/>
@@ -3928,14 +3680,14 @@
       </p:sp>
       <p:sp>
         <p:nvSpPr>
-          <p:cNvPr id="99" name="Text 80"/>
-          <p:cNvSpPr/>
-          <p:nvPr/>
-        </p:nvSpPr>
-        <p:spPr>
-          <a:xfrm>
-            <a:off x="457200" y="8485632"/>
-            <a:ext cx="3017520" cy="237744"/>
+          <p:cNvPr id="93" name="Text 74"/>
+          <p:cNvSpPr/>
+          <p:nvPr/>
+        </p:nvSpPr>
+        <p:spPr>
+          <a:xfrm>
+            <a:off x="457200" y="8467344"/>
+            <a:ext cx="3017520" cy="256032"/>
           </a:xfrm>
           <a:prstGeom prst="rect">
             <a:avLst/>
@@ -3951,7 +3703,7 @@
               <a:buNone/>
             </a:pPr>
             <a:r>
-              <a:rPr lang="en-US" sz="780" b="1" spc="150" kern="0" dirty="0">
+              <a:rPr lang="en-US" sz="800" b="1" spc="150" kern="0" dirty="0">
                 <a:solidFill>
                   <a:srgbClr val="FFFFFF"/>
                 </a:solidFill>
@@ -3961,20 +3713,20 @@
               </a:rPr>
               <a:t>6. IMMEDIATE WITHDRAWAL</a:t>
             </a:r>
-            <a:endParaRPr lang="en-US" sz="780" dirty="0"/>
-          </a:p>
-        </p:txBody>
-      </p:sp>
-      <p:sp>
-        <p:nvSpPr>
-          <p:cNvPr id="100" name="Shape 81"/>
+            <a:endParaRPr lang="en-US" sz="800" dirty="0"/>
+          </a:p>
+        </p:txBody>
+      </p:sp>
+      <p:sp>
+        <p:nvSpPr>
+          <p:cNvPr id="94" name="Shape 75"/>
           <p:cNvSpPr/>
           <p:nvPr/>
         </p:nvSpPr>
         <p:spPr>
           <a:xfrm>
             <a:off x="457200" y="8723376"/>
-            <a:ext cx="3017520" cy="1335024"/>
+            <a:ext cx="3017520" cy="1261872"/>
           </a:xfrm>
           <a:prstGeom prst="rect">
             <a:avLst/>
@@ -3989,7 +3741,7 @@
       </p:sp>
       <p:pic>
         <p:nvPicPr>
-          <p:cNvPr id="101" name="Image 17" descr="preencoded.png">    </p:cNvPr>
+          <p:cNvPr id="95" name="Image 17" descr="preencoded.png">    </p:cNvPr>
           <p:cNvPicPr>
             <a:picLocks noChangeAspect="1"/>
           </p:cNvPicPr>
@@ -4003,7 +3755,7 @@
         </p:blipFill>
         <p:spPr>
           <a:xfrm>
-            <a:off x="585216" y="8869680"/>
+            <a:off x="585216" y="8887968"/>
             <a:ext cx="310896" cy="310896"/>
           </a:xfrm>
           <a:prstGeom prst="rect">
@@ -4013,14 +3765,14 @@
       </p:pic>
       <p:sp>
         <p:nvSpPr>
-          <p:cNvPr id="102" name="Text 82"/>
-          <p:cNvSpPr/>
-          <p:nvPr/>
-        </p:nvSpPr>
-        <p:spPr>
-          <a:xfrm>
-            <a:off x="1005840" y="8833104"/>
-            <a:ext cx="2331720" cy="1115568"/>
+          <p:cNvPr id="96" name="Text 76"/>
+          <p:cNvSpPr/>
+          <p:nvPr/>
+        </p:nvSpPr>
+        <p:spPr>
+          <a:xfrm>
+            <a:off x="1005840" y="8851392"/>
+            <a:ext cx="2331720" cy="1005840"/>
           </a:xfrm>
           <a:prstGeom prst="rect">
             <a:avLst/>
@@ -4036,7 +3788,7 @@
               <a:buNone/>
             </a:pPr>
             <a:r>
-              <a:rPr lang="en-US" sz="730" dirty="0">
+              <a:rPr lang="en-US" sz="780" dirty="0">
                 <a:solidFill>
                   <a:srgbClr val="000000"/>
                 </a:solidFill>
@@ -4044,22 +3796,22 @@
                 <a:ea typeface="Arial" pitchFamily="34" charset="-122"/>
                 <a:cs typeface="Arial" pitchFamily="34" charset="-120"/>
               </a:rPr>
-              <a:t>An instructor, safety staff member or medical practitioner may immediately stop or withdraw a participant to manage an immediate safety or medical risk, informing CI NZALC and CI NCO School as soon as practicable.</a:t>
-            </a:r>
-            <a:endParaRPr lang="en-US" sz="730" dirty="0"/>
-          </a:p>
-        </p:txBody>
-      </p:sp>
-      <p:sp>
-        <p:nvSpPr>
-          <p:cNvPr id="103" name="Shape 83"/>
-          <p:cNvSpPr/>
-          <p:nvPr/>
-        </p:nvSpPr>
-        <p:spPr>
-          <a:xfrm>
-            <a:off x="3630168" y="8485632"/>
-            <a:ext cx="3474720" cy="237744"/>
+              <a:t>An instructor, safety staff member or medical practitioner may immediately withdraw a participant to manage an immediate safety or medical risk. Notify CI NZALC and CI NCO School as soon as practicable.</a:t>
+            </a:r>
+            <a:endParaRPr lang="en-US" sz="780" dirty="0"/>
+          </a:p>
+        </p:txBody>
+      </p:sp>
+      <p:sp>
+        <p:nvSpPr>
+          <p:cNvPr id="97" name="Shape 77"/>
+          <p:cNvSpPr/>
+          <p:nvPr/>
+        </p:nvSpPr>
+        <p:spPr>
+          <a:xfrm>
+            <a:off x="3630168" y="8467344"/>
+            <a:ext cx="3474720" cy="256032"/>
           </a:xfrm>
           <a:prstGeom prst="rect">
             <a:avLst/>
@@ -4072,14 +3824,14 @@
       </p:sp>
       <p:sp>
         <p:nvSpPr>
-          <p:cNvPr id="104" name="Text 84"/>
-          <p:cNvSpPr/>
-          <p:nvPr/>
-        </p:nvSpPr>
-        <p:spPr>
-          <a:xfrm>
-            <a:off x="3630168" y="8485632"/>
-            <a:ext cx="3474720" cy="237744"/>
+          <p:cNvPr id="98" name="Text 78"/>
+          <p:cNvSpPr/>
+          <p:nvPr/>
+        </p:nvSpPr>
+        <p:spPr>
+          <a:xfrm>
+            <a:off x="3630168" y="8467344"/>
+            <a:ext cx="3474720" cy="256032"/>
           </a:xfrm>
           <a:prstGeom prst="rect">
             <a:avLst/>
@@ -4095,7 +3847,7 @@
               <a:buNone/>
             </a:pPr>
             <a:r>
-              <a:rPr lang="en-US" sz="780" b="1" spc="150" kern="0" dirty="0">
+              <a:rPr lang="en-US" sz="800" b="1" spc="150" kern="0" dirty="0">
                 <a:solidFill>
                   <a:srgbClr val="FFFFFF"/>
                 </a:solidFill>
@@ -4105,20 +3857,20 @@
               </a:rPr>
               <a:t>7. RECORD OF DECISION</a:t>
             </a:r>
-            <a:endParaRPr lang="en-US" sz="780" dirty="0"/>
-          </a:p>
-        </p:txBody>
-      </p:sp>
-      <p:sp>
-        <p:nvSpPr>
-          <p:cNvPr id="105" name="Shape 85"/>
+            <a:endParaRPr lang="en-US" sz="800" dirty="0"/>
+          </a:p>
+        </p:txBody>
+      </p:sp>
+      <p:sp>
+        <p:nvSpPr>
+          <p:cNvPr id="99" name="Shape 79"/>
           <p:cNvSpPr/>
           <p:nvPr/>
         </p:nvSpPr>
         <p:spPr>
           <a:xfrm>
             <a:off x="3630168" y="8723376"/>
-            <a:ext cx="3474720" cy="1335024"/>
+            <a:ext cx="3474720" cy="1261872"/>
           </a:xfrm>
           <a:prstGeom prst="rect">
             <a:avLst/>
@@ -4136,13 +3888,247 @@
       </p:sp>
       <p:sp>
         <p:nvSpPr>
+          <p:cNvPr id="100" name="Text 80"/>
+          <p:cNvSpPr/>
+          <p:nvPr/>
+        </p:nvSpPr>
+        <p:spPr>
+          <a:xfrm>
+            <a:off x="3739896" y="8796528"/>
+            <a:ext cx="164592" cy="182880"/>
+          </a:xfrm>
+          <a:prstGeom prst="rect">
+            <a:avLst/>
+          </a:prstGeom>
+          <a:noFill/>
+          <a:ln/>
+        </p:spPr>
+        <p:txBody>
+          <a:bodyPr wrap="square" lIns="0" tIns="0" rIns="0" bIns="0" rtlCol="0" anchor="ctr"/>
+          <a:lstStyle/>
+          <a:p>
+            <a:pPr algn="l" indent="0" marL="0">
+              <a:buNone/>
+            </a:pPr>
+            <a:r>
+              <a:rPr lang="en-US" sz="850" b="1" dirty="0">
+                <a:solidFill>
+                  <a:srgbClr val="C62026"/>
+                </a:solidFill>
+                <a:latin typeface="Arial" pitchFamily="34" charset="0"/>
+                <a:ea typeface="Arial" pitchFamily="34" charset="-122"/>
+                <a:cs typeface="Arial" pitchFamily="34" charset="-120"/>
+              </a:rPr>
+              <a:t>✓</a:t>
+            </a:r>
+            <a:endParaRPr lang="en-US" sz="850" dirty="0"/>
+          </a:p>
+        </p:txBody>
+      </p:sp>
+      <p:sp>
+        <p:nvSpPr>
+          <p:cNvPr id="101" name="Text 81"/>
+          <p:cNvSpPr/>
+          <p:nvPr/>
+        </p:nvSpPr>
+        <p:spPr>
+          <a:xfrm>
+            <a:off x="3941064" y="8796528"/>
+            <a:ext cx="3054096" cy="182880"/>
+          </a:xfrm>
+          <a:prstGeom prst="rect">
+            <a:avLst/>
+          </a:prstGeom>
+          <a:noFill/>
+          <a:ln/>
+        </p:spPr>
+        <p:txBody>
+          <a:bodyPr wrap="square" lIns="0" tIns="0" rIns="0" bIns="0" rtlCol="0" anchor="ctr"/>
+          <a:lstStyle/>
+          <a:p>
+            <a:pPr algn="l" indent="0" marL="0">
+              <a:buNone/>
+            </a:pPr>
+            <a:r>
+              <a:rPr lang="en-US" sz="760" dirty="0">
+                <a:solidFill>
+                  <a:srgbClr val="000000"/>
+                </a:solidFill>
+                <a:latin typeface="Arial" pitchFamily="34" charset="0"/>
+                <a:ea typeface="Arial" pitchFamily="34" charset="-122"/>
+                <a:cs typeface="Arial" pitchFamily="34" charset="-120"/>
+              </a:rPr>
+              <a:t>Ground for withdrawal</a:t>
+            </a:r>
+            <a:endParaRPr lang="en-US" sz="760" dirty="0"/>
+          </a:p>
+        </p:txBody>
+      </p:sp>
+      <p:sp>
+        <p:nvSpPr>
+          <p:cNvPr id="102" name="Text 82"/>
+          <p:cNvSpPr/>
+          <p:nvPr/>
+        </p:nvSpPr>
+        <p:spPr>
+          <a:xfrm>
+            <a:off x="3739896" y="8988552"/>
+            <a:ext cx="164592" cy="182880"/>
+          </a:xfrm>
+          <a:prstGeom prst="rect">
+            <a:avLst/>
+          </a:prstGeom>
+          <a:noFill/>
+          <a:ln/>
+        </p:spPr>
+        <p:txBody>
+          <a:bodyPr wrap="square" lIns="0" tIns="0" rIns="0" bIns="0" rtlCol="0" anchor="ctr"/>
+          <a:lstStyle/>
+          <a:p>
+            <a:pPr algn="l" indent="0" marL="0">
+              <a:buNone/>
+            </a:pPr>
+            <a:r>
+              <a:rPr lang="en-US" sz="850" b="1" dirty="0">
+                <a:solidFill>
+                  <a:srgbClr val="C62026"/>
+                </a:solidFill>
+                <a:latin typeface="Arial" pitchFamily="34" charset="0"/>
+                <a:ea typeface="Arial" pitchFamily="34" charset="-122"/>
+                <a:cs typeface="Arial" pitchFamily="34" charset="-120"/>
+              </a:rPr>
+              <a:t>✓</a:t>
+            </a:r>
+            <a:endParaRPr lang="en-US" sz="850" dirty="0"/>
+          </a:p>
+        </p:txBody>
+      </p:sp>
+      <p:sp>
+        <p:nvSpPr>
+          <p:cNvPr id="103" name="Text 83"/>
+          <p:cNvSpPr/>
+          <p:nvPr/>
+        </p:nvSpPr>
+        <p:spPr>
+          <a:xfrm>
+            <a:off x="3941064" y="8988552"/>
+            <a:ext cx="3054096" cy="182880"/>
+          </a:xfrm>
+          <a:prstGeom prst="rect">
+            <a:avLst/>
+          </a:prstGeom>
+          <a:noFill/>
+          <a:ln/>
+        </p:spPr>
+        <p:txBody>
+          <a:bodyPr wrap="square" lIns="0" tIns="0" rIns="0" bIns="0" rtlCol="0" anchor="ctr"/>
+          <a:lstStyle/>
+          <a:p>
+            <a:pPr algn="l" indent="0" marL="0">
+              <a:buNone/>
+            </a:pPr>
+            <a:r>
+              <a:rPr lang="en-US" sz="760" dirty="0">
+                <a:solidFill>
+                  <a:srgbClr val="000000"/>
+                </a:solidFill>
+                <a:latin typeface="Arial" pitchFamily="34" charset="0"/>
+                <a:ea typeface="Arial" pitchFamily="34" charset="-122"/>
+                <a:cs typeface="Arial" pitchFamily="34" charset="-120"/>
+              </a:rPr>
+              <a:t>Supporting evidence</a:t>
+            </a:r>
+            <a:endParaRPr lang="en-US" sz="760" dirty="0"/>
+          </a:p>
+        </p:txBody>
+      </p:sp>
+      <p:sp>
+        <p:nvSpPr>
+          <p:cNvPr id="104" name="Text 84"/>
+          <p:cNvSpPr/>
+          <p:nvPr/>
+        </p:nvSpPr>
+        <p:spPr>
+          <a:xfrm>
+            <a:off x="3739896" y="9180576"/>
+            <a:ext cx="164592" cy="182880"/>
+          </a:xfrm>
+          <a:prstGeom prst="rect">
+            <a:avLst/>
+          </a:prstGeom>
+          <a:noFill/>
+          <a:ln/>
+        </p:spPr>
+        <p:txBody>
+          <a:bodyPr wrap="square" lIns="0" tIns="0" rIns="0" bIns="0" rtlCol="0" anchor="ctr"/>
+          <a:lstStyle/>
+          <a:p>
+            <a:pPr algn="l" indent="0" marL="0">
+              <a:buNone/>
+            </a:pPr>
+            <a:r>
+              <a:rPr lang="en-US" sz="850" b="1" dirty="0">
+                <a:solidFill>
+                  <a:srgbClr val="C62026"/>
+                </a:solidFill>
+                <a:latin typeface="Arial" pitchFamily="34" charset="0"/>
+                <a:ea typeface="Arial" pitchFamily="34" charset="-122"/>
+                <a:cs typeface="Arial" pitchFamily="34" charset="-120"/>
+              </a:rPr>
+              <a:t>✓</a:t>
+            </a:r>
+            <a:endParaRPr lang="en-US" sz="850" dirty="0"/>
+          </a:p>
+        </p:txBody>
+      </p:sp>
+      <p:sp>
+        <p:nvSpPr>
+          <p:cNvPr id="105" name="Text 85"/>
+          <p:cNvSpPr/>
+          <p:nvPr/>
+        </p:nvSpPr>
+        <p:spPr>
+          <a:xfrm>
+            <a:off x="3941064" y="9180576"/>
+            <a:ext cx="3054096" cy="182880"/>
+          </a:xfrm>
+          <a:prstGeom prst="rect">
+            <a:avLst/>
+          </a:prstGeom>
+          <a:noFill/>
+          <a:ln/>
+        </p:spPr>
+        <p:txBody>
+          <a:bodyPr wrap="square" lIns="0" tIns="0" rIns="0" bIns="0" rtlCol="0" anchor="ctr"/>
+          <a:lstStyle/>
+          <a:p>
+            <a:pPr algn="l" indent="0" marL="0">
+              <a:buNone/>
+            </a:pPr>
+            <a:r>
+              <a:rPr lang="en-US" sz="760" dirty="0">
+                <a:solidFill>
+                  <a:srgbClr val="000000"/>
+                </a:solidFill>
+                <a:latin typeface="Arial" pitchFamily="34" charset="0"/>
+                <a:ea typeface="Arial" pitchFamily="34" charset="-122"/>
+                <a:cs typeface="Arial" pitchFamily="34" charset="-120"/>
+              </a:rPr>
+              <a:t>Coaching or adjustments attempted</a:t>
+            </a:r>
+            <a:endParaRPr lang="en-US" sz="760" dirty="0"/>
+          </a:p>
+        </p:txBody>
+      </p:sp>
+      <p:sp>
+        <p:nvSpPr>
           <p:cNvPr id="106" name="Text 86"/>
           <p:cNvSpPr/>
           <p:nvPr/>
         </p:nvSpPr>
         <p:spPr>
           <a:xfrm>
-            <a:off x="3721608" y="8787384"/>
+            <a:off x="3739896" y="9372600"/>
             <a:ext cx="164592" cy="182880"/>
           </a:xfrm>
           <a:prstGeom prst="rect">
@@ -4159,7 +4145,7 @@
               <a:buNone/>
             </a:pPr>
             <a:r>
-              <a:rPr lang="en-US" sz="800" b="1" dirty="0">
+              <a:rPr lang="en-US" sz="850" b="1" dirty="0">
                 <a:solidFill>
                   <a:srgbClr val="C62026"/>
                 </a:solidFill>
@@ -4169,7 +4155,7 @@
               </a:rPr>
               <a:t>✓</a:t>
             </a:r>
-            <a:endParaRPr lang="en-US" sz="800" dirty="0"/>
+            <a:endParaRPr lang="en-US" sz="850" dirty="0"/>
           </a:p>
         </p:txBody>
       </p:sp>
@@ -4181,8 +4167,8 @@
         </p:nvSpPr>
         <p:spPr>
           <a:xfrm>
-            <a:off x="3904488" y="8787384"/>
-            <a:ext cx="3090672" cy="182880"/>
+            <a:off x="3941064" y="9372600"/>
+            <a:ext cx="3054096" cy="182880"/>
           </a:xfrm>
           <a:prstGeom prst="rect">
             <a:avLst/>
@@ -4198,7 +4184,7 @@
               <a:buNone/>
             </a:pPr>
             <a:r>
-              <a:rPr lang="en-US" sz="670" dirty="0">
+              <a:rPr lang="en-US" sz="760" dirty="0">
                 <a:solidFill>
                   <a:srgbClr val="000000"/>
                 </a:solidFill>
@@ -4206,9 +4192,9 @@
                 <a:ea typeface="Arial" pitchFamily="34" charset="-122"/>
                 <a:cs typeface="Arial" pitchFamily="34" charset="-120"/>
               </a:rPr>
-              <a:t>Ground for withdrawal and relevant requirement or objective</a:t>
-            </a:r>
-            <a:endParaRPr lang="en-US" sz="670" dirty="0"/>
+              <a:t>Why the threshold was met</a:t>
+            </a:r>
+            <a:endParaRPr lang="en-US" sz="760" dirty="0"/>
           </a:p>
         </p:txBody>
       </p:sp>
@@ -4220,7 +4206,7 @@
         </p:nvSpPr>
         <p:spPr>
           <a:xfrm>
-            <a:off x="3721608" y="8993124"/>
+            <a:off x="3739896" y="9564624"/>
             <a:ext cx="164592" cy="182880"/>
           </a:xfrm>
           <a:prstGeom prst="rect">
@@ -4237,7 +4223,7 @@
               <a:buNone/>
             </a:pPr>
             <a:r>
-              <a:rPr lang="en-US" sz="800" b="1" dirty="0">
+              <a:rPr lang="en-US" sz="850" b="1" dirty="0">
                 <a:solidFill>
                   <a:srgbClr val="C62026"/>
                 </a:solidFill>
@@ -4247,7 +4233,7 @@
               </a:rPr>
               <a:t>✓</a:t>
             </a:r>
-            <a:endParaRPr lang="en-US" sz="800" dirty="0"/>
+            <a:endParaRPr lang="en-US" sz="850" dirty="0"/>
           </a:p>
         </p:txBody>
       </p:sp>
@@ -4259,8 +4245,8 @@
         </p:nvSpPr>
         <p:spPr>
           <a:xfrm>
-            <a:off x="3904488" y="8993124"/>
-            <a:ext cx="3090672" cy="182880"/>
+            <a:off x="3941064" y="9564624"/>
+            <a:ext cx="3054096" cy="182880"/>
           </a:xfrm>
           <a:prstGeom prst="rect">
             <a:avLst/>
@@ -4276,7 +4262,7 @@
               <a:buNone/>
             </a:pPr>
             <a:r>
-              <a:rPr lang="en-US" sz="670" dirty="0">
+              <a:rPr lang="en-US" sz="760" dirty="0">
                 <a:solidFill>
                   <a:srgbClr val="000000"/>
                 </a:solidFill>
@@ -4284,9 +4270,9 @@
                 <a:ea typeface="Arial" pitchFamily="34" charset="-122"/>
                 <a:cs typeface="Arial" pitchFamily="34" charset="-120"/>
               </a:rPr>
-              <a:t>Observed evidence and any medical restriction</a:t>
-            </a:r>
-            <a:endParaRPr lang="en-US" sz="670" dirty="0"/>
+              <a:t>Recommending and approving authority</a:t>
+            </a:r>
+            <a:endParaRPr lang="en-US" sz="760" dirty="0"/>
           </a:p>
         </p:txBody>
       </p:sp>
@@ -4298,7 +4284,7 @@
         </p:nvSpPr>
         <p:spPr>
           <a:xfrm>
-            <a:off x="3721608" y="9198864"/>
+            <a:off x="3739896" y="9756648"/>
             <a:ext cx="164592" cy="182880"/>
           </a:xfrm>
           <a:prstGeom prst="rect">
@@ -4315,7 +4301,7 @@
               <a:buNone/>
             </a:pPr>
             <a:r>
-              <a:rPr lang="en-US" sz="800" b="1" dirty="0">
+              <a:rPr lang="en-US" sz="850" b="1" dirty="0">
                 <a:solidFill>
                   <a:srgbClr val="C62026"/>
                 </a:solidFill>
@@ -4325,7 +4311,7 @@
               </a:rPr>
               <a:t>✓</a:t>
             </a:r>
-            <a:endParaRPr lang="en-US" sz="800" dirty="0"/>
+            <a:endParaRPr lang="en-US" sz="850" dirty="0"/>
           </a:p>
         </p:txBody>
       </p:sp>
@@ -4337,8 +4323,8 @@
         </p:nvSpPr>
         <p:spPr>
           <a:xfrm>
-            <a:off x="3904488" y="9198864"/>
-            <a:ext cx="3090672" cy="182880"/>
+            <a:off x="3941064" y="9756648"/>
+            <a:ext cx="3054096" cy="182880"/>
           </a:xfrm>
           <a:prstGeom prst="rect">
             <a:avLst/>
@@ -4354,7 +4340,7 @@
               <a:buNone/>
             </a:pPr>
             <a:r>
-              <a:rPr lang="en-US" sz="670" dirty="0">
+              <a:rPr lang="en-US" sz="760" dirty="0">
                 <a:solidFill>
                   <a:srgbClr val="000000"/>
                 </a:solidFill>
@@ -4362,243 +4348,9 @@
                 <a:ea typeface="Arial" pitchFamily="34" charset="-122"/>
                 <a:cs typeface="Arial" pitchFamily="34" charset="-120"/>
               </a:rPr>
-              <a:t>Coaching, adaptations or authorised adjustments attempted</a:t>
-            </a:r>
-            <a:endParaRPr lang="en-US" sz="670" dirty="0"/>
-          </a:p>
-        </p:txBody>
-      </p:sp>
-      <p:sp>
-        <p:nvSpPr>
-          <p:cNvPr id="112" name="Text 92"/>
-          <p:cNvSpPr/>
-          <p:nvPr/>
-        </p:nvSpPr>
-        <p:spPr>
-          <a:xfrm>
-            <a:off x="3721608" y="9404604"/>
-            <a:ext cx="164592" cy="182880"/>
-          </a:xfrm>
-          <a:prstGeom prst="rect">
-            <a:avLst/>
-          </a:prstGeom>
-          <a:noFill/>
-          <a:ln/>
-        </p:spPr>
-        <p:txBody>
-          <a:bodyPr wrap="square" lIns="0" tIns="0" rIns="0" bIns="0" rtlCol="0" anchor="ctr"/>
-          <a:lstStyle/>
-          <a:p>
-            <a:pPr algn="l" indent="0" marL="0">
-              <a:buNone/>
-            </a:pPr>
-            <a:r>
-              <a:rPr lang="en-US" sz="800" b="1" dirty="0">
-                <a:solidFill>
-                  <a:srgbClr val="C62026"/>
-                </a:solidFill>
-                <a:latin typeface="Arial" pitchFamily="34" charset="0"/>
-                <a:ea typeface="Arial" pitchFamily="34" charset="-122"/>
-                <a:cs typeface="Arial" pitchFamily="34" charset="-120"/>
-              </a:rPr>
-              <a:t>✓</a:t>
-            </a:r>
-            <a:endParaRPr lang="en-US" sz="800" dirty="0"/>
-          </a:p>
-        </p:txBody>
-      </p:sp>
-      <p:sp>
-        <p:nvSpPr>
-          <p:cNvPr id="113" name="Text 93"/>
-          <p:cNvSpPr/>
-          <p:nvPr/>
-        </p:nvSpPr>
-        <p:spPr>
-          <a:xfrm>
-            <a:off x="3904488" y="9404604"/>
-            <a:ext cx="3090672" cy="182880"/>
-          </a:xfrm>
-          <a:prstGeom prst="rect">
-            <a:avLst/>
-          </a:prstGeom>
-          <a:noFill/>
-          <a:ln/>
-        </p:spPr>
-        <p:txBody>
-          <a:bodyPr wrap="square" lIns="0" tIns="0" rIns="0" bIns="0" rtlCol="0" anchor="ctr"/>
-          <a:lstStyle/>
-          <a:p>
-            <a:pPr algn="l" indent="0" marL="0">
-              <a:buNone/>
-            </a:pPr>
-            <a:r>
-              <a:rPr lang="en-US" sz="670" dirty="0">
-                <a:solidFill>
-                  <a:srgbClr val="000000"/>
-                </a:solidFill>
-                <a:latin typeface="Arial" pitchFamily="34" charset="0"/>
-                <a:ea typeface="Arial" pitchFamily="34" charset="-122"/>
-                <a:cs typeface="Arial" pitchFamily="34" charset="-120"/>
-              </a:rPr>
-              <a:t>Why the issue exceeded normal developmental friction</a:t>
-            </a:r>
-            <a:endParaRPr lang="en-US" sz="670" dirty="0"/>
-          </a:p>
-        </p:txBody>
-      </p:sp>
-      <p:sp>
-        <p:nvSpPr>
-          <p:cNvPr id="114" name="Text 94"/>
-          <p:cNvSpPr/>
-          <p:nvPr/>
-        </p:nvSpPr>
-        <p:spPr>
-          <a:xfrm>
-            <a:off x="3721608" y="9610344"/>
-            <a:ext cx="164592" cy="182880"/>
-          </a:xfrm>
-          <a:prstGeom prst="rect">
-            <a:avLst/>
-          </a:prstGeom>
-          <a:noFill/>
-          <a:ln/>
-        </p:spPr>
-        <p:txBody>
-          <a:bodyPr wrap="square" lIns="0" tIns="0" rIns="0" bIns="0" rtlCol="0" anchor="ctr"/>
-          <a:lstStyle/>
-          <a:p>
-            <a:pPr algn="l" indent="0" marL="0">
-              <a:buNone/>
-            </a:pPr>
-            <a:r>
-              <a:rPr lang="en-US" sz="800" b="1" dirty="0">
-                <a:solidFill>
-                  <a:srgbClr val="C62026"/>
-                </a:solidFill>
-                <a:latin typeface="Arial" pitchFamily="34" charset="0"/>
-                <a:ea typeface="Arial" pitchFamily="34" charset="-122"/>
-                <a:cs typeface="Arial" pitchFamily="34" charset="-120"/>
-              </a:rPr>
-              <a:t>✓</a:t>
-            </a:r>
-            <a:endParaRPr lang="en-US" sz="800" dirty="0"/>
-          </a:p>
-        </p:txBody>
-      </p:sp>
-      <p:sp>
-        <p:nvSpPr>
-          <p:cNvPr id="115" name="Text 95"/>
-          <p:cNvSpPr/>
-          <p:nvPr/>
-        </p:nvSpPr>
-        <p:spPr>
-          <a:xfrm>
-            <a:off x="3904488" y="9610344"/>
-            <a:ext cx="3090672" cy="182880"/>
-          </a:xfrm>
-          <a:prstGeom prst="rect">
-            <a:avLst/>
-          </a:prstGeom>
-          <a:noFill/>
-          <a:ln/>
-        </p:spPr>
-        <p:txBody>
-          <a:bodyPr wrap="square" lIns="0" tIns="0" rIns="0" bIns="0" rtlCol="0" anchor="ctr"/>
-          <a:lstStyle/>
-          <a:p>
-            <a:pPr algn="l" indent="0" marL="0">
-              <a:buNone/>
-            </a:pPr>
-            <a:r>
-              <a:rPr lang="en-US" sz="670" dirty="0">
-                <a:solidFill>
-                  <a:srgbClr val="000000"/>
-                </a:solidFill>
-                <a:latin typeface="Arial" pitchFamily="34" charset="0"/>
-                <a:ea typeface="Arial" pitchFamily="34" charset="-122"/>
-                <a:cs typeface="Arial" pitchFamily="34" charset="-120"/>
-              </a:rPr>
-              <a:t>Who recommended and who confirmed the withdrawal</a:t>
-            </a:r>
-            <a:endParaRPr lang="en-US" sz="670" dirty="0"/>
-          </a:p>
-        </p:txBody>
-      </p:sp>
-      <p:sp>
-        <p:nvSpPr>
-          <p:cNvPr id="116" name="Text 96"/>
-          <p:cNvSpPr/>
-          <p:nvPr/>
-        </p:nvSpPr>
-        <p:spPr>
-          <a:xfrm>
-            <a:off x="3721608" y="9816084"/>
-            <a:ext cx="164592" cy="182880"/>
-          </a:xfrm>
-          <a:prstGeom prst="rect">
-            <a:avLst/>
-          </a:prstGeom>
-          <a:noFill/>
-          <a:ln/>
-        </p:spPr>
-        <p:txBody>
-          <a:bodyPr wrap="square" lIns="0" tIns="0" rIns="0" bIns="0" rtlCol="0" anchor="ctr"/>
-          <a:lstStyle/>
-          <a:p>
-            <a:pPr algn="l" indent="0" marL="0">
-              <a:buNone/>
-            </a:pPr>
-            <a:r>
-              <a:rPr lang="en-US" sz="800" b="1" dirty="0">
-                <a:solidFill>
-                  <a:srgbClr val="C62026"/>
-                </a:solidFill>
-                <a:latin typeface="Arial" pitchFamily="34" charset="0"/>
-                <a:ea typeface="Arial" pitchFamily="34" charset="-122"/>
-                <a:cs typeface="Arial" pitchFamily="34" charset="-120"/>
-              </a:rPr>
-              <a:t>✓</a:t>
-            </a:r>
-            <a:endParaRPr lang="en-US" sz="800" dirty="0"/>
-          </a:p>
-        </p:txBody>
-      </p:sp>
-      <p:sp>
-        <p:nvSpPr>
-          <p:cNvPr id="117" name="Text 97"/>
-          <p:cNvSpPr/>
-          <p:nvPr/>
-        </p:nvSpPr>
-        <p:spPr>
-          <a:xfrm>
-            <a:off x="3904488" y="9816084"/>
-            <a:ext cx="3090672" cy="182880"/>
-          </a:xfrm>
-          <a:prstGeom prst="rect">
-            <a:avLst/>
-          </a:prstGeom>
-          <a:noFill/>
-          <a:ln/>
-        </p:spPr>
-        <p:txBody>
-          <a:bodyPr wrap="square" lIns="0" tIns="0" rIns="0" bIns="0" rtlCol="0" anchor="ctr"/>
-          <a:lstStyle/>
-          <a:p>
-            <a:pPr algn="l" indent="0" marL="0">
-              <a:buNone/>
-            </a:pPr>
-            <a:r>
-              <a:rPr lang="en-US" sz="670" dirty="0">
-                <a:solidFill>
-                  <a:srgbClr val="000000"/>
-                </a:solidFill>
-                <a:latin typeface="Arial" pitchFamily="34" charset="0"/>
-                <a:ea typeface="Arial" pitchFamily="34" charset="-122"/>
-                <a:cs typeface="Arial" pitchFamily="34" charset="-120"/>
-              </a:rPr>
-              <a:t>Effect on assessment and continued course participation</a:t>
-            </a:r>
-            <a:endParaRPr lang="en-US" sz="670" dirty="0"/>
+              <a:t>Assessment/course outcome</a:t>
+            </a:r>
+            <a:endParaRPr lang="en-US" sz="760" dirty="0"/>
           </a:p>
         </p:txBody>
       </p:sp>

</xml_diff>

<commit_message>
Purpose sections lead with the Adventure Race's own purpose
Both the SOP and the visual now open with "The purpose of the
Adventure Race is to expose participants and teams to physical,
mental and interpersonal pressure within a race environment" before
the SOP's process purpose.

Co-Authored-By: Claude Fable 5 <noreply@anthropic.com>
Claude-Session: https://claude.ai/code/session_01YLo1WfwUDkbwfJEF3ZNVbB
</commit_message>
<xml_diff>
--- a/output/withdrawal-sop-visual.pptx
+++ b/output/withdrawal-sop-visual.pptx
@@ -1111,7 +1111,7 @@
         <p:spPr>
           <a:xfrm>
             <a:off x="841248" y="1280160"/>
-            <a:ext cx="3730752" cy="329184"/>
+            <a:ext cx="3730752" cy="548640"/>
           </a:xfrm>
           <a:prstGeom prst="rect">
             <a:avLst/>
@@ -1135,7 +1135,7 @@
                 <a:ea typeface="Arial" pitchFamily="34" charset="-122"/>
                 <a:cs typeface="Arial" pitchFamily="34" charset="-120"/>
               </a:rPr>
-              <a:t>Provide a fair, consistent and defensible process for participant withdrawal.</a:t>
+              <a:t>The purpose of the Adventure Race is to expose participants and teams to physical, mental and interpersonal pressure within a race environment. This SOP provides a fair, consistent and defensible process for participant withdrawal.</a:t>
             </a:r>
             <a:endParaRPr lang="en-US" sz="860" dirty="0"/>
           </a:p>
@@ -1149,7 +1149,7 @@
         </p:nvSpPr>
         <p:spPr>
           <a:xfrm>
-            <a:off x="457200" y="1755648"/>
+            <a:off x="457200" y="1883664"/>
             <a:ext cx="4160520" cy="274320"/>
           </a:xfrm>
           <a:prstGeom prst="rect">
@@ -1169,7 +1169,7 @@
         </p:nvSpPr>
         <p:spPr>
           <a:xfrm>
-            <a:off x="457200" y="1755648"/>
+            <a:off x="457200" y="1883664"/>
             <a:ext cx="4160520" cy="274320"/>
           </a:xfrm>
           <a:prstGeom prst="rect">
@@ -1208,8 +1208,8 @@
         </p:nvSpPr>
         <p:spPr>
           <a:xfrm>
-            <a:off x="457200" y="2029968"/>
-            <a:ext cx="4160520" cy="1828800"/>
+            <a:off x="457200" y="2157984"/>
+            <a:ext cx="4160520" cy="1700784"/>
           </a:xfrm>
           <a:prstGeom prst="rect">
             <a:avLst/>
@@ -1230,7 +1230,7 @@
         </p:nvSpPr>
         <p:spPr>
           <a:xfrm>
-            <a:off x="603504" y="2139696"/>
+            <a:off x="603504" y="2267712"/>
             <a:ext cx="3867912" cy="603504"/>
           </a:xfrm>
           <a:prstGeom prst="rect">
@@ -1269,7 +1269,7 @@
         </p:nvSpPr>
         <p:spPr>
           <a:xfrm>
-            <a:off x="903732" y="2788920"/>
+            <a:off x="903732" y="2889504"/>
             <a:ext cx="493776" cy="493776"/>
           </a:xfrm>
           <a:prstGeom prst="ellipse">
@@ -1302,7 +1302,7 @@
         </p:blipFill>
         <p:spPr>
           <a:xfrm>
-            <a:off x="1018032" y="2903220"/>
+            <a:off x="1018032" y="3003804"/>
             <a:ext cx="265176" cy="265176"/>
           </a:xfrm>
           <a:prstGeom prst="rect">
@@ -1318,8 +1318,8 @@
         </p:nvSpPr>
         <p:spPr>
           <a:xfrm>
-            <a:off x="502920" y="3328416"/>
-            <a:ext cx="1295400" cy="457200"/>
+            <a:off x="502920" y="3419856"/>
+            <a:ext cx="1295400" cy="402336"/>
           </a:xfrm>
           <a:prstGeom prst="rect">
             <a:avLst/>
@@ -1357,7 +1357,7 @@
         </p:nvSpPr>
         <p:spPr>
           <a:xfrm>
-            <a:off x="1615440" y="3035808"/>
+            <a:off x="1615440" y="3136392"/>
             <a:ext cx="457200" cy="0"/>
           </a:xfrm>
           <a:prstGeom prst="line">
@@ -1380,7 +1380,7 @@
         </p:nvSpPr>
         <p:spPr>
           <a:xfrm>
-            <a:off x="2290572" y="2788920"/>
+            <a:off x="2290572" y="2889504"/>
             <a:ext cx="493776" cy="493776"/>
           </a:xfrm>
           <a:prstGeom prst="ellipse">
@@ -1413,7 +1413,7 @@
         </p:blipFill>
         <p:spPr>
           <a:xfrm>
-            <a:off x="2404872" y="2903220"/>
+            <a:off x="2404872" y="3003804"/>
             <a:ext cx="265176" cy="265176"/>
           </a:xfrm>
           <a:prstGeom prst="rect">
@@ -1429,8 +1429,8 @@
         </p:nvSpPr>
         <p:spPr>
           <a:xfrm>
-            <a:off x="1889760" y="3328416"/>
-            <a:ext cx="1295400" cy="457200"/>
+            <a:off x="1889760" y="3419856"/>
+            <a:ext cx="1295400" cy="402336"/>
           </a:xfrm>
           <a:prstGeom prst="rect">
             <a:avLst/>
@@ -1468,7 +1468,7 @@
         </p:nvSpPr>
         <p:spPr>
           <a:xfrm>
-            <a:off x="3002280" y="3035808"/>
+            <a:off x="3002280" y="3136392"/>
             <a:ext cx="457200" cy="0"/>
           </a:xfrm>
           <a:prstGeom prst="line">
@@ -1491,7 +1491,7 @@
         </p:nvSpPr>
         <p:spPr>
           <a:xfrm>
-            <a:off x="3677412" y="2788920"/>
+            <a:off x="3677412" y="2889504"/>
             <a:ext cx="493776" cy="493776"/>
           </a:xfrm>
           <a:prstGeom prst="ellipse">
@@ -1524,7 +1524,7 @@
         </p:blipFill>
         <p:spPr>
           <a:xfrm>
-            <a:off x="3791712" y="2903220"/>
+            <a:off x="3791712" y="3003804"/>
             <a:ext cx="265176" cy="265176"/>
           </a:xfrm>
           <a:prstGeom prst="rect">
@@ -1540,8 +1540,8 @@
         </p:nvSpPr>
         <p:spPr>
           <a:xfrm>
-            <a:off x="3276600" y="3328416"/>
-            <a:ext cx="1295400" cy="457200"/>
+            <a:off x="3276600" y="3419856"/>
+            <a:ext cx="1295400" cy="402336"/>
           </a:xfrm>
           <a:prstGeom prst="rect">
             <a:avLst/>

</xml_diff>